<commit_message>
Add cycle-time improvements from notes to Meritage deck
Improvements slide now includes (kept existing bullets):
- Eliminate connector screw swaps & reorientation (~1:40 labor recovered)
- Pre-drill connector holes for screw entry (~4 min/frame, seat-frame bottleneck)
- Connectors pre-drilled 100% for leg pieces + mini-connectors
- Receive leg pieces pre-assembled (~90% built identically; move upstream)

Co-Authored-By: Claude Fable 5 <noreply@anthropic.com>
Claude-Session: https://claude.ai/code/session_019MdxDfxB8wg2Ht2aZSuwqK
</commit_message>
<xml_diff>
--- a/standard-work/standalone/Meritage_3Seater_Standard_Work.pptx
+++ b/standard-work/standalone/Meritage_3Seater_Standard_Work.pptx
@@ -4462,7 +4462,29 @@
             </a:r>
           </a:p>
           <a:p>
+            <a:pPr/>
+            <a:r>
+              <a:t>Eliminate connector screw swaps &amp; reorientation — recovers ~1:40 of labor per unit to redeploy elsewhere</a:t>
+            </a:r>
             <a:endParaRPr lang="en-US"/>
+          </a:p>
+          <a:p>
+            <a:pPr/>
+            <a:r>
+              <a:t>Pre-drill connector holes for screw entry — saves ~4 min per frame assembly (seat-frame assembly is a top bottleneck)</a:t>
+            </a:r>
+          </a:p>
+          <a:p>
+            <a:pPr/>
+            <a:r>
+              <a:t>Connectors pre-drilled 100% for leg pieces, and pre-drill mini-connectors where possible — improves every Meritage</a:t>
+            </a:r>
+          </a:p>
+          <a:p>
+            <a:pPr/>
+            <a:r>
+              <a:t>Receive leg pieces pre-assembled from manufacturing — ~90% are built identically, so move that work upstream</a:t>
+            </a:r>
           </a:p>
         </p:txBody>
       </p:sp>

</xml_diff>

<commit_message>
Add Operator Loading Chart by Task slide to Meritage deck
- Native yamazumi: 6 stations stacked by task vs the 42-min takt line, all
  stations under takt; step-number labels + task legend (#2-#12)
- Caption: takt 42, cycle 41.5, ~10/day, 88% efficiency; notes Arms built
  2-up and Seat/Back Frame split
- Inserted before Improvements using the template's content layout

Co-Authored-By: Claude Fable 5 <noreply@anthropic.com>
Claude-Session: https://claude.ai/code/session_019MdxDfxB8wg2Ht2aZSuwqK
</commit_message>
<xml_diff>
--- a/standard-work/standalone/Meritage_3Seater_Standard_Work.pptx
+++ b/standard-work/standalone/Meritage_3Seater_Standard_Work.pptx
@@ -8,6 +8,7 @@
     <p:sldId id="309" r:id="rId2"/>
     <p:sldId id="311" r:id="rId3"/>
     <p:sldId id="312" r:id="rId4"/>
+    <p:sldId id="314" r:id="rId11"/>
     <p:sldId id="313" r:id="rId5"/>
   </p:sldIdLst>
   <p:sldSz cx="12192000" cy="6858000"/>
@@ -4502,6 +4503,2957 @@
 </p:sld>
 </file>
 
+<file path=ppt/slides/slide5.xml><?xml version="1.0" encoding="utf-8"?>
+<p:sld xmlns:a="http://schemas.openxmlformats.org/drawingml/2006/main" xmlns:p="http://schemas.openxmlformats.org/presentationml/2006/main" xmlns:r="http://schemas.openxmlformats.org/officeDocument/2006/relationships">
+  <p:cSld>
+    <p:spTree>
+      <p:nvGrpSpPr>
+        <p:cNvPr id="1" name=""/>
+        <p:cNvGrpSpPr/>
+        <p:nvPr/>
+      </p:nvGrpSpPr>
+      <p:grpSpPr/>
+      <p:sp>
+        <p:nvSpPr>
+          <p:cNvPr id="2" name="Title 1"/>
+          <p:cNvSpPr>
+            <a:spLocks noGrp="1"/>
+          </p:cNvSpPr>
+          <p:nvPr>
+            <p:ph type="title"/>
+          </p:nvPr>
+        </p:nvSpPr>
+        <p:spPr/>
+        <p:txBody>
+          <a:bodyPr/>
+          <a:lstStyle/>
+          <a:p>
+            <a:r>
+              <a:t>Operator Loading Chart by Task</a:t>
+            </a:r>
+          </a:p>
+        </p:txBody>
+      </p:sp>
+      <p:cxnSp>
+        <p:nvCxnSpPr>
+          <p:cNvPr id="3" name="Connector 2"/>
+          <p:cNvCxnSpPr/>
+          <p:nvPr/>
+        </p:nvCxnSpPr>
+        <p:spPr>
+          <a:xfrm>
+            <a:off x="1435608" y="5349240"/>
+            <a:ext cx="6446519" cy="0"/>
+          </a:xfrm>
+          <a:prstGeom prst="line">
+            <a:avLst/>
+          </a:prstGeom>
+          <a:ln w="9525">
+            <a:solidFill>
+              <a:srgbClr val="D9D9D9"/>
+            </a:solidFill>
+          </a:ln>
+          <a:effectLst/>
+        </p:spPr>
+        <p:style>
+          <a:lnRef idx="2">
+            <a:schemeClr val="accent1"/>
+          </a:lnRef>
+          <a:fillRef idx="0">
+            <a:schemeClr val="accent1"/>
+          </a:fillRef>
+          <a:effectRef idx="1">
+            <a:schemeClr val="accent1"/>
+          </a:effectRef>
+          <a:fontRef idx="minor">
+            <a:schemeClr val="tx1"/>
+          </a:fontRef>
+        </p:style>
+      </p:cxnSp>
+      <p:sp>
+        <p:nvSpPr>
+          <p:cNvPr id="4" name="TextBox 3"/>
+          <p:cNvSpPr txBox="1"/>
+          <p:nvPr/>
+        </p:nvSpPr>
+        <p:spPr>
+          <a:xfrm>
+            <a:off x="978408" y="5248655"/>
+            <a:ext cx="411480" cy="201168"/>
+          </a:xfrm>
+          <a:prstGeom prst="rect">
+            <a:avLst/>
+          </a:prstGeom>
+          <a:noFill/>
+        </p:spPr>
+        <p:txBody>
+          <a:bodyPr wrap="square" lIns="0" rIns="0" tIns="0" bIns="0">
+            <a:spAutoFit/>
+          </a:bodyPr>
+          <a:lstStyle/>
+          <a:p>
+            <a:pPr algn="r"/>
+            <a:r>
+              <a:rPr sz="900" b="0">
+                <a:solidFill>
+                  <a:srgbClr val="808080"/>
+                </a:solidFill>
+                <a:latin typeface="Calibri"/>
+              </a:rPr>
+              <a:t>0</a:t>
+            </a:r>
+          </a:p>
+        </p:txBody>
+      </p:sp>
+      <p:cxnSp>
+        <p:nvCxnSpPr>
+          <p:cNvPr id="5" name="Connector 4"/>
+          <p:cNvCxnSpPr/>
+          <p:nvPr/>
+        </p:nvCxnSpPr>
+        <p:spPr>
+          <a:xfrm>
+            <a:off x="1435608" y="4457700"/>
+            <a:ext cx="6446519" cy="0"/>
+          </a:xfrm>
+          <a:prstGeom prst="line">
+            <a:avLst/>
+          </a:prstGeom>
+          <a:ln w="9525">
+            <a:solidFill>
+              <a:srgbClr val="D9D9D9"/>
+            </a:solidFill>
+          </a:ln>
+          <a:effectLst/>
+        </p:spPr>
+        <p:style>
+          <a:lnRef idx="2">
+            <a:schemeClr val="accent1"/>
+          </a:lnRef>
+          <a:fillRef idx="0">
+            <a:schemeClr val="accent1"/>
+          </a:fillRef>
+          <a:effectRef idx="1">
+            <a:schemeClr val="accent1"/>
+          </a:effectRef>
+          <a:fontRef idx="minor">
+            <a:schemeClr val="tx1"/>
+          </a:fontRef>
+        </p:style>
+      </p:cxnSp>
+      <p:sp>
+        <p:nvSpPr>
+          <p:cNvPr id="6" name="TextBox 5"/>
+          <p:cNvSpPr txBox="1"/>
+          <p:nvPr/>
+        </p:nvSpPr>
+        <p:spPr>
+          <a:xfrm>
+            <a:off x="978408" y="4357116"/>
+            <a:ext cx="411480" cy="201168"/>
+          </a:xfrm>
+          <a:prstGeom prst="rect">
+            <a:avLst/>
+          </a:prstGeom>
+          <a:noFill/>
+        </p:spPr>
+        <p:txBody>
+          <a:bodyPr wrap="square" lIns="0" rIns="0" tIns="0" bIns="0">
+            <a:spAutoFit/>
+          </a:bodyPr>
+          <a:lstStyle/>
+          <a:p>
+            <a:pPr algn="r"/>
+            <a:r>
+              <a:rPr sz="900" b="0">
+                <a:solidFill>
+                  <a:srgbClr val="808080"/>
+                </a:solidFill>
+                <a:latin typeface="Calibri"/>
+              </a:rPr>
+              <a:t>12</a:t>
+            </a:r>
+          </a:p>
+        </p:txBody>
+      </p:sp>
+      <p:cxnSp>
+        <p:nvCxnSpPr>
+          <p:cNvPr id="7" name="Connector 6"/>
+          <p:cNvCxnSpPr/>
+          <p:nvPr/>
+        </p:nvCxnSpPr>
+        <p:spPr>
+          <a:xfrm>
+            <a:off x="1435608" y="3566160"/>
+            <a:ext cx="6446519" cy="0"/>
+          </a:xfrm>
+          <a:prstGeom prst="line">
+            <a:avLst/>
+          </a:prstGeom>
+          <a:ln w="9525">
+            <a:solidFill>
+              <a:srgbClr val="D9D9D9"/>
+            </a:solidFill>
+          </a:ln>
+          <a:effectLst/>
+        </p:spPr>
+        <p:style>
+          <a:lnRef idx="2">
+            <a:schemeClr val="accent1"/>
+          </a:lnRef>
+          <a:fillRef idx="0">
+            <a:schemeClr val="accent1"/>
+          </a:fillRef>
+          <a:effectRef idx="1">
+            <a:schemeClr val="accent1"/>
+          </a:effectRef>
+          <a:fontRef idx="minor">
+            <a:schemeClr val="tx1"/>
+          </a:fontRef>
+        </p:style>
+      </p:cxnSp>
+      <p:sp>
+        <p:nvSpPr>
+          <p:cNvPr id="8" name="TextBox 7"/>
+          <p:cNvSpPr txBox="1"/>
+          <p:nvPr/>
+        </p:nvSpPr>
+        <p:spPr>
+          <a:xfrm>
+            <a:off x="978408" y="3465576"/>
+            <a:ext cx="411480" cy="201168"/>
+          </a:xfrm>
+          <a:prstGeom prst="rect">
+            <a:avLst/>
+          </a:prstGeom>
+          <a:noFill/>
+        </p:spPr>
+        <p:txBody>
+          <a:bodyPr wrap="square" lIns="0" rIns="0" tIns="0" bIns="0">
+            <a:spAutoFit/>
+          </a:bodyPr>
+          <a:lstStyle/>
+          <a:p>
+            <a:pPr algn="r"/>
+            <a:r>
+              <a:rPr sz="900" b="0">
+                <a:solidFill>
+                  <a:srgbClr val="808080"/>
+                </a:solidFill>
+                <a:latin typeface="Calibri"/>
+              </a:rPr>
+              <a:t>24</a:t>
+            </a:r>
+          </a:p>
+        </p:txBody>
+      </p:sp>
+      <p:cxnSp>
+        <p:nvCxnSpPr>
+          <p:cNvPr id="9" name="Connector 8"/>
+          <p:cNvCxnSpPr/>
+          <p:nvPr/>
+        </p:nvCxnSpPr>
+        <p:spPr>
+          <a:xfrm>
+            <a:off x="1435608" y="2674620"/>
+            <a:ext cx="6446519" cy="0"/>
+          </a:xfrm>
+          <a:prstGeom prst="line">
+            <a:avLst/>
+          </a:prstGeom>
+          <a:ln w="9525">
+            <a:solidFill>
+              <a:srgbClr val="D9D9D9"/>
+            </a:solidFill>
+          </a:ln>
+          <a:effectLst/>
+        </p:spPr>
+        <p:style>
+          <a:lnRef idx="2">
+            <a:schemeClr val="accent1"/>
+          </a:lnRef>
+          <a:fillRef idx="0">
+            <a:schemeClr val="accent1"/>
+          </a:fillRef>
+          <a:effectRef idx="1">
+            <a:schemeClr val="accent1"/>
+          </a:effectRef>
+          <a:fontRef idx="minor">
+            <a:schemeClr val="tx1"/>
+          </a:fontRef>
+        </p:style>
+      </p:cxnSp>
+      <p:sp>
+        <p:nvSpPr>
+          <p:cNvPr id="10" name="TextBox 9"/>
+          <p:cNvSpPr txBox="1"/>
+          <p:nvPr/>
+        </p:nvSpPr>
+        <p:spPr>
+          <a:xfrm>
+            <a:off x="978408" y="2574036"/>
+            <a:ext cx="411480" cy="201168"/>
+          </a:xfrm>
+          <a:prstGeom prst="rect">
+            <a:avLst/>
+          </a:prstGeom>
+          <a:noFill/>
+        </p:spPr>
+        <p:txBody>
+          <a:bodyPr wrap="square" lIns="0" rIns="0" tIns="0" bIns="0">
+            <a:spAutoFit/>
+          </a:bodyPr>
+          <a:lstStyle/>
+          <a:p>
+            <a:pPr algn="r"/>
+            <a:r>
+              <a:rPr sz="900" b="0">
+                <a:solidFill>
+                  <a:srgbClr val="808080"/>
+                </a:solidFill>
+                <a:latin typeface="Calibri"/>
+              </a:rPr>
+              <a:t>36</a:t>
+            </a:r>
+          </a:p>
+        </p:txBody>
+      </p:sp>
+      <p:cxnSp>
+        <p:nvCxnSpPr>
+          <p:cNvPr id="11" name="Connector 10"/>
+          <p:cNvCxnSpPr/>
+          <p:nvPr/>
+        </p:nvCxnSpPr>
+        <p:spPr>
+          <a:xfrm>
+            <a:off x="1435608" y="1783080"/>
+            <a:ext cx="6446519" cy="0"/>
+          </a:xfrm>
+          <a:prstGeom prst="line">
+            <a:avLst/>
+          </a:prstGeom>
+          <a:ln w="9525">
+            <a:solidFill>
+              <a:srgbClr val="D9D9D9"/>
+            </a:solidFill>
+          </a:ln>
+          <a:effectLst/>
+        </p:spPr>
+        <p:style>
+          <a:lnRef idx="2">
+            <a:schemeClr val="accent1"/>
+          </a:lnRef>
+          <a:fillRef idx="0">
+            <a:schemeClr val="accent1"/>
+          </a:fillRef>
+          <a:effectRef idx="1">
+            <a:schemeClr val="accent1"/>
+          </a:effectRef>
+          <a:fontRef idx="minor">
+            <a:schemeClr val="tx1"/>
+          </a:fontRef>
+        </p:style>
+      </p:cxnSp>
+      <p:sp>
+        <p:nvSpPr>
+          <p:cNvPr id="12" name="TextBox 11"/>
+          <p:cNvSpPr txBox="1"/>
+          <p:nvPr/>
+        </p:nvSpPr>
+        <p:spPr>
+          <a:xfrm>
+            <a:off x="978408" y="1682496"/>
+            <a:ext cx="411480" cy="201168"/>
+          </a:xfrm>
+          <a:prstGeom prst="rect">
+            <a:avLst/>
+          </a:prstGeom>
+          <a:noFill/>
+        </p:spPr>
+        <p:txBody>
+          <a:bodyPr wrap="square" lIns="0" rIns="0" tIns="0" bIns="0">
+            <a:spAutoFit/>
+          </a:bodyPr>
+          <a:lstStyle/>
+          <a:p>
+            <a:pPr algn="r"/>
+            <a:r>
+              <a:rPr sz="900" b="0">
+                <a:solidFill>
+                  <a:srgbClr val="808080"/>
+                </a:solidFill>
+                <a:latin typeface="Calibri"/>
+              </a:rPr>
+              <a:t>48</a:t>
+            </a:r>
+          </a:p>
+        </p:txBody>
+      </p:sp>
+      <p:sp>
+        <p:nvSpPr>
+          <p:cNvPr id="13" name="Rectangle 12"/>
+          <p:cNvSpPr/>
+          <p:nvPr/>
+        </p:nvSpPr>
+        <p:spPr>
+          <a:xfrm>
+            <a:off x="1650492" y="3919061"/>
+            <a:ext cx="644652" cy="1430178"/>
+          </a:xfrm>
+          <a:prstGeom prst="rect">
+            <a:avLst/>
+          </a:prstGeom>
+          <a:solidFill>
+            <a:srgbClr val="4472C4"/>
+          </a:solidFill>
+          <a:ln w="6350">
+            <a:solidFill>
+              <a:srgbClr val="FFFFFF"/>
+            </a:solidFill>
+          </a:ln>
+          <a:effectLst/>
+        </p:spPr>
+        <p:style>
+          <a:lnRef idx="1">
+            <a:schemeClr val="accent1"/>
+          </a:lnRef>
+          <a:fillRef idx="3">
+            <a:schemeClr val="accent1"/>
+          </a:fillRef>
+          <a:effectRef idx="2">
+            <a:schemeClr val="accent1"/>
+          </a:effectRef>
+          <a:fontRef idx="minor">
+            <a:schemeClr val="lt1"/>
+          </a:fontRef>
+        </p:style>
+        <p:txBody>
+          <a:bodyPr rtlCol="0" anchor="ctr"/>
+          <a:lstStyle/>
+          <a:p>
+            <a:pPr algn="ctr"/>
+          </a:p>
+        </p:txBody>
+      </p:sp>
+      <p:sp>
+        <p:nvSpPr>
+          <p:cNvPr id="14" name="TextBox 13"/>
+          <p:cNvSpPr txBox="1"/>
+          <p:nvPr/>
+        </p:nvSpPr>
+        <p:spPr>
+          <a:xfrm>
+            <a:off x="1650492" y="4524422"/>
+            <a:ext cx="644652" cy="219456"/>
+          </a:xfrm>
+          <a:prstGeom prst="rect">
+            <a:avLst/>
+          </a:prstGeom>
+          <a:noFill/>
+        </p:spPr>
+        <p:txBody>
+          <a:bodyPr wrap="square" lIns="0" rIns="0" tIns="0" bIns="0">
+            <a:spAutoFit/>
+          </a:bodyPr>
+          <a:lstStyle/>
+          <a:p>
+            <a:pPr algn="ctr"/>
+            <a:r>
+              <a:rPr sz="900" b="1">
+                <a:solidFill>
+                  <a:srgbClr val="FFFFFF"/>
+                </a:solidFill>
+                <a:latin typeface="Calibri"/>
+              </a:rPr>
+              <a:t>2</a:t>
+            </a:r>
+          </a:p>
+        </p:txBody>
+      </p:sp>
+      <p:sp>
+        <p:nvSpPr>
+          <p:cNvPr id="15" name="Rectangle 14"/>
+          <p:cNvSpPr/>
+          <p:nvPr/>
+        </p:nvSpPr>
+        <p:spPr>
+          <a:xfrm>
+            <a:off x="1650492" y="3324701"/>
+            <a:ext cx="644652" cy="594359"/>
+          </a:xfrm>
+          <a:prstGeom prst="rect">
+            <a:avLst/>
+          </a:prstGeom>
+          <a:solidFill>
+            <a:srgbClr val="70AD47"/>
+          </a:solidFill>
+          <a:ln w="6350">
+            <a:solidFill>
+              <a:srgbClr val="FFFFFF"/>
+            </a:solidFill>
+          </a:ln>
+          <a:effectLst/>
+        </p:spPr>
+        <p:style>
+          <a:lnRef idx="1">
+            <a:schemeClr val="accent1"/>
+          </a:lnRef>
+          <a:fillRef idx="3">
+            <a:schemeClr val="accent1"/>
+          </a:fillRef>
+          <a:effectRef idx="2">
+            <a:schemeClr val="accent1"/>
+          </a:effectRef>
+          <a:fontRef idx="minor">
+            <a:schemeClr val="lt1"/>
+          </a:fontRef>
+        </p:style>
+        <p:txBody>
+          <a:bodyPr rtlCol="0" anchor="ctr"/>
+          <a:lstStyle/>
+          <a:p>
+            <a:pPr algn="ctr"/>
+          </a:p>
+        </p:txBody>
+      </p:sp>
+      <p:sp>
+        <p:nvSpPr>
+          <p:cNvPr id="16" name="TextBox 15"/>
+          <p:cNvSpPr txBox="1"/>
+          <p:nvPr/>
+        </p:nvSpPr>
+        <p:spPr>
+          <a:xfrm>
+            <a:off x="1650492" y="3512153"/>
+            <a:ext cx="644652" cy="219456"/>
+          </a:xfrm>
+          <a:prstGeom prst="rect">
+            <a:avLst/>
+          </a:prstGeom>
+          <a:noFill/>
+        </p:spPr>
+        <p:txBody>
+          <a:bodyPr wrap="square" lIns="0" rIns="0" tIns="0" bIns="0">
+            <a:spAutoFit/>
+          </a:bodyPr>
+          <a:lstStyle/>
+          <a:p>
+            <a:pPr algn="ctr"/>
+            <a:r>
+              <a:rPr sz="900" b="1">
+                <a:solidFill>
+                  <a:srgbClr val="FFFFFF"/>
+                </a:solidFill>
+                <a:latin typeface="Calibri"/>
+              </a:rPr>
+              <a:t>3</a:t>
+            </a:r>
+          </a:p>
+        </p:txBody>
+      </p:sp>
+      <p:sp>
+        <p:nvSpPr>
+          <p:cNvPr id="17" name="TextBox 16"/>
+          <p:cNvSpPr txBox="1"/>
+          <p:nvPr/>
+        </p:nvSpPr>
+        <p:spPr>
+          <a:xfrm>
+            <a:off x="1376172" y="3086957"/>
+            <a:ext cx="1193292" cy="201168"/>
+          </a:xfrm>
+          <a:prstGeom prst="rect">
+            <a:avLst/>
+          </a:prstGeom>
+          <a:noFill/>
+        </p:spPr>
+        <p:txBody>
+          <a:bodyPr wrap="square" lIns="0" rIns="0" tIns="0" bIns="0">
+            <a:spAutoFit/>
+          </a:bodyPr>
+          <a:lstStyle/>
+          <a:p>
+            <a:pPr algn="ctr"/>
+            <a:r>
+              <a:rPr sz="1000" b="1">
+                <a:solidFill>
+                  <a:srgbClr val="1F3864"/>
+                </a:solidFill>
+                <a:latin typeface="Calibri"/>
+              </a:rPr>
+              <a:t>27.2</a:t>
+            </a:r>
+          </a:p>
+        </p:txBody>
+      </p:sp>
+      <p:sp>
+        <p:nvSpPr>
+          <p:cNvPr id="18" name="TextBox 17"/>
+          <p:cNvSpPr txBox="1"/>
+          <p:nvPr/>
+        </p:nvSpPr>
+        <p:spPr>
+          <a:xfrm>
+            <a:off x="1376172" y="5404103"/>
+            <a:ext cx="1193292" cy="201168"/>
+          </a:xfrm>
+          <a:prstGeom prst="rect">
+            <a:avLst/>
+          </a:prstGeom>
+          <a:noFill/>
+        </p:spPr>
+        <p:txBody>
+          <a:bodyPr wrap="square" lIns="0" rIns="0" tIns="0" bIns="0">
+            <a:spAutoFit/>
+          </a:bodyPr>
+          <a:lstStyle/>
+          <a:p>
+            <a:pPr algn="ctr"/>
+            <a:r>
+              <a:rPr sz="1000" b="1">
+                <a:solidFill>
+                  <a:srgbClr val="404040"/>
+                </a:solidFill>
+                <a:latin typeface="Calibri"/>
+              </a:rPr>
+              <a:t>S1</a:t>
+            </a:r>
+          </a:p>
+        </p:txBody>
+      </p:sp>
+      <p:sp>
+        <p:nvSpPr>
+          <p:cNvPr id="19" name="Rectangle 18"/>
+          <p:cNvSpPr/>
+          <p:nvPr/>
+        </p:nvSpPr>
+        <p:spPr>
+          <a:xfrm>
+            <a:off x="2724912" y="2971800"/>
+            <a:ext cx="644652" cy="2377439"/>
+          </a:xfrm>
+          <a:prstGeom prst="rect">
+            <a:avLst/>
+          </a:prstGeom>
+          <a:solidFill>
+            <a:srgbClr val="1F3864"/>
+          </a:solidFill>
+          <a:ln w="6350">
+            <a:solidFill>
+              <a:srgbClr val="FFFFFF"/>
+            </a:solidFill>
+          </a:ln>
+          <a:effectLst/>
+        </p:spPr>
+        <p:style>
+          <a:lnRef idx="1">
+            <a:schemeClr val="accent1"/>
+          </a:lnRef>
+          <a:fillRef idx="3">
+            <a:schemeClr val="accent1"/>
+          </a:fillRef>
+          <a:effectRef idx="2">
+            <a:schemeClr val="accent1"/>
+          </a:effectRef>
+          <a:fontRef idx="minor">
+            <a:schemeClr val="lt1"/>
+          </a:fontRef>
+        </p:style>
+        <p:txBody>
+          <a:bodyPr rtlCol="0" anchor="ctr"/>
+          <a:lstStyle/>
+          <a:p>
+            <a:pPr algn="ctr"/>
+          </a:p>
+        </p:txBody>
+      </p:sp>
+      <p:sp>
+        <p:nvSpPr>
+          <p:cNvPr id="20" name="TextBox 19"/>
+          <p:cNvSpPr txBox="1"/>
+          <p:nvPr/>
+        </p:nvSpPr>
+        <p:spPr>
+          <a:xfrm>
+            <a:off x="2724912" y="4050791"/>
+            <a:ext cx="644652" cy="219456"/>
+          </a:xfrm>
+          <a:prstGeom prst="rect">
+            <a:avLst/>
+          </a:prstGeom>
+          <a:noFill/>
+        </p:spPr>
+        <p:txBody>
+          <a:bodyPr wrap="square" lIns="0" rIns="0" tIns="0" bIns="0">
+            <a:spAutoFit/>
+          </a:bodyPr>
+          <a:lstStyle/>
+          <a:p>
+            <a:pPr algn="ctr"/>
+            <a:r>
+              <a:rPr sz="900" b="1">
+                <a:solidFill>
+                  <a:srgbClr val="FFFFFF"/>
+                </a:solidFill>
+                <a:latin typeface="Calibri"/>
+              </a:rPr>
+              <a:t>4</a:t>
+            </a:r>
+          </a:p>
+        </p:txBody>
+      </p:sp>
+      <p:sp>
+        <p:nvSpPr>
+          <p:cNvPr id="21" name="TextBox 20"/>
+          <p:cNvSpPr txBox="1"/>
+          <p:nvPr/>
+        </p:nvSpPr>
+        <p:spPr>
+          <a:xfrm>
+            <a:off x="2450592" y="2734056"/>
+            <a:ext cx="1193292" cy="201168"/>
+          </a:xfrm>
+          <a:prstGeom prst="rect">
+            <a:avLst/>
+          </a:prstGeom>
+          <a:noFill/>
+        </p:spPr>
+        <p:txBody>
+          <a:bodyPr wrap="square" lIns="0" rIns="0" tIns="0" bIns="0">
+            <a:spAutoFit/>
+          </a:bodyPr>
+          <a:lstStyle/>
+          <a:p>
+            <a:pPr algn="ctr"/>
+            <a:r>
+              <a:rPr sz="1000" b="1">
+                <a:solidFill>
+                  <a:srgbClr val="1F3864"/>
+                </a:solidFill>
+                <a:latin typeface="Calibri"/>
+              </a:rPr>
+              <a:t>32</a:t>
+            </a:r>
+          </a:p>
+        </p:txBody>
+      </p:sp>
+      <p:sp>
+        <p:nvSpPr>
+          <p:cNvPr id="22" name="TextBox 21"/>
+          <p:cNvSpPr txBox="1"/>
+          <p:nvPr/>
+        </p:nvSpPr>
+        <p:spPr>
+          <a:xfrm>
+            <a:off x="2450592" y="5404103"/>
+            <a:ext cx="1193292" cy="201168"/>
+          </a:xfrm>
+          <a:prstGeom prst="rect">
+            <a:avLst/>
+          </a:prstGeom>
+          <a:noFill/>
+        </p:spPr>
+        <p:txBody>
+          <a:bodyPr wrap="square" lIns="0" rIns="0" tIns="0" bIns="0">
+            <a:spAutoFit/>
+          </a:bodyPr>
+          <a:lstStyle/>
+          <a:p>
+            <a:pPr algn="ctr"/>
+            <a:r>
+              <a:rPr sz="1000" b="1">
+                <a:solidFill>
+                  <a:srgbClr val="404040"/>
+                </a:solidFill>
+                <a:latin typeface="Calibri"/>
+              </a:rPr>
+              <a:t>S2  x2</a:t>
+            </a:r>
+          </a:p>
+        </p:txBody>
+      </p:sp>
+      <p:sp>
+        <p:nvSpPr>
+          <p:cNvPr id="23" name="Rectangle 22"/>
+          <p:cNvSpPr/>
+          <p:nvPr/>
+        </p:nvSpPr>
+        <p:spPr>
+          <a:xfrm>
+            <a:off x="3799332" y="2303145"/>
+            <a:ext cx="644652" cy="3046094"/>
+          </a:xfrm>
+          <a:prstGeom prst="rect">
+            <a:avLst/>
+          </a:prstGeom>
+          <a:solidFill>
+            <a:srgbClr val="5B9BD5"/>
+          </a:solidFill>
+          <a:ln w="6350">
+            <a:solidFill>
+              <a:srgbClr val="FFFFFF"/>
+            </a:solidFill>
+          </a:ln>
+          <a:effectLst/>
+        </p:spPr>
+        <p:style>
+          <a:lnRef idx="1">
+            <a:schemeClr val="accent1"/>
+          </a:lnRef>
+          <a:fillRef idx="3">
+            <a:schemeClr val="accent1"/>
+          </a:fillRef>
+          <a:effectRef idx="2">
+            <a:schemeClr val="accent1"/>
+          </a:effectRef>
+          <a:fontRef idx="minor">
+            <a:schemeClr val="lt1"/>
+          </a:fontRef>
+        </p:style>
+        <p:txBody>
+          <a:bodyPr rtlCol="0" anchor="ctr"/>
+          <a:lstStyle/>
+          <a:p>
+            <a:pPr algn="ctr"/>
+          </a:p>
+        </p:txBody>
+      </p:sp>
+      <p:sp>
+        <p:nvSpPr>
+          <p:cNvPr id="24" name="TextBox 23"/>
+          <p:cNvSpPr txBox="1"/>
+          <p:nvPr/>
+        </p:nvSpPr>
+        <p:spPr>
+          <a:xfrm>
+            <a:off x="3799332" y="3716464"/>
+            <a:ext cx="644652" cy="219456"/>
+          </a:xfrm>
+          <a:prstGeom prst="rect">
+            <a:avLst/>
+          </a:prstGeom>
+          <a:noFill/>
+        </p:spPr>
+        <p:txBody>
+          <a:bodyPr wrap="square" lIns="0" rIns="0" tIns="0" bIns="0">
+            <a:spAutoFit/>
+          </a:bodyPr>
+          <a:lstStyle/>
+          <a:p>
+            <a:pPr algn="ctr"/>
+            <a:r>
+              <a:rPr sz="900" b="1">
+                <a:solidFill>
+                  <a:srgbClr val="FFFFFF"/>
+                </a:solidFill>
+                <a:latin typeface="Calibri"/>
+              </a:rPr>
+              <a:t>5a</a:t>
+            </a:r>
+          </a:p>
+        </p:txBody>
+      </p:sp>
+      <p:sp>
+        <p:nvSpPr>
+          <p:cNvPr id="25" name="TextBox 24"/>
+          <p:cNvSpPr txBox="1"/>
+          <p:nvPr/>
+        </p:nvSpPr>
+        <p:spPr>
+          <a:xfrm>
+            <a:off x="3525012" y="2065401"/>
+            <a:ext cx="1193292" cy="201168"/>
+          </a:xfrm>
+          <a:prstGeom prst="rect">
+            <a:avLst/>
+          </a:prstGeom>
+          <a:noFill/>
+        </p:spPr>
+        <p:txBody>
+          <a:bodyPr wrap="square" lIns="0" rIns="0" tIns="0" bIns="0">
+            <a:spAutoFit/>
+          </a:bodyPr>
+          <a:lstStyle/>
+          <a:p>
+            <a:pPr algn="ctr"/>
+            <a:r>
+              <a:rPr sz="1000" b="1">
+                <a:solidFill>
+                  <a:srgbClr val="1F3864"/>
+                </a:solidFill>
+                <a:latin typeface="Calibri"/>
+              </a:rPr>
+              <a:t>41</a:t>
+            </a:r>
+          </a:p>
+        </p:txBody>
+      </p:sp>
+      <p:sp>
+        <p:nvSpPr>
+          <p:cNvPr id="26" name="TextBox 25"/>
+          <p:cNvSpPr txBox="1"/>
+          <p:nvPr/>
+        </p:nvSpPr>
+        <p:spPr>
+          <a:xfrm>
+            <a:off x="3525012" y="5404103"/>
+            <a:ext cx="1193292" cy="201168"/>
+          </a:xfrm>
+          <a:prstGeom prst="rect">
+            <a:avLst/>
+          </a:prstGeom>
+          <a:noFill/>
+        </p:spPr>
+        <p:txBody>
+          <a:bodyPr wrap="square" lIns="0" rIns="0" tIns="0" bIns="0">
+            <a:spAutoFit/>
+          </a:bodyPr>
+          <a:lstStyle/>
+          <a:p>
+            <a:pPr algn="ctr"/>
+            <a:r>
+              <a:rPr sz="1000" b="1">
+                <a:solidFill>
+                  <a:srgbClr val="404040"/>
+                </a:solidFill>
+                <a:latin typeface="Calibri"/>
+              </a:rPr>
+              <a:t>S3</a:t>
+            </a:r>
+          </a:p>
+        </p:txBody>
+      </p:sp>
+      <p:sp>
+        <p:nvSpPr>
+          <p:cNvPr id="27" name="Rectangle 26"/>
+          <p:cNvSpPr/>
+          <p:nvPr/>
+        </p:nvSpPr>
+        <p:spPr>
+          <a:xfrm>
+            <a:off x="4873752" y="4903470"/>
+            <a:ext cx="644652" cy="445769"/>
+          </a:xfrm>
+          <a:prstGeom prst="rect">
+            <a:avLst/>
+          </a:prstGeom>
+          <a:solidFill>
+            <a:srgbClr val="5B9BD5"/>
+          </a:solidFill>
+          <a:ln w="6350">
+            <a:solidFill>
+              <a:srgbClr val="FFFFFF"/>
+            </a:solidFill>
+          </a:ln>
+          <a:effectLst/>
+        </p:spPr>
+        <p:style>
+          <a:lnRef idx="1">
+            <a:schemeClr val="accent1"/>
+          </a:lnRef>
+          <a:fillRef idx="3">
+            <a:schemeClr val="accent1"/>
+          </a:fillRef>
+          <a:effectRef idx="2">
+            <a:schemeClr val="accent1"/>
+          </a:effectRef>
+          <a:fontRef idx="minor">
+            <a:schemeClr val="lt1"/>
+          </a:fontRef>
+        </p:style>
+        <p:txBody>
+          <a:bodyPr rtlCol="0" anchor="ctr"/>
+          <a:lstStyle/>
+          <a:p>
+            <a:pPr algn="ctr"/>
+          </a:p>
+        </p:txBody>
+      </p:sp>
+      <p:sp>
+        <p:nvSpPr>
+          <p:cNvPr id="28" name="TextBox 27"/>
+          <p:cNvSpPr txBox="1"/>
+          <p:nvPr/>
+        </p:nvSpPr>
+        <p:spPr>
+          <a:xfrm>
+            <a:off x="4873752" y="5016627"/>
+            <a:ext cx="644652" cy="219456"/>
+          </a:xfrm>
+          <a:prstGeom prst="rect">
+            <a:avLst/>
+          </a:prstGeom>
+          <a:noFill/>
+        </p:spPr>
+        <p:txBody>
+          <a:bodyPr wrap="square" lIns="0" rIns="0" tIns="0" bIns="0">
+            <a:spAutoFit/>
+          </a:bodyPr>
+          <a:lstStyle/>
+          <a:p>
+            <a:pPr algn="ctr"/>
+            <a:r>
+              <a:rPr sz="900" b="1">
+                <a:solidFill>
+                  <a:srgbClr val="FFFFFF"/>
+                </a:solidFill>
+                <a:latin typeface="Calibri"/>
+              </a:rPr>
+              <a:t>5b</a:t>
+            </a:r>
+          </a:p>
+        </p:txBody>
+      </p:sp>
+      <p:sp>
+        <p:nvSpPr>
+          <p:cNvPr id="29" name="Rectangle 28"/>
+          <p:cNvSpPr/>
+          <p:nvPr/>
+        </p:nvSpPr>
+        <p:spPr>
+          <a:xfrm>
+            <a:off x="4873752" y="2414587"/>
+            <a:ext cx="644652" cy="2488882"/>
+          </a:xfrm>
+          <a:prstGeom prst="rect">
+            <a:avLst/>
+          </a:prstGeom>
+          <a:solidFill>
+            <a:srgbClr val="ED7D31"/>
+          </a:solidFill>
+          <a:ln w="6350">
+            <a:solidFill>
+              <a:srgbClr val="FFFFFF"/>
+            </a:solidFill>
+          </a:ln>
+          <a:effectLst/>
+        </p:spPr>
+        <p:style>
+          <a:lnRef idx="1">
+            <a:schemeClr val="accent1"/>
+          </a:lnRef>
+          <a:fillRef idx="3">
+            <a:schemeClr val="accent1"/>
+          </a:fillRef>
+          <a:effectRef idx="2">
+            <a:schemeClr val="accent1"/>
+          </a:effectRef>
+          <a:fontRef idx="minor">
+            <a:schemeClr val="lt1"/>
+          </a:fontRef>
+        </p:style>
+        <p:txBody>
+          <a:bodyPr rtlCol="0" anchor="ctr"/>
+          <a:lstStyle/>
+          <a:p>
+            <a:pPr algn="ctr"/>
+          </a:p>
+        </p:txBody>
+      </p:sp>
+      <p:sp>
+        <p:nvSpPr>
+          <p:cNvPr id="30" name="TextBox 29"/>
+          <p:cNvSpPr txBox="1"/>
+          <p:nvPr/>
+        </p:nvSpPr>
+        <p:spPr>
+          <a:xfrm>
+            <a:off x="4873752" y="3549300"/>
+            <a:ext cx="644652" cy="219456"/>
+          </a:xfrm>
+          <a:prstGeom prst="rect">
+            <a:avLst/>
+          </a:prstGeom>
+          <a:noFill/>
+        </p:spPr>
+        <p:txBody>
+          <a:bodyPr wrap="square" lIns="0" rIns="0" tIns="0" bIns="0">
+            <a:spAutoFit/>
+          </a:bodyPr>
+          <a:lstStyle/>
+          <a:p>
+            <a:pPr algn="ctr"/>
+            <a:r>
+              <a:rPr sz="900" b="1">
+                <a:solidFill>
+                  <a:srgbClr val="FFFFFF"/>
+                </a:solidFill>
+                <a:latin typeface="Calibri"/>
+              </a:rPr>
+              <a:t>6a</a:t>
+            </a:r>
+          </a:p>
+        </p:txBody>
+      </p:sp>
+      <p:sp>
+        <p:nvSpPr>
+          <p:cNvPr id="31" name="TextBox 30"/>
+          <p:cNvSpPr txBox="1"/>
+          <p:nvPr/>
+        </p:nvSpPr>
+        <p:spPr>
+          <a:xfrm>
+            <a:off x="4599432" y="2176843"/>
+            <a:ext cx="1193292" cy="201168"/>
+          </a:xfrm>
+          <a:prstGeom prst="rect">
+            <a:avLst/>
+          </a:prstGeom>
+          <a:noFill/>
+        </p:spPr>
+        <p:txBody>
+          <a:bodyPr wrap="square" lIns="0" rIns="0" tIns="0" bIns="0">
+            <a:spAutoFit/>
+          </a:bodyPr>
+          <a:lstStyle/>
+          <a:p>
+            <a:pPr algn="ctr"/>
+            <a:r>
+              <a:rPr sz="1000" b="1">
+                <a:solidFill>
+                  <a:srgbClr val="1F3864"/>
+                </a:solidFill>
+                <a:latin typeface="Calibri"/>
+              </a:rPr>
+              <a:t>39.5</a:t>
+            </a:r>
+          </a:p>
+        </p:txBody>
+      </p:sp>
+      <p:sp>
+        <p:nvSpPr>
+          <p:cNvPr id="32" name="TextBox 31"/>
+          <p:cNvSpPr txBox="1"/>
+          <p:nvPr/>
+        </p:nvSpPr>
+        <p:spPr>
+          <a:xfrm>
+            <a:off x="4599432" y="5404103"/>
+            <a:ext cx="1193292" cy="201168"/>
+          </a:xfrm>
+          <a:prstGeom prst="rect">
+            <a:avLst/>
+          </a:prstGeom>
+          <a:noFill/>
+        </p:spPr>
+        <p:txBody>
+          <a:bodyPr wrap="square" lIns="0" rIns="0" tIns="0" bIns="0">
+            <a:spAutoFit/>
+          </a:bodyPr>
+          <a:lstStyle/>
+          <a:p>
+            <a:pPr algn="ctr"/>
+            <a:r>
+              <a:rPr sz="1000" b="1">
+                <a:solidFill>
+                  <a:srgbClr val="404040"/>
+                </a:solidFill>
+                <a:latin typeface="Calibri"/>
+              </a:rPr>
+              <a:t>S4</a:t>
+            </a:r>
+          </a:p>
+        </p:txBody>
+      </p:sp>
+      <p:sp>
+        <p:nvSpPr>
+          <p:cNvPr id="33" name="Rectangle 32"/>
+          <p:cNvSpPr/>
+          <p:nvPr/>
+        </p:nvSpPr>
+        <p:spPr>
+          <a:xfrm>
+            <a:off x="5948172" y="4606290"/>
+            <a:ext cx="644652" cy="742949"/>
+          </a:xfrm>
+          <a:prstGeom prst="rect">
+            <a:avLst/>
+          </a:prstGeom>
+          <a:solidFill>
+            <a:srgbClr val="ED7D31"/>
+          </a:solidFill>
+          <a:ln w="6350">
+            <a:solidFill>
+              <a:srgbClr val="FFFFFF"/>
+            </a:solidFill>
+          </a:ln>
+          <a:effectLst/>
+        </p:spPr>
+        <p:style>
+          <a:lnRef idx="1">
+            <a:schemeClr val="accent1"/>
+          </a:lnRef>
+          <a:fillRef idx="3">
+            <a:schemeClr val="accent1"/>
+          </a:fillRef>
+          <a:effectRef idx="2">
+            <a:schemeClr val="accent1"/>
+          </a:effectRef>
+          <a:fontRef idx="minor">
+            <a:schemeClr val="lt1"/>
+          </a:fontRef>
+        </p:style>
+        <p:txBody>
+          <a:bodyPr rtlCol="0" anchor="ctr"/>
+          <a:lstStyle/>
+          <a:p>
+            <a:pPr algn="ctr"/>
+          </a:p>
+        </p:txBody>
+      </p:sp>
+      <p:sp>
+        <p:nvSpPr>
+          <p:cNvPr id="34" name="TextBox 33"/>
+          <p:cNvSpPr txBox="1"/>
+          <p:nvPr/>
+        </p:nvSpPr>
+        <p:spPr>
+          <a:xfrm>
+            <a:off x="5948172" y="4868037"/>
+            <a:ext cx="644652" cy="219456"/>
+          </a:xfrm>
+          <a:prstGeom prst="rect">
+            <a:avLst/>
+          </a:prstGeom>
+          <a:noFill/>
+        </p:spPr>
+        <p:txBody>
+          <a:bodyPr wrap="square" lIns="0" rIns="0" tIns="0" bIns="0">
+            <a:spAutoFit/>
+          </a:bodyPr>
+          <a:lstStyle/>
+          <a:p>
+            <a:pPr algn="ctr"/>
+            <a:r>
+              <a:rPr sz="900" b="1">
+                <a:solidFill>
+                  <a:srgbClr val="FFFFFF"/>
+                </a:solidFill>
+                <a:latin typeface="Calibri"/>
+              </a:rPr>
+              <a:t>6b</a:t>
+            </a:r>
+          </a:p>
+        </p:txBody>
+      </p:sp>
+      <p:sp>
+        <p:nvSpPr>
+          <p:cNvPr id="35" name="Rectangle 34"/>
+          <p:cNvSpPr/>
+          <p:nvPr/>
+        </p:nvSpPr>
+        <p:spPr>
+          <a:xfrm>
+            <a:off x="5948172" y="3268979"/>
+            <a:ext cx="644652" cy="1337310"/>
+          </a:xfrm>
+          <a:prstGeom prst="rect">
+            <a:avLst/>
+          </a:prstGeom>
+          <a:solidFill>
+            <a:srgbClr val="A5A5A5"/>
+          </a:solidFill>
+          <a:ln w="6350">
+            <a:solidFill>
+              <a:srgbClr val="FFFFFF"/>
+            </a:solidFill>
+          </a:ln>
+          <a:effectLst/>
+        </p:spPr>
+        <p:style>
+          <a:lnRef idx="1">
+            <a:schemeClr val="accent1"/>
+          </a:lnRef>
+          <a:fillRef idx="3">
+            <a:schemeClr val="accent1"/>
+          </a:fillRef>
+          <a:effectRef idx="2">
+            <a:schemeClr val="accent1"/>
+          </a:effectRef>
+          <a:fontRef idx="minor">
+            <a:schemeClr val="lt1"/>
+          </a:fontRef>
+        </p:style>
+        <p:txBody>
+          <a:bodyPr rtlCol="0" anchor="ctr"/>
+          <a:lstStyle/>
+          <a:p>
+            <a:pPr algn="ctr"/>
+          </a:p>
+        </p:txBody>
+      </p:sp>
+      <p:sp>
+        <p:nvSpPr>
+          <p:cNvPr id="36" name="TextBox 35"/>
+          <p:cNvSpPr txBox="1"/>
+          <p:nvPr/>
+        </p:nvSpPr>
+        <p:spPr>
+          <a:xfrm>
+            <a:off x="5948172" y="3827906"/>
+            <a:ext cx="644652" cy="219456"/>
+          </a:xfrm>
+          <a:prstGeom prst="rect">
+            <a:avLst/>
+          </a:prstGeom>
+          <a:noFill/>
+        </p:spPr>
+        <p:txBody>
+          <a:bodyPr wrap="square" lIns="0" rIns="0" tIns="0" bIns="0">
+            <a:spAutoFit/>
+          </a:bodyPr>
+          <a:lstStyle/>
+          <a:p>
+            <a:pPr algn="ctr"/>
+            <a:r>
+              <a:rPr sz="900" b="1">
+                <a:solidFill>
+                  <a:srgbClr val="FFFFFF"/>
+                </a:solidFill>
+                <a:latin typeface="Calibri"/>
+              </a:rPr>
+              <a:t>7</a:t>
+            </a:r>
+          </a:p>
+        </p:txBody>
+      </p:sp>
+      <p:sp>
+        <p:nvSpPr>
+          <p:cNvPr id="37" name="Rectangle 36"/>
+          <p:cNvSpPr/>
+          <p:nvPr/>
+        </p:nvSpPr>
+        <p:spPr>
+          <a:xfrm>
+            <a:off x="5948172" y="2897504"/>
+            <a:ext cx="644652" cy="371474"/>
+          </a:xfrm>
+          <a:prstGeom prst="rect">
+            <a:avLst/>
+          </a:prstGeom>
+          <a:solidFill>
+            <a:srgbClr val="997300"/>
+          </a:solidFill>
+          <a:ln w="6350">
+            <a:solidFill>
+              <a:srgbClr val="FFFFFF"/>
+            </a:solidFill>
+          </a:ln>
+          <a:effectLst/>
+        </p:spPr>
+        <p:style>
+          <a:lnRef idx="1">
+            <a:schemeClr val="accent1"/>
+          </a:lnRef>
+          <a:fillRef idx="3">
+            <a:schemeClr val="accent1"/>
+          </a:fillRef>
+          <a:effectRef idx="2">
+            <a:schemeClr val="accent1"/>
+          </a:effectRef>
+          <a:fontRef idx="minor">
+            <a:schemeClr val="lt1"/>
+          </a:fontRef>
+        </p:style>
+        <p:txBody>
+          <a:bodyPr rtlCol="0" anchor="ctr"/>
+          <a:lstStyle/>
+          <a:p>
+            <a:pPr algn="ctr"/>
+          </a:p>
+        </p:txBody>
+      </p:sp>
+      <p:sp>
+        <p:nvSpPr>
+          <p:cNvPr id="38" name="TextBox 37"/>
+          <p:cNvSpPr txBox="1"/>
+          <p:nvPr/>
+        </p:nvSpPr>
+        <p:spPr>
+          <a:xfrm>
+            <a:off x="5948172" y="2973514"/>
+            <a:ext cx="644652" cy="219456"/>
+          </a:xfrm>
+          <a:prstGeom prst="rect">
+            <a:avLst/>
+          </a:prstGeom>
+          <a:noFill/>
+        </p:spPr>
+        <p:txBody>
+          <a:bodyPr wrap="square" lIns="0" rIns="0" tIns="0" bIns="0">
+            <a:spAutoFit/>
+          </a:bodyPr>
+          <a:lstStyle/>
+          <a:p>
+            <a:pPr algn="ctr"/>
+            <a:r>
+              <a:rPr sz="900" b="1">
+                <a:solidFill>
+                  <a:srgbClr val="FFFFFF"/>
+                </a:solidFill>
+                <a:latin typeface="Calibri"/>
+              </a:rPr>
+              <a:t>8</a:t>
+            </a:r>
+          </a:p>
+        </p:txBody>
+      </p:sp>
+      <p:sp>
+        <p:nvSpPr>
+          <p:cNvPr id="39" name="Rectangle 38"/>
+          <p:cNvSpPr/>
+          <p:nvPr/>
+        </p:nvSpPr>
+        <p:spPr>
+          <a:xfrm>
+            <a:off x="5948172" y="2303145"/>
+            <a:ext cx="644652" cy="594359"/>
+          </a:xfrm>
+          <a:prstGeom prst="rect">
+            <a:avLst/>
+          </a:prstGeom>
+          <a:solidFill>
+            <a:srgbClr val="548235"/>
+          </a:solidFill>
+          <a:ln w="6350">
+            <a:solidFill>
+              <a:srgbClr val="FFFFFF"/>
+            </a:solidFill>
+          </a:ln>
+          <a:effectLst/>
+        </p:spPr>
+        <p:style>
+          <a:lnRef idx="1">
+            <a:schemeClr val="accent1"/>
+          </a:lnRef>
+          <a:fillRef idx="3">
+            <a:schemeClr val="accent1"/>
+          </a:fillRef>
+          <a:effectRef idx="2">
+            <a:schemeClr val="accent1"/>
+          </a:effectRef>
+          <a:fontRef idx="minor">
+            <a:schemeClr val="lt1"/>
+          </a:fontRef>
+        </p:style>
+        <p:txBody>
+          <a:bodyPr rtlCol="0" anchor="ctr"/>
+          <a:lstStyle/>
+          <a:p>
+            <a:pPr algn="ctr"/>
+          </a:p>
+        </p:txBody>
+      </p:sp>
+      <p:sp>
+        <p:nvSpPr>
+          <p:cNvPr id="40" name="TextBox 39"/>
+          <p:cNvSpPr txBox="1"/>
+          <p:nvPr/>
+        </p:nvSpPr>
+        <p:spPr>
+          <a:xfrm>
+            <a:off x="5948172" y="2490597"/>
+            <a:ext cx="644652" cy="219456"/>
+          </a:xfrm>
+          <a:prstGeom prst="rect">
+            <a:avLst/>
+          </a:prstGeom>
+          <a:noFill/>
+        </p:spPr>
+        <p:txBody>
+          <a:bodyPr wrap="square" lIns="0" rIns="0" tIns="0" bIns="0">
+            <a:spAutoFit/>
+          </a:bodyPr>
+          <a:lstStyle/>
+          <a:p>
+            <a:pPr algn="ctr"/>
+            <a:r>
+              <a:rPr sz="900" b="1">
+                <a:solidFill>
+                  <a:srgbClr val="FFFFFF"/>
+                </a:solidFill>
+                <a:latin typeface="Calibri"/>
+              </a:rPr>
+              <a:t>9</a:t>
+            </a:r>
+          </a:p>
+        </p:txBody>
+      </p:sp>
+      <p:sp>
+        <p:nvSpPr>
+          <p:cNvPr id="41" name="TextBox 40"/>
+          <p:cNvSpPr txBox="1"/>
+          <p:nvPr/>
+        </p:nvSpPr>
+        <p:spPr>
+          <a:xfrm>
+            <a:off x="5673852" y="2065401"/>
+            <a:ext cx="1193292" cy="201168"/>
+          </a:xfrm>
+          <a:prstGeom prst="rect">
+            <a:avLst/>
+          </a:prstGeom>
+          <a:noFill/>
+        </p:spPr>
+        <p:txBody>
+          <a:bodyPr wrap="square" lIns="0" rIns="0" tIns="0" bIns="0">
+            <a:spAutoFit/>
+          </a:bodyPr>
+          <a:lstStyle/>
+          <a:p>
+            <a:pPr algn="ctr"/>
+            <a:r>
+              <a:rPr sz="1000" b="1">
+                <a:solidFill>
+                  <a:srgbClr val="1F3864"/>
+                </a:solidFill>
+                <a:latin typeface="Calibri"/>
+              </a:rPr>
+              <a:t>41</a:t>
+            </a:r>
+          </a:p>
+        </p:txBody>
+      </p:sp>
+      <p:sp>
+        <p:nvSpPr>
+          <p:cNvPr id="42" name="TextBox 41"/>
+          <p:cNvSpPr txBox="1"/>
+          <p:nvPr/>
+        </p:nvSpPr>
+        <p:spPr>
+          <a:xfrm>
+            <a:off x="5673852" y="5404103"/>
+            <a:ext cx="1193292" cy="201168"/>
+          </a:xfrm>
+          <a:prstGeom prst="rect">
+            <a:avLst/>
+          </a:prstGeom>
+          <a:noFill/>
+        </p:spPr>
+        <p:txBody>
+          <a:bodyPr wrap="square" lIns="0" rIns="0" tIns="0" bIns="0">
+            <a:spAutoFit/>
+          </a:bodyPr>
+          <a:lstStyle/>
+          <a:p>
+            <a:pPr algn="ctr"/>
+            <a:r>
+              <a:rPr sz="1000" b="1">
+                <a:solidFill>
+                  <a:srgbClr val="404040"/>
+                </a:solidFill>
+                <a:latin typeface="Calibri"/>
+              </a:rPr>
+              <a:t>S5</a:t>
+            </a:r>
+          </a:p>
+        </p:txBody>
+      </p:sp>
+      <p:sp>
+        <p:nvSpPr>
+          <p:cNvPr id="43" name="Rectangle 42"/>
+          <p:cNvSpPr/>
+          <p:nvPr/>
+        </p:nvSpPr>
+        <p:spPr>
+          <a:xfrm>
+            <a:off x="7022592" y="3677602"/>
+            <a:ext cx="644652" cy="1671637"/>
+          </a:xfrm>
+          <a:prstGeom prst="rect">
+            <a:avLst/>
+          </a:prstGeom>
+          <a:solidFill>
+            <a:srgbClr val="843C0C"/>
+          </a:solidFill>
+          <a:ln w="6350">
+            <a:solidFill>
+              <a:srgbClr val="FFFFFF"/>
+            </a:solidFill>
+          </a:ln>
+          <a:effectLst/>
+        </p:spPr>
+        <p:style>
+          <a:lnRef idx="1">
+            <a:schemeClr val="accent1"/>
+          </a:lnRef>
+          <a:fillRef idx="3">
+            <a:schemeClr val="accent1"/>
+          </a:fillRef>
+          <a:effectRef idx="2">
+            <a:schemeClr val="accent1"/>
+          </a:effectRef>
+          <a:fontRef idx="minor">
+            <a:schemeClr val="lt1"/>
+          </a:fontRef>
+        </p:style>
+        <p:txBody>
+          <a:bodyPr rtlCol="0" anchor="ctr"/>
+          <a:lstStyle/>
+          <a:p>
+            <a:pPr algn="ctr"/>
+          </a:p>
+        </p:txBody>
+      </p:sp>
+      <p:sp>
+        <p:nvSpPr>
+          <p:cNvPr id="44" name="TextBox 43"/>
+          <p:cNvSpPr txBox="1"/>
+          <p:nvPr/>
+        </p:nvSpPr>
+        <p:spPr>
+          <a:xfrm>
+            <a:off x="7022592" y="4403693"/>
+            <a:ext cx="644652" cy="219456"/>
+          </a:xfrm>
+          <a:prstGeom prst="rect">
+            <a:avLst/>
+          </a:prstGeom>
+          <a:noFill/>
+        </p:spPr>
+        <p:txBody>
+          <a:bodyPr wrap="square" lIns="0" rIns="0" tIns="0" bIns="0">
+            <a:spAutoFit/>
+          </a:bodyPr>
+          <a:lstStyle/>
+          <a:p>
+            <a:pPr algn="ctr"/>
+            <a:r>
+              <a:rPr sz="900" b="1">
+                <a:solidFill>
+                  <a:srgbClr val="FFFFFF"/>
+                </a:solidFill>
+                <a:latin typeface="Calibri"/>
+              </a:rPr>
+              <a:t>10</a:t>
+            </a:r>
+          </a:p>
+        </p:txBody>
+      </p:sp>
+      <p:sp>
+        <p:nvSpPr>
+          <p:cNvPr id="45" name="Rectangle 44"/>
+          <p:cNvSpPr/>
+          <p:nvPr/>
+        </p:nvSpPr>
+        <p:spPr>
+          <a:xfrm>
+            <a:off x="7022592" y="2340292"/>
+            <a:ext cx="644652" cy="1337310"/>
+          </a:xfrm>
+          <a:prstGeom prst="rect">
+            <a:avLst/>
+          </a:prstGeom>
+          <a:solidFill>
+            <a:srgbClr val="7B7B7B"/>
+          </a:solidFill>
+          <a:ln w="6350">
+            <a:solidFill>
+              <a:srgbClr val="FFFFFF"/>
+            </a:solidFill>
+          </a:ln>
+          <a:effectLst/>
+        </p:spPr>
+        <p:style>
+          <a:lnRef idx="1">
+            <a:schemeClr val="accent1"/>
+          </a:lnRef>
+          <a:fillRef idx="3">
+            <a:schemeClr val="accent1"/>
+          </a:fillRef>
+          <a:effectRef idx="2">
+            <a:schemeClr val="accent1"/>
+          </a:effectRef>
+          <a:fontRef idx="minor">
+            <a:schemeClr val="lt1"/>
+          </a:fontRef>
+        </p:style>
+        <p:txBody>
+          <a:bodyPr rtlCol="0" anchor="ctr"/>
+          <a:lstStyle/>
+          <a:p>
+            <a:pPr algn="ctr"/>
+          </a:p>
+        </p:txBody>
+      </p:sp>
+      <p:sp>
+        <p:nvSpPr>
+          <p:cNvPr id="46" name="TextBox 45"/>
+          <p:cNvSpPr txBox="1"/>
+          <p:nvPr/>
+        </p:nvSpPr>
+        <p:spPr>
+          <a:xfrm>
+            <a:off x="7022592" y="2899219"/>
+            <a:ext cx="644652" cy="219456"/>
+          </a:xfrm>
+          <a:prstGeom prst="rect">
+            <a:avLst/>
+          </a:prstGeom>
+          <a:noFill/>
+        </p:spPr>
+        <p:txBody>
+          <a:bodyPr wrap="square" lIns="0" rIns="0" tIns="0" bIns="0">
+            <a:spAutoFit/>
+          </a:bodyPr>
+          <a:lstStyle/>
+          <a:p>
+            <a:pPr algn="ctr"/>
+            <a:r>
+              <a:rPr sz="900" b="1">
+                <a:solidFill>
+                  <a:srgbClr val="FFFFFF"/>
+                </a:solidFill>
+                <a:latin typeface="Calibri"/>
+              </a:rPr>
+              <a:t>11</a:t>
+            </a:r>
+          </a:p>
+        </p:txBody>
+      </p:sp>
+      <p:sp>
+        <p:nvSpPr>
+          <p:cNvPr id="47" name="Rectangle 46"/>
+          <p:cNvSpPr/>
+          <p:nvPr/>
+        </p:nvSpPr>
+        <p:spPr>
+          <a:xfrm>
+            <a:off x="7022592" y="2265997"/>
+            <a:ext cx="644652" cy="74294"/>
+          </a:xfrm>
+          <a:prstGeom prst="rect">
+            <a:avLst/>
+          </a:prstGeom>
+          <a:solidFill>
+            <a:srgbClr val="BF8F00"/>
+          </a:solidFill>
+          <a:ln w="6350">
+            <a:solidFill>
+              <a:srgbClr val="FFFFFF"/>
+            </a:solidFill>
+          </a:ln>
+          <a:effectLst/>
+        </p:spPr>
+        <p:style>
+          <a:lnRef idx="1">
+            <a:schemeClr val="accent1"/>
+          </a:lnRef>
+          <a:fillRef idx="3">
+            <a:schemeClr val="accent1"/>
+          </a:fillRef>
+          <a:effectRef idx="2">
+            <a:schemeClr val="accent1"/>
+          </a:effectRef>
+          <a:fontRef idx="minor">
+            <a:schemeClr val="lt1"/>
+          </a:fontRef>
+        </p:style>
+        <p:txBody>
+          <a:bodyPr rtlCol="0" anchor="ctr"/>
+          <a:lstStyle/>
+          <a:p>
+            <a:pPr algn="ctr"/>
+          </a:p>
+        </p:txBody>
+      </p:sp>
+      <p:sp>
+        <p:nvSpPr>
+          <p:cNvPr id="48" name="TextBox 47"/>
+          <p:cNvSpPr txBox="1"/>
+          <p:nvPr/>
+        </p:nvSpPr>
+        <p:spPr>
+          <a:xfrm>
+            <a:off x="6748272" y="2028253"/>
+            <a:ext cx="1193292" cy="201168"/>
+          </a:xfrm>
+          <a:prstGeom prst="rect">
+            <a:avLst/>
+          </a:prstGeom>
+          <a:noFill/>
+        </p:spPr>
+        <p:txBody>
+          <a:bodyPr wrap="square" lIns="0" rIns="0" tIns="0" bIns="0">
+            <a:spAutoFit/>
+          </a:bodyPr>
+          <a:lstStyle/>
+          <a:p>
+            <a:pPr algn="ctr"/>
+            <a:r>
+              <a:rPr sz="1000" b="1">
+                <a:solidFill>
+                  <a:srgbClr val="1F3864"/>
+                </a:solidFill>
+                <a:latin typeface="Calibri"/>
+              </a:rPr>
+              <a:t>41.5</a:t>
+            </a:r>
+          </a:p>
+        </p:txBody>
+      </p:sp>
+      <p:sp>
+        <p:nvSpPr>
+          <p:cNvPr id="49" name="TextBox 48"/>
+          <p:cNvSpPr txBox="1"/>
+          <p:nvPr/>
+        </p:nvSpPr>
+        <p:spPr>
+          <a:xfrm>
+            <a:off x="6748272" y="5404103"/>
+            <a:ext cx="1193292" cy="201168"/>
+          </a:xfrm>
+          <a:prstGeom prst="rect">
+            <a:avLst/>
+          </a:prstGeom>
+          <a:noFill/>
+        </p:spPr>
+        <p:txBody>
+          <a:bodyPr wrap="square" lIns="0" rIns="0" tIns="0" bIns="0">
+            <a:spAutoFit/>
+          </a:bodyPr>
+          <a:lstStyle/>
+          <a:p>
+            <a:pPr algn="ctr"/>
+            <a:r>
+              <a:rPr sz="1000" b="1">
+                <a:solidFill>
+                  <a:srgbClr val="404040"/>
+                </a:solidFill>
+                <a:latin typeface="Calibri"/>
+              </a:rPr>
+              <a:t>S6</a:t>
+            </a:r>
+          </a:p>
+        </p:txBody>
+      </p:sp>
+      <p:cxnSp>
+        <p:nvCxnSpPr>
+          <p:cNvPr id="50" name="Connector 49"/>
+          <p:cNvCxnSpPr/>
+          <p:nvPr/>
+        </p:nvCxnSpPr>
+        <p:spPr>
+          <a:xfrm>
+            <a:off x="1435608" y="2228850"/>
+            <a:ext cx="6446519" cy="0"/>
+          </a:xfrm>
+          <a:prstGeom prst="line">
+            <a:avLst/>
+          </a:prstGeom>
+          <a:ln w="19050">
+            <a:solidFill>
+              <a:srgbClr val="C00000"/>
+            </a:solidFill>
+            <a:prstDash val="dash"/>
+          </a:ln>
+          <a:effectLst/>
+        </p:spPr>
+        <p:style>
+          <a:lnRef idx="2">
+            <a:schemeClr val="accent1"/>
+          </a:lnRef>
+          <a:fillRef idx="0">
+            <a:schemeClr val="accent1"/>
+          </a:fillRef>
+          <a:effectRef idx="1">
+            <a:schemeClr val="accent1"/>
+          </a:effectRef>
+          <a:fontRef idx="minor">
+            <a:schemeClr val="tx1"/>
+          </a:fontRef>
+        </p:style>
+      </p:cxnSp>
+      <p:sp>
+        <p:nvSpPr>
+          <p:cNvPr id="51" name="TextBox 50"/>
+          <p:cNvSpPr txBox="1"/>
+          <p:nvPr/>
+        </p:nvSpPr>
+        <p:spPr>
+          <a:xfrm>
+            <a:off x="6601967" y="2009393"/>
+            <a:ext cx="1280160" cy="182880"/>
+          </a:xfrm>
+          <a:prstGeom prst="rect">
+            <a:avLst/>
+          </a:prstGeom>
+          <a:noFill/>
+        </p:spPr>
+        <p:txBody>
+          <a:bodyPr wrap="square" lIns="0" rIns="0" tIns="0" bIns="0">
+            <a:spAutoFit/>
+          </a:bodyPr>
+          <a:lstStyle/>
+          <a:p>
+            <a:pPr algn="r"/>
+            <a:r>
+              <a:rPr sz="1000" b="1">
+                <a:solidFill>
+                  <a:srgbClr val="C00000"/>
+                </a:solidFill>
+                <a:latin typeface="Calibri"/>
+              </a:rPr>
+              <a:t>Takt 42 min</a:t>
+            </a:r>
+          </a:p>
+        </p:txBody>
+      </p:sp>
+      <p:sp>
+        <p:nvSpPr>
+          <p:cNvPr id="52" name="TextBox 51"/>
+          <p:cNvSpPr txBox="1"/>
+          <p:nvPr/>
+        </p:nvSpPr>
+        <p:spPr>
+          <a:xfrm>
+            <a:off x="8229600" y="1463039"/>
+            <a:ext cx="3108960" cy="228600"/>
+          </a:xfrm>
+          <a:prstGeom prst="rect">
+            <a:avLst/>
+          </a:prstGeom>
+          <a:noFill/>
+        </p:spPr>
+        <p:txBody>
+          <a:bodyPr wrap="square" lIns="0" rIns="0" tIns="0" bIns="0">
+            <a:spAutoFit/>
+          </a:bodyPr>
+          <a:lstStyle/>
+          <a:p>
+            <a:pPr algn="l"/>
+            <a:r>
+              <a:rPr sz="1050" b="1">
+                <a:solidFill>
+                  <a:srgbClr val="404040"/>
+                </a:solidFill>
+                <a:latin typeface="Calibri"/>
+              </a:rPr>
+              <a:t>Tasks (SWI step #)</a:t>
+            </a:r>
+          </a:p>
+        </p:txBody>
+      </p:sp>
+      <p:sp>
+        <p:nvSpPr>
+          <p:cNvPr id="53" name="Rectangle 52"/>
+          <p:cNvSpPr/>
+          <p:nvPr/>
+        </p:nvSpPr>
+        <p:spPr>
+          <a:xfrm>
+            <a:off x="8229600" y="1755648"/>
+            <a:ext cx="146304" cy="146304"/>
+          </a:xfrm>
+          <a:prstGeom prst="rect">
+            <a:avLst/>
+          </a:prstGeom>
+          <a:solidFill>
+            <a:srgbClr val="4472C4"/>
+          </a:solidFill>
+          <a:ln>
+            <a:noFill/>
+          </a:ln>
+          <a:effectLst/>
+        </p:spPr>
+        <p:style>
+          <a:lnRef idx="1">
+            <a:schemeClr val="accent1"/>
+          </a:lnRef>
+          <a:fillRef idx="3">
+            <a:schemeClr val="accent1"/>
+          </a:fillRef>
+          <a:effectRef idx="2">
+            <a:schemeClr val="accent1"/>
+          </a:effectRef>
+          <a:fontRef idx="minor">
+            <a:schemeClr val="lt1"/>
+          </a:fontRef>
+        </p:style>
+        <p:txBody>
+          <a:bodyPr rtlCol="0" anchor="ctr"/>
+          <a:lstStyle/>
+          <a:p>
+            <a:pPr algn="ctr"/>
+          </a:p>
+        </p:txBody>
+      </p:sp>
+      <p:sp>
+        <p:nvSpPr>
+          <p:cNvPr id="54" name="TextBox 53"/>
+          <p:cNvSpPr txBox="1"/>
+          <p:nvPr/>
+        </p:nvSpPr>
+        <p:spPr>
+          <a:xfrm>
+            <a:off x="8467344" y="1719072"/>
+            <a:ext cx="2834640" cy="274320"/>
+          </a:xfrm>
+          <a:prstGeom prst="rect">
+            <a:avLst/>
+          </a:prstGeom>
+          <a:noFill/>
+        </p:spPr>
+        <p:txBody>
+          <a:bodyPr wrap="square" lIns="0" rIns="0" tIns="0" bIns="0">
+            <a:spAutoFit/>
+          </a:bodyPr>
+          <a:lstStyle/>
+          <a:p>
+            <a:pPr algn="l"/>
+            <a:r>
+              <a:rPr sz="950" b="1">
+                <a:solidFill>
+                  <a:srgbClr val="1F3864"/>
+                </a:solidFill>
+                <a:latin typeface="Calibri"/>
+              </a:rPr>
+              <a:t>#2  </a:t>
+            </a:r>
+            <a:r>
+              <a:rPr sz="950" b="0">
+                <a:solidFill>
+                  <a:srgbClr val="404040"/>
+                </a:solidFill>
+                <a:latin typeface="Calibri"/>
+              </a:rPr>
+              <a:t>Connector Prep</a:t>
+            </a:r>
+          </a:p>
+        </p:txBody>
+      </p:sp>
+      <p:sp>
+        <p:nvSpPr>
+          <p:cNvPr id="55" name="Rectangle 54"/>
+          <p:cNvSpPr/>
+          <p:nvPr/>
+        </p:nvSpPr>
+        <p:spPr>
+          <a:xfrm>
+            <a:off x="8229600" y="2071116"/>
+            <a:ext cx="146304" cy="146304"/>
+          </a:xfrm>
+          <a:prstGeom prst="rect">
+            <a:avLst/>
+          </a:prstGeom>
+          <a:solidFill>
+            <a:srgbClr val="70AD47"/>
+          </a:solidFill>
+          <a:ln>
+            <a:noFill/>
+          </a:ln>
+          <a:effectLst/>
+        </p:spPr>
+        <p:style>
+          <a:lnRef idx="1">
+            <a:schemeClr val="accent1"/>
+          </a:lnRef>
+          <a:fillRef idx="3">
+            <a:schemeClr val="accent1"/>
+          </a:fillRef>
+          <a:effectRef idx="2">
+            <a:schemeClr val="accent1"/>
+          </a:effectRef>
+          <a:fontRef idx="minor">
+            <a:schemeClr val="lt1"/>
+          </a:fontRef>
+        </p:style>
+        <p:txBody>
+          <a:bodyPr rtlCol="0" anchor="ctr"/>
+          <a:lstStyle/>
+          <a:p>
+            <a:pPr algn="ctr"/>
+          </a:p>
+        </p:txBody>
+      </p:sp>
+      <p:sp>
+        <p:nvSpPr>
+          <p:cNvPr id="56" name="TextBox 55"/>
+          <p:cNvSpPr txBox="1"/>
+          <p:nvPr/>
+        </p:nvSpPr>
+        <p:spPr>
+          <a:xfrm>
+            <a:off x="8467344" y="2034540"/>
+            <a:ext cx="2834640" cy="274320"/>
+          </a:xfrm>
+          <a:prstGeom prst="rect">
+            <a:avLst/>
+          </a:prstGeom>
+          <a:noFill/>
+        </p:spPr>
+        <p:txBody>
+          <a:bodyPr wrap="square" lIns="0" rIns="0" tIns="0" bIns="0">
+            <a:spAutoFit/>
+          </a:bodyPr>
+          <a:lstStyle/>
+          <a:p>
+            <a:pPr algn="l"/>
+            <a:r>
+              <a:rPr sz="950" b="1">
+                <a:solidFill>
+                  <a:srgbClr val="1F3864"/>
+                </a:solidFill>
+                <a:latin typeface="Calibri"/>
+              </a:rPr>
+              <a:t>#3  </a:t>
+            </a:r>
+            <a:r>
+              <a:rPr sz="950" b="0">
+                <a:solidFill>
+                  <a:srgbClr val="404040"/>
+                </a:solidFill>
+                <a:latin typeface="Calibri"/>
+              </a:rPr>
+              <a:t>Leg Assembly</a:t>
+            </a:r>
+          </a:p>
+        </p:txBody>
+      </p:sp>
+      <p:sp>
+        <p:nvSpPr>
+          <p:cNvPr id="57" name="Rectangle 56"/>
+          <p:cNvSpPr/>
+          <p:nvPr/>
+        </p:nvSpPr>
+        <p:spPr>
+          <a:xfrm>
+            <a:off x="8229600" y="2386584"/>
+            <a:ext cx="146304" cy="146304"/>
+          </a:xfrm>
+          <a:prstGeom prst="rect">
+            <a:avLst/>
+          </a:prstGeom>
+          <a:solidFill>
+            <a:srgbClr val="1F3864"/>
+          </a:solidFill>
+          <a:ln>
+            <a:noFill/>
+          </a:ln>
+          <a:effectLst/>
+        </p:spPr>
+        <p:style>
+          <a:lnRef idx="1">
+            <a:schemeClr val="accent1"/>
+          </a:lnRef>
+          <a:fillRef idx="3">
+            <a:schemeClr val="accent1"/>
+          </a:fillRef>
+          <a:effectRef idx="2">
+            <a:schemeClr val="accent1"/>
+          </a:effectRef>
+          <a:fontRef idx="minor">
+            <a:schemeClr val="lt1"/>
+          </a:fontRef>
+        </p:style>
+        <p:txBody>
+          <a:bodyPr rtlCol="0" anchor="ctr"/>
+          <a:lstStyle/>
+          <a:p>
+            <a:pPr algn="ctr"/>
+          </a:p>
+        </p:txBody>
+      </p:sp>
+      <p:sp>
+        <p:nvSpPr>
+          <p:cNvPr id="58" name="TextBox 57"/>
+          <p:cNvSpPr txBox="1"/>
+          <p:nvPr/>
+        </p:nvSpPr>
+        <p:spPr>
+          <a:xfrm>
+            <a:off x="8467344" y="2350008"/>
+            <a:ext cx="2834640" cy="274320"/>
+          </a:xfrm>
+          <a:prstGeom prst="rect">
+            <a:avLst/>
+          </a:prstGeom>
+          <a:noFill/>
+        </p:spPr>
+        <p:txBody>
+          <a:bodyPr wrap="square" lIns="0" rIns="0" tIns="0" bIns="0">
+            <a:spAutoFit/>
+          </a:bodyPr>
+          <a:lstStyle/>
+          <a:p>
+            <a:pPr algn="l"/>
+            <a:r>
+              <a:rPr sz="950" b="1">
+                <a:solidFill>
+                  <a:srgbClr val="1F3864"/>
+                </a:solidFill>
+                <a:latin typeface="Calibri"/>
+              </a:rPr>
+              <a:t>#4  </a:t>
+            </a:r>
+            <a:r>
+              <a:rPr sz="950" b="0">
+                <a:solidFill>
+                  <a:srgbClr val="404040"/>
+                </a:solidFill>
+                <a:latin typeface="Calibri"/>
+              </a:rPr>
+              <a:t>Arms Assembly</a:t>
+            </a:r>
+          </a:p>
+        </p:txBody>
+      </p:sp>
+      <p:sp>
+        <p:nvSpPr>
+          <p:cNvPr id="59" name="Rectangle 58"/>
+          <p:cNvSpPr/>
+          <p:nvPr/>
+        </p:nvSpPr>
+        <p:spPr>
+          <a:xfrm>
+            <a:off x="8229600" y="2702051"/>
+            <a:ext cx="146304" cy="146304"/>
+          </a:xfrm>
+          <a:prstGeom prst="rect">
+            <a:avLst/>
+          </a:prstGeom>
+          <a:solidFill>
+            <a:srgbClr val="5B9BD5"/>
+          </a:solidFill>
+          <a:ln>
+            <a:noFill/>
+          </a:ln>
+          <a:effectLst/>
+        </p:spPr>
+        <p:style>
+          <a:lnRef idx="1">
+            <a:schemeClr val="accent1"/>
+          </a:lnRef>
+          <a:fillRef idx="3">
+            <a:schemeClr val="accent1"/>
+          </a:fillRef>
+          <a:effectRef idx="2">
+            <a:schemeClr val="accent1"/>
+          </a:effectRef>
+          <a:fontRef idx="minor">
+            <a:schemeClr val="lt1"/>
+          </a:fontRef>
+        </p:style>
+        <p:txBody>
+          <a:bodyPr rtlCol="0" anchor="ctr"/>
+          <a:lstStyle/>
+          <a:p>
+            <a:pPr algn="ctr"/>
+          </a:p>
+        </p:txBody>
+      </p:sp>
+      <p:sp>
+        <p:nvSpPr>
+          <p:cNvPr id="60" name="TextBox 59"/>
+          <p:cNvSpPr txBox="1"/>
+          <p:nvPr/>
+        </p:nvSpPr>
+        <p:spPr>
+          <a:xfrm>
+            <a:off x="8467344" y="2665475"/>
+            <a:ext cx="2834640" cy="274320"/>
+          </a:xfrm>
+          <a:prstGeom prst="rect">
+            <a:avLst/>
+          </a:prstGeom>
+          <a:noFill/>
+        </p:spPr>
+        <p:txBody>
+          <a:bodyPr wrap="square" lIns="0" rIns="0" tIns="0" bIns="0">
+            <a:spAutoFit/>
+          </a:bodyPr>
+          <a:lstStyle/>
+          <a:p>
+            <a:pPr algn="l"/>
+            <a:r>
+              <a:rPr sz="950" b="1">
+                <a:solidFill>
+                  <a:srgbClr val="1F3864"/>
+                </a:solidFill>
+                <a:latin typeface="Calibri"/>
+              </a:rPr>
+              <a:t>#5  </a:t>
+            </a:r>
+            <a:r>
+              <a:rPr sz="950" b="0">
+                <a:solidFill>
+                  <a:srgbClr val="404040"/>
+                </a:solidFill>
+                <a:latin typeface="Calibri"/>
+              </a:rPr>
+              <a:t>Seat Frame Assembly</a:t>
+            </a:r>
+          </a:p>
+        </p:txBody>
+      </p:sp>
+      <p:sp>
+        <p:nvSpPr>
+          <p:cNvPr id="61" name="Rectangle 60"/>
+          <p:cNvSpPr/>
+          <p:nvPr/>
+        </p:nvSpPr>
+        <p:spPr>
+          <a:xfrm>
+            <a:off x="8229600" y="3017520"/>
+            <a:ext cx="146304" cy="146304"/>
+          </a:xfrm>
+          <a:prstGeom prst="rect">
+            <a:avLst/>
+          </a:prstGeom>
+          <a:solidFill>
+            <a:srgbClr val="ED7D31"/>
+          </a:solidFill>
+          <a:ln>
+            <a:noFill/>
+          </a:ln>
+          <a:effectLst/>
+        </p:spPr>
+        <p:style>
+          <a:lnRef idx="1">
+            <a:schemeClr val="accent1"/>
+          </a:lnRef>
+          <a:fillRef idx="3">
+            <a:schemeClr val="accent1"/>
+          </a:fillRef>
+          <a:effectRef idx="2">
+            <a:schemeClr val="accent1"/>
+          </a:effectRef>
+          <a:fontRef idx="minor">
+            <a:schemeClr val="lt1"/>
+          </a:fontRef>
+        </p:style>
+        <p:txBody>
+          <a:bodyPr rtlCol="0" anchor="ctr"/>
+          <a:lstStyle/>
+          <a:p>
+            <a:pPr algn="ctr"/>
+          </a:p>
+        </p:txBody>
+      </p:sp>
+      <p:sp>
+        <p:nvSpPr>
+          <p:cNvPr id="62" name="TextBox 61"/>
+          <p:cNvSpPr txBox="1"/>
+          <p:nvPr/>
+        </p:nvSpPr>
+        <p:spPr>
+          <a:xfrm>
+            <a:off x="8467344" y="2980944"/>
+            <a:ext cx="2834640" cy="274320"/>
+          </a:xfrm>
+          <a:prstGeom prst="rect">
+            <a:avLst/>
+          </a:prstGeom>
+          <a:noFill/>
+        </p:spPr>
+        <p:txBody>
+          <a:bodyPr wrap="square" lIns="0" rIns="0" tIns="0" bIns="0">
+            <a:spAutoFit/>
+          </a:bodyPr>
+          <a:lstStyle/>
+          <a:p>
+            <a:pPr algn="l"/>
+            <a:r>
+              <a:rPr sz="950" b="1">
+                <a:solidFill>
+                  <a:srgbClr val="1F3864"/>
+                </a:solidFill>
+                <a:latin typeface="Calibri"/>
+              </a:rPr>
+              <a:t>#6  </a:t>
+            </a:r>
+            <a:r>
+              <a:rPr sz="950" b="0">
+                <a:solidFill>
+                  <a:srgbClr val="404040"/>
+                </a:solidFill>
+                <a:latin typeface="Calibri"/>
+              </a:rPr>
+              <a:t>Back Frame Assembly</a:t>
+            </a:r>
+          </a:p>
+        </p:txBody>
+      </p:sp>
+      <p:sp>
+        <p:nvSpPr>
+          <p:cNvPr id="63" name="Rectangle 62"/>
+          <p:cNvSpPr/>
+          <p:nvPr/>
+        </p:nvSpPr>
+        <p:spPr>
+          <a:xfrm>
+            <a:off x="8229600" y="3332988"/>
+            <a:ext cx="146304" cy="146304"/>
+          </a:xfrm>
+          <a:prstGeom prst="rect">
+            <a:avLst/>
+          </a:prstGeom>
+          <a:solidFill>
+            <a:srgbClr val="A5A5A5"/>
+          </a:solidFill>
+          <a:ln>
+            <a:noFill/>
+          </a:ln>
+          <a:effectLst/>
+        </p:spPr>
+        <p:style>
+          <a:lnRef idx="1">
+            <a:schemeClr val="accent1"/>
+          </a:lnRef>
+          <a:fillRef idx="3">
+            <a:schemeClr val="accent1"/>
+          </a:fillRef>
+          <a:effectRef idx="2">
+            <a:schemeClr val="accent1"/>
+          </a:effectRef>
+          <a:fontRef idx="minor">
+            <a:schemeClr val="lt1"/>
+          </a:fontRef>
+        </p:style>
+        <p:txBody>
+          <a:bodyPr rtlCol="0" anchor="ctr"/>
+          <a:lstStyle/>
+          <a:p>
+            <a:pPr algn="ctr"/>
+          </a:p>
+        </p:txBody>
+      </p:sp>
+      <p:sp>
+        <p:nvSpPr>
+          <p:cNvPr id="64" name="TextBox 63"/>
+          <p:cNvSpPr txBox="1"/>
+          <p:nvPr/>
+        </p:nvSpPr>
+        <p:spPr>
+          <a:xfrm>
+            <a:off x="8467344" y="3296412"/>
+            <a:ext cx="2834640" cy="274320"/>
+          </a:xfrm>
+          <a:prstGeom prst="rect">
+            <a:avLst/>
+          </a:prstGeom>
+          <a:noFill/>
+        </p:spPr>
+        <p:txBody>
+          <a:bodyPr wrap="square" lIns="0" rIns="0" tIns="0" bIns="0">
+            <a:spAutoFit/>
+          </a:bodyPr>
+          <a:lstStyle/>
+          <a:p>
+            <a:pPr algn="l"/>
+            <a:r>
+              <a:rPr sz="950" b="1">
+                <a:solidFill>
+                  <a:srgbClr val="1F3864"/>
+                </a:solidFill>
+                <a:latin typeface="Calibri"/>
+              </a:rPr>
+              <a:t>#7  </a:t>
+            </a:r>
+            <a:r>
+              <a:rPr sz="950" b="0">
+                <a:solidFill>
+                  <a:srgbClr val="404040"/>
+                </a:solidFill>
+                <a:latin typeface="Calibri"/>
+              </a:rPr>
+              <a:t>Attaching Arms</a:t>
+            </a:r>
+          </a:p>
+        </p:txBody>
+      </p:sp>
+      <p:sp>
+        <p:nvSpPr>
+          <p:cNvPr id="65" name="Rectangle 64"/>
+          <p:cNvSpPr/>
+          <p:nvPr/>
+        </p:nvSpPr>
+        <p:spPr>
+          <a:xfrm>
+            <a:off x="8229600" y="3648456"/>
+            <a:ext cx="146304" cy="146304"/>
+          </a:xfrm>
+          <a:prstGeom prst="rect">
+            <a:avLst/>
+          </a:prstGeom>
+          <a:solidFill>
+            <a:srgbClr val="997300"/>
+          </a:solidFill>
+          <a:ln>
+            <a:noFill/>
+          </a:ln>
+          <a:effectLst/>
+        </p:spPr>
+        <p:style>
+          <a:lnRef idx="1">
+            <a:schemeClr val="accent1"/>
+          </a:lnRef>
+          <a:fillRef idx="3">
+            <a:schemeClr val="accent1"/>
+          </a:fillRef>
+          <a:effectRef idx="2">
+            <a:schemeClr val="accent1"/>
+          </a:effectRef>
+          <a:fontRef idx="minor">
+            <a:schemeClr val="lt1"/>
+          </a:fontRef>
+        </p:style>
+        <p:txBody>
+          <a:bodyPr rtlCol="0" anchor="ctr"/>
+          <a:lstStyle/>
+          <a:p>
+            <a:pPr algn="ctr"/>
+          </a:p>
+        </p:txBody>
+      </p:sp>
+      <p:sp>
+        <p:nvSpPr>
+          <p:cNvPr id="66" name="TextBox 65"/>
+          <p:cNvSpPr txBox="1"/>
+          <p:nvPr/>
+        </p:nvSpPr>
+        <p:spPr>
+          <a:xfrm>
+            <a:off x="8467344" y="3611879"/>
+            <a:ext cx="2834640" cy="274320"/>
+          </a:xfrm>
+          <a:prstGeom prst="rect">
+            <a:avLst/>
+          </a:prstGeom>
+          <a:noFill/>
+        </p:spPr>
+        <p:txBody>
+          <a:bodyPr wrap="square" lIns="0" rIns="0" tIns="0" bIns="0">
+            <a:spAutoFit/>
+          </a:bodyPr>
+          <a:lstStyle/>
+          <a:p>
+            <a:pPr algn="l"/>
+            <a:r>
+              <a:rPr sz="950" b="1">
+                <a:solidFill>
+                  <a:srgbClr val="1F3864"/>
+                </a:solidFill>
+                <a:latin typeface="Calibri"/>
+              </a:rPr>
+              <a:t>#8  </a:t>
+            </a:r>
+            <a:r>
+              <a:rPr sz="950" b="0">
+                <a:solidFill>
+                  <a:srgbClr val="404040"/>
+                </a:solidFill>
+                <a:latin typeface="Calibri"/>
+              </a:rPr>
+              <a:t>Attaching Back Support</a:t>
+            </a:r>
+          </a:p>
+        </p:txBody>
+      </p:sp>
+      <p:sp>
+        <p:nvSpPr>
+          <p:cNvPr id="67" name="Rectangle 66"/>
+          <p:cNvSpPr/>
+          <p:nvPr/>
+        </p:nvSpPr>
+        <p:spPr>
+          <a:xfrm>
+            <a:off x="8229600" y="3963923"/>
+            <a:ext cx="146304" cy="146304"/>
+          </a:xfrm>
+          <a:prstGeom prst="rect">
+            <a:avLst/>
+          </a:prstGeom>
+          <a:solidFill>
+            <a:srgbClr val="548235"/>
+          </a:solidFill>
+          <a:ln>
+            <a:noFill/>
+          </a:ln>
+          <a:effectLst/>
+        </p:spPr>
+        <p:style>
+          <a:lnRef idx="1">
+            <a:schemeClr val="accent1"/>
+          </a:lnRef>
+          <a:fillRef idx="3">
+            <a:schemeClr val="accent1"/>
+          </a:fillRef>
+          <a:effectRef idx="2">
+            <a:schemeClr val="accent1"/>
+          </a:effectRef>
+          <a:fontRef idx="minor">
+            <a:schemeClr val="lt1"/>
+          </a:fontRef>
+        </p:style>
+        <p:txBody>
+          <a:bodyPr rtlCol="0" anchor="ctr"/>
+          <a:lstStyle/>
+          <a:p>
+            <a:pPr algn="ctr"/>
+          </a:p>
+        </p:txBody>
+      </p:sp>
+      <p:sp>
+        <p:nvSpPr>
+          <p:cNvPr id="68" name="TextBox 67"/>
+          <p:cNvSpPr txBox="1"/>
+          <p:nvPr/>
+        </p:nvSpPr>
+        <p:spPr>
+          <a:xfrm>
+            <a:off x="8467344" y="3927348"/>
+            <a:ext cx="2834640" cy="274320"/>
+          </a:xfrm>
+          <a:prstGeom prst="rect">
+            <a:avLst/>
+          </a:prstGeom>
+          <a:noFill/>
+        </p:spPr>
+        <p:txBody>
+          <a:bodyPr wrap="square" lIns="0" rIns="0" tIns="0" bIns="0">
+            <a:spAutoFit/>
+          </a:bodyPr>
+          <a:lstStyle/>
+          <a:p>
+            <a:pPr algn="l"/>
+            <a:r>
+              <a:rPr sz="950" b="1">
+                <a:solidFill>
+                  <a:srgbClr val="1F3864"/>
+                </a:solidFill>
+                <a:latin typeface="Calibri"/>
+              </a:rPr>
+              <a:t>#9  </a:t>
+            </a:r>
+            <a:r>
+              <a:rPr sz="950" b="0">
+                <a:solidFill>
+                  <a:srgbClr val="404040"/>
+                </a:solidFill>
+                <a:latin typeface="Calibri"/>
+              </a:rPr>
+              <a:t>Leg Finishing</a:t>
+            </a:r>
+          </a:p>
+        </p:txBody>
+      </p:sp>
+      <p:sp>
+        <p:nvSpPr>
+          <p:cNvPr id="69" name="Rectangle 68"/>
+          <p:cNvSpPr/>
+          <p:nvPr/>
+        </p:nvSpPr>
+        <p:spPr>
+          <a:xfrm>
+            <a:off x="8229600" y="4279392"/>
+            <a:ext cx="146304" cy="146304"/>
+          </a:xfrm>
+          <a:prstGeom prst="rect">
+            <a:avLst/>
+          </a:prstGeom>
+          <a:solidFill>
+            <a:srgbClr val="843C0C"/>
+          </a:solidFill>
+          <a:ln>
+            <a:noFill/>
+          </a:ln>
+          <a:effectLst/>
+        </p:spPr>
+        <p:style>
+          <a:lnRef idx="1">
+            <a:schemeClr val="accent1"/>
+          </a:lnRef>
+          <a:fillRef idx="3">
+            <a:schemeClr val="accent1"/>
+          </a:fillRef>
+          <a:effectRef idx="2">
+            <a:schemeClr val="accent1"/>
+          </a:effectRef>
+          <a:fontRef idx="minor">
+            <a:schemeClr val="lt1"/>
+          </a:fontRef>
+        </p:style>
+        <p:txBody>
+          <a:bodyPr rtlCol="0" anchor="ctr"/>
+          <a:lstStyle/>
+          <a:p>
+            <a:pPr algn="ctr"/>
+          </a:p>
+        </p:txBody>
+      </p:sp>
+      <p:sp>
+        <p:nvSpPr>
+          <p:cNvPr id="70" name="TextBox 69"/>
+          <p:cNvSpPr txBox="1"/>
+          <p:nvPr/>
+        </p:nvSpPr>
+        <p:spPr>
+          <a:xfrm>
+            <a:off x="8467344" y="4242816"/>
+            <a:ext cx="2834640" cy="274320"/>
+          </a:xfrm>
+          <a:prstGeom prst="rect">
+            <a:avLst/>
+          </a:prstGeom>
+          <a:noFill/>
+        </p:spPr>
+        <p:txBody>
+          <a:bodyPr wrap="square" lIns="0" rIns="0" tIns="0" bIns="0">
+            <a:spAutoFit/>
+          </a:bodyPr>
+          <a:lstStyle/>
+          <a:p>
+            <a:pPr algn="l"/>
+            <a:r>
+              <a:rPr sz="950" b="1">
+                <a:solidFill>
+                  <a:srgbClr val="1F3864"/>
+                </a:solidFill>
+                <a:latin typeface="Calibri"/>
+              </a:rPr>
+              <a:t>#10  </a:t>
+            </a:r>
+            <a:r>
+              <a:rPr sz="950" b="0">
+                <a:solidFill>
+                  <a:srgbClr val="404040"/>
+                </a:solidFill>
+                <a:latin typeface="Calibri"/>
+              </a:rPr>
+              <a:t>Seat Support Frame</a:t>
+            </a:r>
+          </a:p>
+        </p:txBody>
+      </p:sp>
+      <p:sp>
+        <p:nvSpPr>
+          <p:cNvPr id="71" name="Rectangle 70"/>
+          <p:cNvSpPr/>
+          <p:nvPr/>
+        </p:nvSpPr>
+        <p:spPr>
+          <a:xfrm>
+            <a:off x="8229600" y="4594859"/>
+            <a:ext cx="146304" cy="146304"/>
+          </a:xfrm>
+          <a:prstGeom prst="rect">
+            <a:avLst/>
+          </a:prstGeom>
+          <a:solidFill>
+            <a:srgbClr val="7B7B7B"/>
+          </a:solidFill>
+          <a:ln>
+            <a:noFill/>
+          </a:ln>
+          <a:effectLst/>
+        </p:spPr>
+        <p:style>
+          <a:lnRef idx="1">
+            <a:schemeClr val="accent1"/>
+          </a:lnRef>
+          <a:fillRef idx="3">
+            <a:schemeClr val="accent1"/>
+          </a:fillRef>
+          <a:effectRef idx="2">
+            <a:schemeClr val="accent1"/>
+          </a:effectRef>
+          <a:fontRef idx="minor">
+            <a:schemeClr val="lt1"/>
+          </a:fontRef>
+        </p:style>
+        <p:txBody>
+          <a:bodyPr rtlCol="0" anchor="ctr"/>
+          <a:lstStyle/>
+          <a:p>
+            <a:pPr algn="ctr"/>
+          </a:p>
+        </p:txBody>
+      </p:sp>
+      <p:sp>
+        <p:nvSpPr>
+          <p:cNvPr id="72" name="TextBox 71"/>
+          <p:cNvSpPr txBox="1"/>
+          <p:nvPr/>
+        </p:nvSpPr>
+        <p:spPr>
+          <a:xfrm>
+            <a:off x="8467344" y="4558283"/>
+            <a:ext cx="2834640" cy="274320"/>
+          </a:xfrm>
+          <a:prstGeom prst="rect">
+            <a:avLst/>
+          </a:prstGeom>
+          <a:noFill/>
+        </p:spPr>
+        <p:txBody>
+          <a:bodyPr wrap="square" lIns="0" rIns="0" tIns="0" bIns="0">
+            <a:spAutoFit/>
+          </a:bodyPr>
+          <a:lstStyle/>
+          <a:p>
+            <a:pPr algn="l"/>
+            <a:r>
+              <a:rPr sz="950" b="1">
+                <a:solidFill>
+                  <a:srgbClr val="1F3864"/>
+                </a:solidFill>
+                <a:latin typeface="Calibri"/>
+              </a:rPr>
+              <a:t>#11  </a:t>
+            </a:r>
+            <a:r>
+              <a:rPr sz="950" b="0">
+                <a:solidFill>
+                  <a:srgbClr val="404040"/>
+                </a:solidFill>
+                <a:latin typeface="Calibri"/>
+              </a:rPr>
+              <a:t>Attaching Seat Frame</a:t>
+            </a:r>
+          </a:p>
+        </p:txBody>
+      </p:sp>
+      <p:sp>
+        <p:nvSpPr>
+          <p:cNvPr id="73" name="Rectangle 72"/>
+          <p:cNvSpPr/>
+          <p:nvPr/>
+        </p:nvSpPr>
+        <p:spPr>
+          <a:xfrm>
+            <a:off x="8229600" y="4910327"/>
+            <a:ext cx="146304" cy="146304"/>
+          </a:xfrm>
+          <a:prstGeom prst="rect">
+            <a:avLst/>
+          </a:prstGeom>
+          <a:solidFill>
+            <a:srgbClr val="BF8F00"/>
+          </a:solidFill>
+          <a:ln>
+            <a:noFill/>
+          </a:ln>
+          <a:effectLst/>
+        </p:spPr>
+        <p:style>
+          <a:lnRef idx="1">
+            <a:schemeClr val="accent1"/>
+          </a:lnRef>
+          <a:fillRef idx="3">
+            <a:schemeClr val="accent1"/>
+          </a:fillRef>
+          <a:effectRef idx="2">
+            <a:schemeClr val="accent1"/>
+          </a:effectRef>
+          <a:fontRef idx="minor">
+            <a:schemeClr val="lt1"/>
+          </a:fontRef>
+        </p:style>
+        <p:txBody>
+          <a:bodyPr rtlCol="0" anchor="ctr"/>
+          <a:lstStyle/>
+          <a:p>
+            <a:pPr algn="ctr"/>
+          </a:p>
+        </p:txBody>
+      </p:sp>
+      <p:sp>
+        <p:nvSpPr>
+          <p:cNvPr id="74" name="TextBox 73"/>
+          <p:cNvSpPr txBox="1"/>
+          <p:nvPr/>
+        </p:nvSpPr>
+        <p:spPr>
+          <a:xfrm>
+            <a:off x="8467344" y="4873752"/>
+            <a:ext cx="2834640" cy="274320"/>
+          </a:xfrm>
+          <a:prstGeom prst="rect">
+            <a:avLst/>
+          </a:prstGeom>
+          <a:noFill/>
+        </p:spPr>
+        <p:txBody>
+          <a:bodyPr wrap="square" lIns="0" rIns="0" tIns="0" bIns="0">
+            <a:spAutoFit/>
+          </a:bodyPr>
+          <a:lstStyle/>
+          <a:p>
+            <a:pPr algn="l"/>
+            <a:r>
+              <a:rPr sz="950" b="1">
+                <a:solidFill>
+                  <a:srgbClr val="1F3864"/>
+                </a:solidFill>
+                <a:latin typeface="Calibri"/>
+              </a:rPr>
+              <a:t>#12  </a:t>
+            </a:r>
+            <a:r>
+              <a:rPr sz="950" b="0">
+                <a:solidFill>
+                  <a:srgbClr val="404040"/>
+                </a:solidFill>
+                <a:latin typeface="Calibri"/>
+              </a:rPr>
+              <a:t>Attach TUUCI Plate</a:t>
+            </a:r>
+          </a:p>
+        </p:txBody>
+      </p:sp>
+      <p:sp>
+        <p:nvSpPr>
+          <p:cNvPr id="75" name="TextBox 74"/>
+          <p:cNvSpPr txBox="1"/>
+          <p:nvPr/>
+        </p:nvSpPr>
+        <p:spPr>
+          <a:xfrm>
+            <a:off x="1024128" y="5806440"/>
+            <a:ext cx="10241280" cy="365760"/>
+          </a:xfrm>
+          <a:prstGeom prst="rect">
+            <a:avLst/>
+          </a:prstGeom>
+          <a:noFill/>
+        </p:spPr>
+        <p:txBody>
+          <a:bodyPr wrap="square" lIns="0" rIns="0" tIns="0" bIns="0">
+            <a:spAutoFit/>
+          </a:bodyPr>
+          <a:lstStyle/>
+          <a:p>
+            <a:pPr algn="l"/>
+            <a:r>
+              <a:rPr sz="1100" b="0">
+                <a:solidFill>
+                  <a:srgbClr val="404040"/>
+                </a:solidFill>
+                <a:latin typeface="Calibri"/>
+              </a:rPr>
+              <a:t>Takt 42 min   ·   Cycle time 41.5 min   ·   Capacity ~10 units/day   ·   88% line efficiency   ·   </a:t>
+            </a:r>
+            <a:r>
+              <a:rPr sz="1100" b="0">
+                <a:solidFill>
+                  <a:srgbClr val="404040"/>
+                </a:solidFill>
+                <a:latin typeface="Calibri"/>
+              </a:rPr>
+              <a:t>S2 = Arms built by 2 operators (64 → 32 min); Seat Frame (#5) &amp; Back Frame (#6) split across stations.</a:t>
+            </a:r>
+          </a:p>
+        </p:txBody>
+      </p:sp>
+    </p:spTree>
+  </p:cSld>
+  <p:clrMapOvr>
+    <a:masterClrMapping/>
+  </p:clrMapOvr>
+</p:sld>
+</file>
+
 <file path=ppt/theme/theme1.xml><?xml version="1.0" encoding="utf-8"?>
 <a:theme xmlns:a="http://schemas.openxmlformats.org/drawingml/2006/main" name="Office Theme">
   <a:themeElements>

</xml_diff>

<commit_message>
Add connector-BOM slide after Meritage Improvements
New slide "First Step to Pre-Assembly: Fix the Connector BOM":
- Premise: pre-assembly in Vietnam requires each connector uniquely
  identified by part number in the BOM
- BOM lists 2 connector types; there are really 3
- Table: Front = 1015301 x2 (Type 1); Back-left = 1015302 (left config);
  Back-right = 1016592 (right config)
- Callout: drawings show all three correctly, BOM does not — close the
  drawing-to-BOM gap to enable correct pre-assembly

Co-Authored-By: Claude Fable 5 <noreply@anthropic.com>
Claude-Session: https://claude.ai/code/session_019MdxDfxB8wg2Ht2aZSuwqK
</commit_message>
<xml_diff>
--- a/standard-work/standalone/Meritage_3Seater_Standard_Work.pptx
+++ b/standard-work/standalone/Meritage_3Seater_Standard_Work.pptx
@@ -7,9 +7,14 @@
   <p:sldIdLst>
     <p:sldId id="309" r:id="rId2"/>
     <p:sldId id="311" r:id="rId3"/>
-    <p:sldId id="312" r:id="rId4"/>
-    <p:sldId id="314" r:id="rId11"/>
-    <p:sldId id="313" r:id="rId5"/>
+    <p:sldId id="317" r:id="rId4"/>
+    <p:sldId id="318" r:id="rId5"/>
+    <p:sldId id="312" r:id="rId6"/>
+    <p:sldId id="313" r:id="rId7"/>
+    <p:sldId id="319" r:id="rId16"/>
+    <p:sldId id="314" r:id="rId8"/>
+    <p:sldId id="315" r:id="rId9"/>
+    <p:sldId id="316" r:id="rId10"/>
   </p:sldIdLst>
   <p:sldSz cx="12192000" cy="6858000"/>
   <p:notesSz cx="6858000" cy="9144000"/>
@@ -271,7 +276,7 @@
           <a:p>
             <a:fld id="{701F44BB-14DF-43E9-8FF7-086183F60DE1}" type="datetimeFigureOut">
               <a:rPr lang="en-US" smtClean="0"/>
-              <a:t>6/18/2026</a:t>
+              <a:t>6/22/2026</a:t>
             </a:fld>
             <a:endParaRPr lang="en-US"/>
           </a:p>
@@ -341,6 +346,7 @@
   <p:clrMapOvr>
     <a:masterClrMapping/>
   </p:clrMapOvr>
+  <p:transition spd="med"/>
 </p:sldLayout>
 </file>
 
@@ -469,7 +475,7 @@
           <a:p>
             <a:fld id="{701F44BB-14DF-43E9-8FF7-086183F60DE1}" type="datetimeFigureOut">
               <a:rPr lang="en-US" smtClean="0"/>
-              <a:t>6/18/2026</a:t>
+              <a:t>6/22/2026</a:t>
             </a:fld>
             <a:endParaRPr lang="en-US"/>
           </a:p>
@@ -539,6 +545,7 @@
   <p:clrMapOvr>
     <a:masterClrMapping/>
   </p:clrMapOvr>
+  <p:transition spd="med"/>
 </p:sldLayout>
 </file>
 
@@ -677,7 +684,7 @@
           <a:p>
             <a:fld id="{701F44BB-14DF-43E9-8FF7-086183F60DE1}" type="datetimeFigureOut">
               <a:rPr lang="en-US" smtClean="0"/>
-              <a:t>6/18/2026</a:t>
+              <a:t>6/22/2026</a:t>
             </a:fld>
             <a:endParaRPr lang="en-US"/>
           </a:p>
@@ -747,6 +754,7 @@
   <p:clrMapOvr>
     <a:masterClrMapping/>
   </p:clrMapOvr>
+  <p:transition spd="med"/>
 </p:sldLayout>
 </file>
 
@@ -922,6 +930,7 @@
           <a:lstStyle/>
           <a:p>
             <a:fld id="{86CB4B4D-7CA3-9044-876B-883B54F8677D}" type="slidenum">
+              <a:rPr/>
               <a:t>‹#›</a:t>
             </a:fld>
             <a:endParaRPr/>
@@ -1282,6 +1291,7 @@
           <a:lstStyle/>
           <a:p>
             <a:fld id="{86CB4B4D-7CA3-9044-876B-883B54F8677D}" type="slidenum">
+              <a:rPr/>
               <a:t>‹#›</a:t>
             </a:fld>
             <a:endParaRPr/>
@@ -1427,7 +1437,7 @@
           <a:p>
             <a:fld id="{701F44BB-14DF-43E9-8FF7-086183F60DE1}" type="datetimeFigureOut">
               <a:rPr lang="en-US" smtClean="0"/>
-              <a:t>6/18/2026</a:t>
+              <a:t>6/22/2026</a:t>
             </a:fld>
             <a:endParaRPr lang="en-US"/>
           </a:p>
@@ -1497,6 +1507,7 @@
   <p:clrMapOvr>
     <a:masterClrMapping/>
   </p:clrMapOvr>
+  <p:transition spd="med"/>
 </p:sldLayout>
 </file>
 
@@ -1702,7 +1713,7 @@
           <a:p>
             <a:fld id="{701F44BB-14DF-43E9-8FF7-086183F60DE1}" type="datetimeFigureOut">
               <a:rPr lang="en-US" smtClean="0"/>
-              <a:t>6/18/2026</a:t>
+              <a:t>6/22/2026</a:t>
             </a:fld>
             <a:endParaRPr lang="en-US"/>
           </a:p>
@@ -1772,6 +1783,7 @@
   <p:clrMapOvr>
     <a:masterClrMapping/>
   </p:clrMapOvr>
+  <p:transition spd="med"/>
 </p:sldLayout>
 </file>
 
@@ -1967,7 +1979,7 @@
           <a:p>
             <a:fld id="{701F44BB-14DF-43E9-8FF7-086183F60DE1}" type="datetimeFigureOut">
               <a:rPr lang="en-US" smtClean="0"/>
-              <a:t>6/18/2026</a:t>
+              <a:t>6/22/2026</a:t>
             </a:fld>
             <a:endParaRPr lang="en-US"/>
           </a:p>
@@ -2037,6 +2049,7 @@
   <p:clrMapOvr>
     <a:masterClrMapping/>
   </p:clrMapOvr>
+  <p:transition spd="med"/>
 </p:sldLayout>
 </file>
 
@@ -2379,7 +2392,7 @@
           <a:p>
             <a:fld id="{701F44BB-14DF-43E9-8FF7-086183F60DE1}" type="datetimeFigureOut">
               <a:rPr lang="en-US" smtClean="0"/>
-              <a:t>6/18/2026</a:t>
+              <a:t>6/22/2026</a:t>
             </a:fld>
             <a:endParaRPr lang="en-US"/>
           </a:p>
@@ -2449,6 +2462,7 @@
   <p:clrMapOvr>
     <a:masterClrMapping/>
   </p:clrMapOvr>
+  <p:transition spd="med"/>
 </p:sldLayout>
 </file>
 
@@ -2520,7 +2534,7 @@
           <a:p>
             <a:fld id="{701F44BB-14DF-43E9-8FF7-086183F60DE1}" type="datetimeFigureOut">
               <a:rPr lang="en-US" smtClean="0"/>
-              <a:t>6/18/2026</a:t>
+              <a:t>6/22/2026</a:t>
             </a:fld>
             <a:endParaRPr lang="en-US"/>
           </a:p>
@@ -2590,6 +2604,7 @@
   <p:clrMapOvr>
     <a:masterClrMapping/>
   </p:clrMapOvr>
+  <p:transition spd="med"/>
 </p:sldLayout>
 </file>
 
@@ -2633,7 +2648,7 @@
           <a:p>
             <a:fld id="{701F44BB-14DF-43E9-8FF7-086183F60DE1}" type="datetimeFigureOut">
               <a:rPr lang="en-US" smtClean="0"/>
-              <a:t>6/18/2026</a:t>
+              <a:t>6/22/2026</a:t>
             </a:fld>
             <a:endParaRPr lang="en-US"/>
           </a:p>
@@ -2703,6 +2718,7 @@
   <p:clrMapOvr>
     <a:masterClrMapping/>
   </p:clrMapOvr>
+  <p:transition spd="med"/>
 </p:sldLayout>
 </file>
 
@@ -2944,7 +2960,7 @@
           <a:p>
             <a:fld id="{701F44BB-14DF-43E9-8FF7-086183F60DE1}" type="datetimeFigureOut">
               <a:rPr lang="en-US" smtClean="0"/>
-              <a:t>6/18/2026</a:t>
+              <a:t>6/22/2026</a:t>
             </a:fld>
             <a:endParaRPr lang="en-US"/>
           </a:p>
@@ -3014,6 +3030,7 @@
   <p:clrMapOvr>
     <a:masterClrMapping/>
   </p:clrMapOvr>
+  <p:transition spd="med"/>
 </p:sldLayout>
 </file>
 
@@ -3232,7 +3249,7 @@
           <a:p>
             <a:fld id="{701F44BB-14DF-43E9-8FF7-086183F60DE1}" type="datetimeFigureOut">
               <a:rPr lang="en-US" smtClean="0"/>
-              <a:t>6/18/2026</a:t>
+              <a:t>6/22/2026</a:t>
             </a:fld>
             <a:endParaRPr lang="en-US"/>
           </a:p>
@@ -3302,6 +3319,7 @@
   <p:clrMapOvr>
     <a:masterClrMapping/>
   </p:clrMapOvr>
+  <p:transition spd="med"/>
 </p:sldLayout>
 </file>
 
@@ -3473,7 +3491,7 @@
           <a:p>
             <a:fld id="{701F44BB-14DF-43E9-8FF7-086183F60DE1}" type="datetimeFigureOut">
               <a:rPr lang="en-US" smtClean="0"/>
-              <a:t>6/18/2026</a:t>
+              <a:t>6/22/2026</a:t>
             </a:fld>
             <a:endParaRPr lang="en-US"/>
           </a:p>
@@ -3592,6 +3610,7 @@
     <p:sldLayoutId id="2147483660" r:id="rId12"/>
     <p:sldLayoutId id="2147483661" r:id="rId13"/>
   </p:sldLayoutIdLst>
+  <p:transition spd="med"/>
   <p:txStyles>
     <p:titleStyle>
       <a:lvl1pPr algn="l" defTabSz="914400" rtl="0" eaLnBrk="1" latinLnBrk="0" hangingPunct="1">
@@ -3906,8 +3925,8 @@
         </p:nvSpPr>
         <p:spPr>
           <a:xfrm>
-            <a:off x="818334" y="1918624"/>
-            <a:ext cx="6743753" cy="1341906"/>
+            <a:off x="742135" y="1232483"/>
+            <a:ext cx="4866185" cy="2931095"/>
           </a:xfrm>
           <a:prstGeom prst="rect">
             <a:avLst/>
@@ -3947,7 +3966,7 @@
               </a:spcBef>
             </a:pPr>
             <a:r>
-              <a:rPr lang="en-US" sz="4400">
+              <a:rPr lang="en-US" sz="3600" b="1" dirty="0">
                 <a:solidFill>
                   <a:schemeClr val="bg1"/>
                 </a:solidFill>
@@ -3956,10 +3975,22 @@
                 <a:cs typeface="Proxima Nova Medium"/>
                 <a:sym typeface="Proxima Nova Medium"/>
               </a:rPr>
-              <a:t>Meritage 3 Seater Sofa </a:t>
-            </a:r>
-            <a:r>
-              <a:rPr lang="en-US" sz="4400" dirty="0">
+              <a:t>Standard Works: </a:t>
+            </a:r>
+          </a:p>
+          <a:p>
+            <a:pPr marL="571500" indent="-571500" defTabSz="177800" hangingPunct="0">
+              <a:lnSpc>
+                <a:spcPct val="90000"/>
+              </a:lnSpc>
+              <a:spcBef>
+                <a:spcPts val="600"/>
+              </a:spcBef>
+              <a:buFontTx/>
+              <a:buChar char="-"/>
+            </a:pPr>
+            <a:r>
+              <a:rPr lang="en-US" sz="3600" dirty="0">
                 <a:solidFill>
                   <a:schemeClr val="bg1"/>
                 </a:solidFill>
@@ -3968,8 +3999,75 @@
                 <a:cs typeface="Proxima Nova Medium"/>
                 <a:sym typeface="Proxima Nova Medium"/>
               </a:rPr>
-              <a:t>Standard Work </a:t>
-            </a:r>
+              <a:t>Swivel Chair </a:t>
+            </a:r>
+          </a:p>
+          <a:p>
+            <a:pPr marL="571500" indent="-571500" defTabSz="177800" hangingPunct="0">
+              <a:lnSpc>
+                <a:spcPct val="90000"/>
+              </a:lnSpc>
+              <a:spcBef>
+                <a:spcPts val="600"/>
+              </a:spcBef>
+              <a:buFontTx/>
+              <a:buChar char="-"/>
+            </a:pPr>
+            <a:r>
+              <a:rPr lang="en-US" sz="3600" dirty="0">
+                <a:solidFill>
+                  <a:schemeClr val="bg1"/>
+                </a:solidFill>
+                <a:latin typeface="+mj-lt"/>
+                <a:ea typeface="Proxima Nova Medium"/>
+                <a:cs typeface="Proxima Nova Medium"/>
+                <a:sym typeface="Proxima Nova Medium"/>
+              </a:rPr>
+              <a:t>Meritage 3 seater </a:t>
+            </a:r>
+          </a:p>
+          <a:p>
+            <a:pPr marL="571500" indent="-571500" defTabSz="177800" hangingPunct="0">
+              <a:lnSpc>
+                <a:spcPct val="90000"/>
+              </a:lnSpc>
+              <a:spcBef>
+                <a:spcPts val="600"/>
+              </a:spcBef>
+              <a:buFontTx/>
+              <a:buChar char="-"/>
+            </a:pPr>
+            <a:r>
+              <a:rPr lang="en-US" sz="3600" dirty="0">
+                <a:solidFill>
+                  <a:schemeClr val="bg1"/>
+                </a:solidFill>
+                <a:latin typeface="+mj-lt"/>
+                <a:ea typeface="Proxima Nova Medium"/>
+                <a:cs typeface="Proxima Nova Medium"/>
+                <a:sym typeface="Proxima Nova Medium"/>
+              </a:rPr>
+              <a:t>Sola Sofa </a:t>
+            </a:r>
+          </a:p>
+          <a:p>
+            <a:pPr defTabSz="177800" hangingPunct="0">
+              <a:lnSpc>
+                <a:spcPct val="90000"/>
+              </a:lnSpc>
+              <a:spcBef>
+                <a:spcPts val="600"/>
+              </a:spcBef>
+            </a:pPr>
+            <a:endParaRPr lang="en-US" sz="3600" b="1" dirty="0">
+              <a:solidFill>
+                <a:schemeClr val="bg1"/>
+              </a:solidFill>
+              <a:latin typeface="+mj-lt"/>
+              <a:ea typeface="Proxima Nova Medium"/>
+              <a:cs typeface="Proxima Nova Medium"/>
+              <a:sym typeface="Proxima Nova Medium"/>
+            </a:endParaRPr>
           </a:p>
         </p:txBody>
       </p:sp>
@@ -3987,8 +4085,8 @@
         </p:nvSpPr>
         <p:spPr>
           <a:xfrm>
-            <a:off x="951685" y="3432307"/>
-            <a:ext cx="2681287" cy="490904"/>
+            <a:off x="951685" y="4135878"/>
+            <a:ext cx="3163115" cy="754053"/>
           </a:xfrm>
           <a:prstGeom prst="rect">
             <a:avLst/>
@@ -4028,7 +4126,7 @@
               </a:spcBef>
             </a:pPr>
             <a:r>
-              <a:rPr lang="en-US" sz="1050" b="1">
+              <a:rPr lang="en-US" sz="2000" b="1" dirty="0">
                 <a:solidFill>
                   <a:schemeClr val="bg1"/>
                 </a:solidFill>
@@ -4036,7 +4134,7 @@
               </a:rPr>
               <a:t>Douglas O'Keefe</a:t>
             </a:r>
-            <a:endParaRPr lang="en-US" b="1">
+            <a:endParaRPr lang="en-US" sz="2000" b="1" dirty="0">
               <a:solidFill>
                 <a:schemeClr val="bg1"/>
               </a:solidFill>
@@ -4055,7 +4153,7 @@
               </a:spcBef>
             </a:pPr>
             <a:r>
-              <a:rPr lang="en-US" sz="1050" b="1">
+              <a:rPr lang="en-US" sz="2000" b="1" dirty="0">
                 <a:solidFill>
                   <a:schemeClr val="bg1"/>
                 </a:solidFill>
@@ -4063,7 +4161,7 @@
               </a:rPr>
               <a:t>06/18/2026</a:t>
             </a:r>
-            <a:endParaRPr lang="en-US" sz="1450" b="1" dirty="0">
+            <a:endParaRPr lang="en-US" sz="2000" b="1" dirty="0">
               <a:solidFill>
                 <a:schemeClr val="bg1"/>
               </a:solidFill>
@@ -4074,47 +4172,6 @@
           </a:p>
         </p:txBody>
       </p:sp>
-      <p:cxnSp>
-        <p:nvCxnSpPr>
-          <p:cNvPr id="5" name="Straight Connector 4">
-            <a:extLst>
-              <a:ext uri="{FF2B5EF4-FFF2-40B4-BE49-F238E27FC236}">
-                <a16:creationId xmlns:a16="http://schemas.microsoft.com/office/drawing/2014/main" id="{2DA8FB91-CE9C-32F3-F900-6A26DC906367}"/>
-              </a:ext>
-            </a:extLst>
-          </p:cNvPr>
-          <p:cNvCxnSpPr/>
-          <p:nvPr/>
-        </p:nvCxnSpPr>
-        <p:spPr>
-          <a:xfrm>
-            <a:off x="951685" y="3105805"/>
-            <a:ext cx="2392326" cy="0"/>
-          </a:xfrm>
-          <a:prstGeom prst="line">
-            <a:avLst/>
-          </a:prstGeom>
-          <a:ln>
-            <a:solidFill>
-              <a:srgbClr val="FF0000"/>
-            </a:solidFill>
-          </a:ln>
-        </p:spPr>
-        <p:style>
-          <a:lnRef idx="1">
-            <a:schemeClr val="accent4"/>
-          </a:lnRef>
-          <a:fillRef idx="0">
-            <a:schemeClr val="accent4"/>
-          </a:fillRef>
-          <a:effectRef idx="0">
-            <a:schemeClr val="accent4"/>
-          </a:effectRef>
-          <a:fontRef idx="minor">
-            <a:schemeClr val="tx1"/>
-          </a:fontRef>
-        </p:style>
-      </p:cxnSp>
     </p:spTree>
     <p:extLst>
       <p:ext uri="{BB962C8B-B14F-4D97-AF65-F5344CB8AC3E}">
@@ -4126,6 +4183,679 @@
     <a:masterClrMapping/>
   </p:clrMapOvr>
   <p:transition spd="med"/>
+</p:sld>
+</file>
+
+<file path=ppt/slides/slide10.xml><?xml version="1.0" encoding="utf-8"?>
+<p:sld xmlns:a="http://schemas.openxmlformats.org/drawingml/2006/main" xmlns:p="http://schemas.openxmlformats.org/presentationml/2006/main" xmlns:r="http://schemas.openxmlformats.org/officeDocument/2006/relationships">
+  <p:cSld>
+    <p:spTree>
+      <p:nvGrpSpPr>
+        <p:cNvPr id="1" name=""/>
+        <p:cNvGrpSpPr/>
+        <p:nvPr/>
+      </p:nvGrpSpPr>
+      <p:grpSpPr/>
+      <p:sp>
+        <p:nvSpPr>
+          <p:cNvPr id="2" name="Title 1"/>
+          <p:cNvSpPr>
+            <a:spLocks noGrp="1"/>
+          </p:cNvSpPr>
+          <p:nvPr>
+            <p:ph type="title"/>
+          </p:nvPr>
+        </p:nvSpPr>
+        <p:spPr/>
+        <p:txBody>
+          <a:bodyPr/>
+          <a:lstStyle/>
+          <a:p>
+            <a:r>
+              <a:t>First Step to Pre-Assembly: Fix the Connector BOM</a:t>
+            </a:r>
+          </a:p>
+        </p:txBody>
+      </p:sp>
+      <p:sp>
+        <p:nvSpPr>
+          <p:cNvPr id="3" name="TextBox 2"/>
+          <p:cNvSpPr txBox="1"/>
+          <p:nvPr/>
+        </p:nvSpPr>
+        <p:spPr>
+          <a:xfrm>
+            <a:off x="1024128" y="1508760"/>
+            <a:ext cx="10149840" cy="914400"/>
+          </a:xfrm>
+          <a:prstGeom prst="rect">
+            <a:avLst/>
+          </a:prstGeom>
+          <a:noFill/>
+        </p:spPr>
+        <p:txBody>
+          <a:bodyPr wrap="square" lIns="45720" rIns="45720" tIns="0" bIns="0">
+            <a:spAutoFit/>
+          </a:bodyPr>
+          <a:lstStyle/>
+          <a:p>
+            <a:pPr algn="l">
+              <a:lnSpc>
+                <a:spcPct val="105000"/>
+              </a:lnSpc>
+            </a:pPr>
+            <a:r>
+              <a:rPr sz="1500" b="1">
+                <a:solidFill>
+                  <a:srgbClr val="262626"/>
+                </a:solidFill>
+                <a:latin typeface="Calibri"/>
+              </a:rPr>
+              <a:t>The first step to getting connectors pre-assembled in Vietnam: </a:t>
+            </a:r>
+            <a:r>
+              <a:rPr sz="1500" b="0">
+                <a:solidFill>
+                  <a:srgbClr val="262626"/>
+                </a:solidFill>
+                <a:latin typeface="Calibri"/>
+              </a:rPr>
+              <a:t>give each connector its own part number in the BOM.</a:t>
+            </a:r>
+          </a:p>
+          <a:p>
+            <a:pPr>
+              <a:lnSpc>
+                <a:spcPct val="105000"/>
+              </a:lnSpc>
+              <a:spcBef>
+                <a:spcPts val="600"/>
+              </a:spcBef>
+            </a:pPr>
+            <a:r>
+              <a:rPr sz="1400" b="0">
+                <a:solidFill>
+                  <a:srgbClr val="262626"/>
+                </a:solidFill>
+                <a:latin typeface="Calibri"/>
+              </a:rPr>
+              <a:t>Today the Meritage 3-Seater BOM lists </a:t>
+            </a:r>
+            <a:r>
+              <a:rPr sz="1400" b="1">
+                <a:solidFill>
+                  <a:srgbClr val="843C0C"/>
+                </a:solidFill>
+                <a:latin typeface="Calibri"/>
+              </a:rPr>
+              <a:t>2 connector types — but there are really 3.</a:t>
+            </a:r>
+          </a:p>
+        </p:txBody>
+      </p:sp>
+      <p:graphicFrame>
+        <p:nvGraphicFramePr>
+          <p:cNvPr id="4" name="Table 3"/>
+          <p:cNvGraphicFramePr>
+            <a:graphicFrameLocks noGrp="1"/>
+          </p:cNvGraphicFramePr>
+          <p:nvPr/>
+        </p:nvGraphicFramePr>
+        <p:xfrm>
+          <a:off x="1024128" y="2743200"/>
+          <a:ext cx="8595360" cy="1554480"/>
+        </p:xfrm>
+        <a:graphic>
+          <a:graphicData uri="http://schemas.openxmlformats.org/drawingml/2006/table">
+            <a:tbl>
+              <a:tblPr firstRow="1" bandRow="1">
+                <a:tableStyleId>{5C22544A-7EE6-4342-B048-85BDC9FD1C3A}</a:tableStyleId>
+              </a:tblPr>
+              <a:tblGrid>
+                <a:gridCol w="2468880"/>
+                <a:gridCol w="3017520"/>
+                <a:gridCol w="2194560"/>
+                <a:gridCol w="914400"/>
+              </a:tblGrid>
+              <a:tr h="388620">
+                <a:tc>
+                  <a:txBody>
+                    <a:bodyPr/>
+                    <a:lstStyle/>
+                    <a:p>
+                      <a:r>
+                        <a:rPr sz="1200" b="1">
+                          <a:solidFill>
+                            <a:srgbClr val="FFFFFF"/>
+                          </a:solidFill>
+                          <a:latin typeface="Calibri"/>
+                        </a:rPr>
+                        <a:t>Location</a:t>
+                      </a:r>
+                    </a:p>
+                  </a:txBody>
+                  <a:tcPr>
+                    <a:solidFill>
+                      <a:srgbClr val="1F3864"/>
+                    </a:solidFill>
+                  </a:tcPr>
+                </a:tc>
+                <a:tc>
+                  <a:txBody>
+                    <a:bodyPr/>
+                    <a:lstStyle/>
+                    <a:p>
+                      <a:r>
+                        <a:rPr sz="1200" b="1">
+                          <a:solidFill>
+                            <a:srgbClr val="FFFFFF"/>
+                          </a:solidFill>
+                          <a:latin typeface="Calibri"/>
+                        </a:rPr>
+                        <a:t>Configuration</a:t>
+                      </a:r>
+                    </a:p>
+                  </a:txBody>
+                  <a:tcPr>
+                    <a:solidFill>
+                      <a:srgbClr val="1F3864"/>
+                    </a:solidFill>
+                  </a:tcPr>
+                </a:tc>
+                <a:tc>
+                  <a:txBody>
+                    <a:bodyPr/>
+                    <a:lstStyle/>
+                    <a:p>
+                      <a:r>
+                        <a:rPr sz="1200" b="1">
+                          <a:solidFill>
+                            <a:srgbClr val="FFFFFF"/>
+                          </a:solidFill>
+                          <a:latin typeface="Calibri"/>
+                        </a:rPr>
+                        <a:t>Part number</a:t>
+                      </a:r>
+                    </a:p>
+                  </a:txBody>
+                  <a:tcPr>
+                    <a:solidFill>
+                      <a:srgbClr val="1F3864"/>
+                    </a:solidFill>
+                  </a:tcPr>
+                </a:tc>
+                <a:tc>
+                  <a:txBody>
+                    <a:bodyPr/>
+                    <a:lstStyle/>
+                    <a:p>
+                      <a:pPr algn="ctr"/>
+                      <a:r>
+                        <a:rPr sz="1200" b="1">
+                          <a:solidFill>
+                            <a:srgbClr val="FFFFFF"/>
+                          </a:solidFill>
+                          <a:latin typeface="Calibri"/>
+                        </a:rPr>
+                        <a:t>Qty</a:t>
+                      </a:r>
+                    </a:p>
+                  </a:txBody>
+                  <a:tcPr>
+                    <a:solidFill>
+                      <a:srgbClr val="1F3864"/>
+                    </a:solidFill>
+                  </a:tcPr>
+                </a:tc>
+              </a:tr>
+              <a:tr h="388620">
+                <a:tc>
+                  <a:txBody>
+                    <a:bodyPr/>
+                    <a:lstStyle/>
+                    <a:p>
+                      <a:r>
+                        <a:rPr sz="1200" b="0">
+                          <a:solidFill>
+                            <a:srgbClr val="262626"/>
+                          </a:solidFill>
+                          <a:latin typeface="Calibri"/>
+                        </a:rPr>
+                        <a:t>Front of frame</a:t>
+                      </a:r>
+                    </a:p>
+                  </a:txBody>
+                  <a:tcPr>
+                    <a:solidFill>
+                      <a:srgbClr val="FFFFFF"/>
+                    </a:solidFill>
+                  </a:tcPr>
+                </a:tc>
+                <a:tc>
+                  <a:txBody>
+                    <a:bodyPr/>
+                    <a:lstStyle/>
+                    <a:p>
+                      <a:r>
+                        <a:rPr sz="1200" b="0">
+                          <a:solidFill>
+                            <a:srgbClr val="262626"/>
+                          </a:solidFill>
+                          <a:latin typeface="Calibri"/>
+                        </a:rPr>
+                        <a:t>Type 1 (same both sides)</a:t>
+                      </a:r>
+                    </a:p>
+                  </a:txBody>
+                  <a:tcPr>
+                    <a:solidFill>
+                      <a:srgbClr val="FFFFFF"/>
+                    </a:solidFill>
+                  </a:tcPr>
+                </a:tc>
+                <a:tc>
+                  <a:txBody>
+                    <a:bodyPr/>
+                    <a:lstStyle/>
+                    <a:p>
+                      <a:r>
+                        <a:rPr sz="1200" b="1">
+                          <a:solidFill>
+                            <a:srgbClr val="1F3864"/>
+                          </a:solidFill>
+                          <a:latin typeface="Calibri"/>
+                        </a:rPr>
+                        <a:t>1015301</a:t>
+                      </a:r>
+                    </a:p>
+                  </a:txBody>
+                  <a:tcPr>
+                    <a:solidFill>
+                      <a:srgbClr val="FFFFFF"/>
+                    </a:solidFill>
+                  </a:tcPr>
+                </a:tc>
+                <a:tc>
+                  <a:txBody>
+                    <a:bodyPr/>
+                    <a:lstStyle/>
+                    <a:p>
+                      <a:pPr algn="ctr"/>
+                      <a:r>
+                        <a:rPr sz="1200" b="0">
+                          <a:solidFill>
+                            <a:srgbClr val="262626"/>
+                          </a:solidFill>
+                          <a:latin typeface="Calibri"/>
+                        </a:rPr>
+                        <a:t>2</a:t>
+                      </a:r>
+                    </a:p>
+                  </a:txBody>
+                  <a:tcPr>
+                    <a:solidFill>
+                      <a:srgbClr val="FFFFFF"/>
+                    </a:solidFill>
+                  </a:tcPr>
+                </a:tc>
+              </a:tr>
+              <a:tr h="388620">
+                <a:tc>
+                  <a:txBody>
+                    <a:bodyPr/>
+                    <a:lstStyle/>
+                    <a:p>
+                      <a:r>
+                        <a:rPr sz="1200" b="0">
+                          <a:solidFill>
+                            <a:srgbClr val="262626"/>
+                          </a:solidFill>
+                          <a:latin typeface="Calibri"/>
+                        </a:rPr>
+                        <a:t>Back – left</a:t>
+                      </a:r>
+                    </a:p>
+                  </a:txBody>
+                  <a:tcPr>
+                    <a:solidFill>
+                      <a:srgbClr val="FFFFFF"/>
+                    </a:solidFill>
+                  </a:tcPr>
+                </a:tc>
+                <a:tc>
+                  <a:txBody>
+                    <a:bodyPr/>
+                    <a:lstStyle/>
+                    <a:p>
+                      <a:r>
+                        <a:rPr sz="1200" b="0">
+                          <a:solidFill>
+                            <a:srgbClr val="262626"/>
+                          </a:solidFill>
+                          <a:latin typeface="Calibri"/>
+                        </a:rPr>
+                        <a:t>Left configuration</a:t>
+                      </a:r>
+                    </a:p>
+                  </a:txBody>
+                  <a:tcPr>
+                    <a:solidFill>
+                      <a:srgbClr val="FFFFFF"/>
+                    </a:solidFill>
+                  </a:tcPr>
+                </a:tc>
+                <a:tc>
+                  <a:txBody>
+                    <a:bodyPr/>
+                    <a:lstStyle/>
+                    <a:p>
+                      <a:r>
+                        <a:rPr sz="1200" b="1">
+                          <a:solidFill>
+                            <a:srgbClr val="1F3864"/>
+                          </a:solidFill>
+                          <a:latin typeface="Calibri"/>
+                        </a:rPr>
+                        <a:t>1015302</a:t>
+                      </a:r>
+                    </a:p>
+                  </a:txBody>
+                  <a:tcPr>
+                    <a:solidFill>
+                      <a:srgbClr val="FFFFFF"/>
+                    </a:solidFill>
+                  </a:tcPr>
+                </a:tc>
+                <a:tc>
+                  <a:txBody>
+                    <a:bodyPr/>
+                    <a:lstStyle/>
+                    <a:p>
+                      <a:pPr algn="ctr"/>
+                      <a:r>
+                        <a:rPr sz="1200" b="0">
+                          <a:solidFill>
+                            <a:srgbClr val="262626"/>
+                          </a:solidFill>
+                          <a:latin typeface="Calibri"/>
+                        </a:rPr>
+                        <a:t>1</a:t>
+                      </a:r>
+                    </a:p>
+                  </a:txBody>
+                  <a:tcPr>
+                    <a:solidFill>
+                      <a:srgbClr val="FFFFFF"/>
+                    </a:solidFill>
+                  </a:tcPr>
+                </a:tc>
+              </a:tr>
+              <a:tr h="388620">
+                <a:tc>
+                  <a:txBody>
+                    <a:bodyPr/>
+                    <a:lstStyle/>
+                    <a:p>
+                      <a:r>
+                        <a:rPr sz="1200" b="0">
+                          <a:solidFill>
+                            <a:srgbClr val="262626"/>
+                          </a:solidFill>
+                          <a:latin typeface="Calibri"/>
+                        </a:rPr>
+                        <a:t>Back – right</a:t>
+                      </a:r>
+                    </a:p>
+                  </a:txBody>
+                  <a:tcPr>
+                    <a:solidFill>
+                      <a:srgbClr val="FFFFFF"/>
+                    </a:solidFill>
+                  </a:tcPr>
+                </a:tc>
+                <a:tc>
+                  <a:txBody>
+                    <a:bodyPr/>
+                    <a:lstStyle/>
+                    <a:p>
+                      <a:r>
+                        <a:rPr sz="1200" b="0">
+                          <a:solidFill>
+                            <a:srgbClr val="262626"/>
+                          </a:solidFill>
+                          <a:latin typeface="Calibri"/>
+                        </a:rPr>
+                        <a:t>Right configuration</a:t>
+                      </a:r>
+                    </a:p>
+                  </a:txBody>
+                  <a:tcPr>
+                    <a:solidFill>
+                      <a:srgbClr val="FFFFFF"/>
+                    </a:solidFill>
+                  </a:tcPr>
+                </a:tc>
+                <a:tc>
+                  <a:txBody>
+                    <a:bodyPr/>
+                    <a:lstStyle/>
+                    <a:p>
+                      <a:r>
+                        <a:rPr sz="1200" b="1">
+                          <a:solidFill>
+                            <a:srgbClr val="1F3864"/>
+                          </a:solidFill>
+                          <a:latin typeface="Calibri"/>
+                        </a:rPr>
+                        <a:t>1016592</a:t>
+                      </a:r>
+                    </a:p>
+                  </a:txBody>
+                  <a:tcPr>
+                    <a:solidFill>
+                      <a:srgbClr val="FFFFFF"/>
+                    </a:solidFill>
+                  </a:tcPr>
+                </a:tc>
+                <a:tc>
+                  <a:txBody>
+                    <a:bodyPr/>
+                    <a:lstStyle/>
+                    <a:p>
+                      <a:pPr algn="ctr"/>
+                      <a:r>
+                        <a:rPr sz="1200" b="0">
+                          <a:solidFill>
+                            <a:srgbClr val="262626"/>
+                          </a:solidFill>
+                          <a:latin typeface="Calibri"/>
+                        </a:rPr>
+                        <a:t>1</a:t>
+                      </a:r>
+                    </a:p>
+                  </a:txBody>
+                  <a:tcPr>
+                    <a:solidFill>
+                      <a:srgbClr val="FFFFFF"/>
+                    </a:solidFill>
+                  </a:tcPr>
+                </a:tc>
+              </a:tr>
+            </a:tbl>
+          </a:graphicData>
+        </a:graphic>
+      </p:graphicFrame>
+      <p:sp>
+        <p:nvSpPr>
+          <p:cNvPr id="5" name="Rectangle 4"/>
+          <p:cNvSpPr/>
+          <p:nvPr/>
+        </p:nvSpPr>
+        <p:spPr>
+          <a:xfrm>
+            <a:off x="1024128" y="4617720"/>
+            <a:ext cx="10149840" cy="1143000"/>
+          </a:xfrm>
+          <a:prstGeom prst="rect">
+            <a:avLst/>
+          </a:prstGeom>
+          <a:solidFill>
+            <a:srgbClr val="FBF3E0"/>
+          </a:solidFill>
+          <a:ln w="9525">
+            <a:solidFill>
+              <a:srgbClr val="E6CFA0"/>
+            </a:solidFill>
+          </a:ln>
+          <a:effectLst/>
+        </p:spPr>
+        <p:style>
+          <a:lnRef idx="1">
+            <a:schemeClr val="accent1"/>
+          </a:lnRef>
+          <a:fillRef idx="3">
+            <a:schemeClr val="accent1"/>
+          </a:fillRef>
+          <a:effectRef idx="2">
+            <a:schemeClr val="accent1"/>
+          </a:effectRef>
+          <a:fontRef idx="minor">
+            <a:schemeClr val="lt1"/>
+          </a:fontRef>
+        </p:style>
+        <p:txBody>
+          <a:bodyPr rtlCol="0" anchor="ctr"/>
+          <a:lstStyle/>
+          <a:p>
+            <a:pPr algn="ctr"/>
+          </a:p>
+        </p:txBody>
+      </p:sp>
+      <p:sp>
+        <p:nvSpPr>
+          <p:cNvPr id="6" name="Rectangle 5"/>
+          <p:cNvSpPr/>
+          <p:nvPr/>
+        </p:nvSpPr>
+        <p:spPr>
+          <a:xfrm>
+            <a:off x="1024128" y="4617720"/>
+            <a:ext cx="73152" cy="1143000"/>
+          </a:xfrm>
+          <a:prstGeom prst="rect">
+            <a:avLst/>
+          </a:prstGeom>
+          <a:solidFill>
+            <a:srgbClr val="BF8F00"/>
+          </a:solidFill>
+          <a:ln>
+            <a:noFill/>
+          </a:ln>
+          <a:effectLst/>
+        </p:spPr>
+        <p:style>
+          <a:lnRef idx="1">
+            <a:schemeClr val="accent1"/>
+          </a:lnRef>
+          <a:fillRef idx="3">
+            <a:schemeClr val="accent1"/>
+          </a:fillRef>
+          <a:effectRef idx="2">
+            <a:schemeClr val="accent1"/>
+          </a:effectRef>
+          <a:fontRef idx="minor">
+            <a:schemeClr val="lt1"/>
+          </a:fontRef>
+        </p:style>
+        <p:txBody>
+          <a:bodyPr rtlCol="0" anchor="ctr"/>
+          <a:lstStyle/>
+          <a:p>
+            <a:pPr algn="ctr"/>
+          </a:p>
+        </p:txBody>
+      </p:sp>
+      <p:sp>
+        <p:nvSpPr>
+          <p:cNvPr id="7" name="TextBox 6"/>
+          <p:cNvSpPr txBox="1"/>
+          <p:nvPr/>
+        </p:nvSpPr>
+        <p:spPr>
+          <a:xfrm>
+            <a:off x="1280160" y="4773168"/>
+            <a:ext cx="9692640" cy="914400"/>
+          </a:xfrm>
+          <a:prstGeom prst="rect">
+            <a:avLst/>
+          </a:prstGeom>
+          <a:noFill/>
+        </p:spPr>
+        <p:txBody>
+          <a:bodyPr wrap="square" lIns="45720" rIns="45720" tIns="0" bIns="0">
+            <a:spAutoFit/>
+          </a:bodyPr>
+          <a:lstStyle/>
+          <a:p>
+            <a:pPr algn="l">
+              <a:lnSpc>
+                <a:spcPct val="105000"/>
+              </a:lnSpc>
+            </a:pPr>
+            <a:r>
+              <a:rPr sz="1350" b="1">
+                <a:solidFill>
+                  <a:srgbClr val="1F3864"/>
+                </a:solidFill>
+                <a:latin typeface="Calibri"/>
+              </a:rPr>
+              <a:t>The gap.  </a:t>
+            </a:r>
+            <a:r>
+              <a:rPr sz="1350" b="0">
+                <a:solidFill>
+                  <a:srgbClr val="262626"/>
+                </a:solidFill>
+                <a:latin typeface="Calibri"/>
+              </a:rPr>
+              <a:t>The drawings already show all three connectors correctly — </a:t>
+            </a:r>
+            <a:r>
+              <a:rPr sz="1350" b="0">
+                <a:solidFill>
+                  <a:srgbClr val="262626"/>
+                </a:solidFill>
+                <a:latin typeface="Calibri"/>
+              </a:rPr>
+              <a:t>1015301 (×2) on the front, and 1015302 + 1016592 on the back — but the BOM does not.</a:t>
+            </a:r>
+          </a:p>
+          <a:p>
+            <a:pPr>
+              <a:lnSpc>
+                <a:spcPct val="105000"/>
+              </a:lnSpc>
+              <a:spcBef>
+                <a:spcPts val="500"/>
+              </a:spcBef>
+            </a:pPr>
+            <a:r>
+              <a:rPr sz="1350" b="1">
+                <a:solidFill>
+                  <a:srgbClr val="23402C"/>
+                </a:solidFill>
+                <a:latin typeface="Calibri"/>
+              </a:rPr>
+              <a:t>Fix this drawing-to-BOM mismatch first; then every connector can arrive from Vietnam pre-assembled to the correct configuration.</a:t>
+            </a:r>
+          </a:p>
+        </p:txBody>
+      </p:sp>
+    </p:spTree>
+  </p:cSld>
+  <p:clrMapOvr>
+    <a:masterClrMapping/>
+  </p:clrMapOvr>
 </p:sld>
 </file>
 
@@ -4162,7 +4892,12 @@
             <p:ph type="title"/>
           </p:nvPr>
         </p:nvSpPr>
-        <p:spPr/>
+        <p:spPr>
+          <a:xfrm>
+            <a:off x="5147310" y="602606"/>
+            <a:ext cx="1897380" cy="909701"/>
+          </a:xfrm>
+        </p:spPr>
         <p:txBody>
           <a:bodyPr/>
           <a:lstStyle/>
@@ -4197,7 +4932,13 @@
           <a:p>
             <a:r>
               <a:rPr lang="en-US" dirty="0"/>
-              <a:t>Review current state standard work procedure</a:t>
+              <a:t>Understand Sola process and labor time </a:t>
+            </a:r>
+          </a:p>
+          <a:p>
+            <a:r>
+              <a:rPr lang="en-US" dirty="0"/>
+              <a:t>Review current state standard work procedures</a:t>
             </a:r>
           </a:p>
           <a:p>
@@ -4280,7 +5021,7 @@
           <p:cNvPr id="2" name="Title 1">
             <a:extLst>
               <a:ext uri="{FF2B5EF4-FFF2-40B4-BE49-F238E27FC236}">
-                <a16:creationId xmlns:a16="http://schemas.microsoft.com/office/drawing/2014/main" id="{A6CA8A62-D0C7-6EBB-2F3B-10D1798206A0}"/>
+                <a16:creationId xmlns:a16="http://schemas.microsoft.com/office/drawing/2014/main" id="{78C8B300-BDBE-47D4-013A-987882CC7DDB}"/>
               </a:ext>
             </a:extLst>
           </p:cNvPr>
@@ -4298,7 +5039,19 @@
           <a:p>
             <a:r>
               <a:rPr lang="en-US" dirty="0"/>
-              <a:t>Key Takeaways</a:t>
+              <a:t>Key Takeaways: </a:t>
+            </a:r>
+            <a:r>
+              <a:rPr lang="en-US" dirty="0">
+                <a:solidFill>
+                  <a:schemeClr val="accent6"/>
+                </a:solidFill>
+              </a:rPr>
+              <a:t>Swivel</a:t>
+            </a:r>
+            <a:r>
+              <a:rPr lang="en-US" dirty="0"/>
+              <a:t>  </a:t>
             </a:r>
           </a:p>
         </p:txBody>
@@ -4308,7 +5061,7 @@
           <p:cNvPr id="3" name="Text Placeholder 2">
             <a:extLst>
               <a:ext uri="{FF2B5EF4-FFF2-40B4-BE49-F238E27FC236}">
-                <a16:creationId xmlns:a16="http://schemas.microsoft.com/office/drawing/2014/main" id="{81773628-9B98-D01A-F206-8718B5EC1E0F}"/>
+                <a16:creationId xmlns:a16="http://schemas.microsoft.com/office/drawing/2014/main" id="{C3E3A6C9-BA4D-F7CB-CE71-8BC1D680707F}"/>
               </a:ext>
             </a:extLst>
           </p:cNvPr>
@@ -4324,41 +5077,14 @@
           <a:bodyPr/>
           <a:lstStyle/>
           <a:p>
-            <a:r>
-              <a:rPr lang="en-US" dirty="0"/>
-              <a:t>Meritage 3 seater</a:t>
-            </a:r>
-            <a:r>
-              <a:rPr lang="en-US"/>
-              <a:t> Sofa assembly labor time: 254 min </a:t>
-            </a:r>
-          </a:p>
-          <a:p>
-            <a:r>
-              <a:rPr lang="en-US" dirty="0"/>
-              <a:t>Theoretical output based on cycle time (41.5 min), assuming parts are available from paint.</a:t>
-            </a:r>
-          </a:p>
-          <a:p>
-            <a:pPr lvl="1"/>
-            <a:r>
-              <a:rPr lang="en-US" dirty="0"/>
-              <a:t>~10 units per day (7 operators)</a:t>
-            </a:r>
-          </a:p>
-          <a:p>
-            <a:pPr lvl="1"/>
-            <a:r>
-              <a:rPr lang="en-US" dirty="0"/>
-              <a:t>Takt time required (demand of 10 units): 42 min</a:t>
-            </a:r>
+            <a:endParaRPr lang="en-US"/>
           </a:p>
         </p:txBody>
       </p:sp>
     </p:spTree>
     <p:extLst>
       <p:ext uri="{BB962C8B-B14F-4D97-AF65-F5344CB8AC3E}">
-        <p14:creationId xmlns:p14="http://schemas.microsoft.com/office/powerpoint/2010/main" val="3967448658"/>
+        <p14:creationId xmlns:p14="http://schemas.microsoft.com/office/powerpoint/2010/main" val="666012139"/>
       </p:ext>
     </p:extLst>
   </p:cSld>
@@ -4370,6 +5096,108 @@
 </file>
 
 <file path=ppt/slides/slide4.xml><?xml version="1.0" encoding="utf-8"?>
+<p:sld xmlns:a="http://schemas.openxmlformats.org/drawingml/2006/main" xmlns:r="http://schemas.openxmlformats.org/officeDocument/2006/relationships" xmlns:p="http://schemas.openxmlformats.org/presentationml/2006/main">
+  <p:cSld>
+    <p:spTree>
+      <p:nvGrpSpPr>
+        <p:cNvPr id="1" name="">
+          <a:extLst>
+            <a:ext uri="{FF2B5EF4-FFF2-40B4-BE49-F238E27FC236}">
+              <a16:creationId xmlns:a16="http://schemas.microsoft.com/office/drawing/2014/main" id="{97482F00-181D-F13D-022E-23C836AC6F9F}"/>
+            </a:ext>
+          </a:extLst>
+        </p:cNvPr>
+        <p:cNvGrpSpPr/>
+        <p:nvPr/>
+      </p:nvGrpSpPr>
+      <p:grpSpPr>
+        <a:xfrm>
+          <a:off x="0" y="0"/>
+          <a:ext cx="0" cy="0"/>
+          <a:chOff x="0" y="0"/>
+          <a:chExt cx="0" cy="0"/>
+        </a:xfrm>
+      </p:grpSpPr>
+      <p:sp>
+        <p:nvSpPr>
+          <p:cNvPr id="2" name="Title 1">
+            <a:extLst>
+              <a:ext uri="{FF2B5EF4-FFF2-40B4-BE49-F238E27FC236}">
+                <a16:creationId xmlns:a16="http://schemas.microsoft.com/office/drawing/2014/main" id="{E22D20E9-A6DB-B49B-BD5E-9388E836EE44}"/>
+              </a:ext>
+            </a:extLst>
+          </p:cNvPr>
+          <p:cNvSpPr>
+            <a:spLocks noGrp="1"/>
+          </p:cNvSpPr>
+          <p:nvPr>
+            <p:ph type="title"/>
+          </p:nvPr>
+        </p:nvSpPr>
+        <p:spPr/>
+        <p:txBody>
+          <a:bodyPr/>
+          <a:lstStyle/>
+          <a:p>
+            <a:r>
+              <a:rPr lang="en-US" dirty="0"/>
+              <a:t>Improvements: </a:t>
+            </a:r>
+            <a:r>
+              <a:rPr lang="en-US" dirty="0">
+                <a:solidFill>
+                  <a:schemeClr val="accent6"/>
+                </a:solidFill>
+              </a:rPr>
+              <a:t>Swivel</a:t>
+            </a:r>
+            <a:r>
+              <a:rPr lang="en-US" dirty="0"/>
+              <a:t>  </a:t>
+            </a:r>
+          </a:p>
+        </p:txBody>
+      </p:sp>
+      <p:sp>
+        <p:nvSpPr>
+          <p:cNvPr id="3" name="Text Placeholder 2">
+            <a:extLst>
+              <a:ext uri="{FF2B5EF4-FFF2-40B4-BE49-F238E27FC236}">
+                <a16:creationId xmlns:a16="http://schemas.microsoft.com/office/drawing/2014/main" id="{96BCA0E3-EAF9-76B8-E6DE-C9FDBC23E61C}"/>
+              </a:ext>
+            </a:extLst>
+          </p:cNvPr>
+          <p:cNvSpPr>
+            <a:spLocks noGrp="1"/>
+          </p:cNvSpPr>
+          <p:nvPr>
+            <p:ph type="body" idx="1"/>
+          </p:nvPr>
+        </p:nvSpPr>
+        <p:spPr/>
+        <p:txBody>
+          <a:bodyPr/>
+          <a:lstStyle/>
+          <a:p>
+            <a:endParaRPr lang="en-US" dirty="0"/>
+          </a:p>
+        </p:txBody>
+      </p:sp>
+    </p:spTree>
+    <p:extLst>
+      <p:ext uri="{BB962C8B-B14F-4D97-AF65-F5344CB8AC3E}">
+        <p14:creationId xmlns:p14="http://schemas.microsoft.com/office/powerpoint/2010/main" val="670356622"/>
+      </p:ext>
+    </p:extLst>
+  </p:cSld>
+  <p:clrMapOvr>
+    <a:masterClrMapping/>
+  </p:clrMapOvr>
+  <p:transition spd="med"/>
+</p:sld>
+</file>
+
+<file path=ppt/slides/slide5.xml><?xml version="1.0" encoding="utf-8"?>
 <p:sld xmlns:a="http://schemas.openxmlformats.org/drawingml/2006/main" xmlns:r="http://schemas.openxmlformats.org/officeDocument/2006/relationships" xmlns:p="http://schemas.openxmlformats.org/presentationml/2006/main">
   <p:cSld>
     <p:spTree>
@@ -4391,6 +5219,130 @@
           <p:cNvPr id="2" name="Title 1">
             <a:extLst>
               <a:ext uri="{FF2B5EF4-FFF2-40B4-BE49-F238E27FC236}">
+                <a16:creationId xmlns:a16="http://schemas.microsoft.com/office/drawing/2014/main" id="{A6CA8A62-D0C7-6EBB-2F3B-10D1798206A0}"/>
+              </a:ext>
+            </a:extLst>
+          </p:cNvPr>
+          <p:cNvSpPr>
+            <a:spLocks noGrp="1"/>
+          </p:cNvSpPr>
+          <p:nvPr>
+            <p:ph type="title"/>
+          </p:nvPr>
+        </p:nvSpPr>
+        <p:spPr>
+          <a:xfrm>
+            <a:off x="3295650" y="487745"/>
+            <a:ext cx="5600700" cy="909701"/>
+          </a:xfrm>
+        </p:spPr>
+        <p:txBody>
+          <a:bodyPr/>
+          <a:lstStyle/>
+          <a:p>
+            <a:r>
+              <a:rPr lang="en-US" dirty="0"/>
+              <a:t>Key Takeaways: </a:t>
+            </a:r>
+            <a:r>
+              <a:rPr lang="en-US" dirty="0">
+                <a:solidFill>
+                  <a:schemeClr val="accent1"/>
+                </a:solidFill>
+              </a:rPr>
+              <a:t>Meritage</a:t>
+            </a:r>
+            <a:r>
+              <a:rPr lang="en-US" dirty="0"/>
+              <a:t> </a:t>
+            </a:r>
+          </a:p>
+        </p:txBody>
+      </p:sp>
+      <p:sp>
+        <p:nvSpPr>
+          <p:cNvPr id="3" name="Text Placeholder 2">
+            <a:extLst>
+              <a:ext uri="{FF2B5EF4-FFF2-40B4-BE49-F238E27FC236}">
+                <a16:creationId xmlns:a16="http://schemas.microsoft.com/office/drawing/2014/main" id="{81773628-9B98-D01A-F206-8718B5EC1E0F}"/>
+              </a:ext>
+            </a:extLst>
+          </p:cNvPr>
+          <p:cNvSpPr>
+            <a:spLocks noGrp="1"/>
+          </p:cNvSpPr>
+          <p:nvPr>
+            <p:ph type="body" idx="1"/>
+          </p:nvPr>
+        </p:nvSpPr>
+        <p:spPr/>
+        <p:txBody>
+          <a:bodyPr/>
+          <a:lstStyle/>
+          <a:p>
+            <a:r>
+              <a:rPr lang="en-US" dirty="0"/>
+              <a:t>Meritage 3-seater Sofa assembly labor time: 254 min </a:t>
+            </a:r>
+          </a:p>
+          <a:p>
+            <a:r>
+              <a:rPr lang="en-US" dirty="0"/>
+              <a:t>Theoretical output based on cycle time (41.5 min), assuming parts are available from paint.</a:t>
+            </a:r>
+          </a:p>
+          <a:p>
+            <a:pPr lvl="1"/>
+            <a:r>
+              <a:rPr lang="en-US" dirty="0"/>
+              <a:t>~10 units per day (7 operators)</a:t>
+            </a:r>
+          </a:p>
+          <a:p>
+            <a:pPr lvl="1"/>
+            <a:r>
+              <a:rPr lang="en-US" dirty="0"/>
+              <a:t>Takt time required (demand of 10 units): 42 min</a:t>
+            </a:r>
+          </a:p>
+        </p:txBody>
+      </p:sp>
+    </p:spTree>
+    <p:extLst>
+      <p:ext uri="{BB962C8B-B14F-4D97-AF65-F5344CB8AC3E}">
+        <p14:creationId xmlns:p14="http://schemas.microsoft.com/office/powerpoint/2010/main" val="3967448658"/>
+      </p:ext>
+    </p:extLst>
+  </p:cSld>
+  <p:clrMapOvr>
+    <a:masterClrMapping/>
+  </p:clrMapOvr>
+  <p:transition spd="med"/>
+</p:sld>
+</file>
+
+<file path=ppt/slides/slide6.xml><?xml version="1.0" encoding="utf-8"?>
+<p:sld xmlns:a="http://schemas.openxmlformats.org/drawingml/2006/main" xmlns:r="http://schemas.openxmlformats.org/officeDocument/2006/relationships" xmlns:p="http://schemas.openxmlformats.org/presentationml/2006/main">
+  <p:cSld>
+    <p:spTree>
+      <p:nvGrpSpPr>
+        <p:cNvPr id="1" name=""/>
+        <p:cNvGrpSpPr/>
+        <p:nvPr/>
+      </p:nvGrpSpPr>
+      <p:grpSpPr>
+        <a:xfrm>
+          <a:off x="0" y="0"/>
+          <a:ext cx="0" cy="0"/>
+          <a:chOff x="0" y="0"/>
+          <a:chExt cx="0" cy="0"/>
+        </a:xfrm>
+      </p:grpSpPr>
+      <p:sp>
+        <p:nvSpPr>
+          <p:cNvPr id="2" name="Title 1">
+            <a:extLst>
+              <a:ext uri="{FF2B5EF4-FFF2-40B4-BE49-F238E27FC236}">
                 <a16:creationId xmlns:a16="http://schemas.microsoft.com/office/drawing/2014/main" id="{5354F6A0-47EF-52F0-F471-A3C9F254EFB8}"/>
               </a:ext>
             </a:extLst>
@@ -4402,15 +5354,38 @@
             <p:ph type="title"/>
           </p:nvPr>
         </p:nvSpPr>
-        <p:spPr/>
-        <p:txBody>
-          <a:bodyPr/>
+        <p:spPr>
+          <a:xfrm>
+            <a:off x="3629215" y="803276"/>
+            <a:ext cx="4933569" cy="909701"/>
+          </a:xfrm>
+        </p:spPr>
+        <p:txBody>
+          <a:bodyPr>
+            <a:normAutofit fontScale="90000"/>
+          </a:bodyPr>
           <a:lstStyle/>
           <a:p>
             <a:r>
               <a:rPr lang="en-US" dirty="0"/>
-              <a:t>Improvements</a:t>
-            </a:r>
+              <a:t>Improvements: </a:t>
+            </a:r>
+            <a:r>
+              <a:rPr lang="en-US" dirty="0">
+                <a:solidFill>
+                  <a:schemeClr val="accent1"/>
+                </a:solidFill>
+              </a:rPr>
+              <a:t>Meritage</a:t>
+            </a:r>
+            <a:r>
+              <a:rPr lang="en-US" dirty="0"/>
+              <a:t> </a:t>
+            </a:r>
+            <a:br>
+              <a:rPr lang="en-US" dirty="0"/>
+            </a:br>
+            <a:endParaRPr lang="en-US" dirty="0"/>
           </a:p>
         </p:txBody>
       </p:sp>
@@ -4432,59 +5407,96 @@
         </p:nvSpPr>
         <p:spPr/>
         <p:txBody>
-          <a:bodyPr/>
+          <a:bodyPr>
+            <a:normAutofit lnSpcReduction="10000"/>
+          </a:bodyPr>
           <a:lstStyle/>
           <a:p>
             <a:r>
               <a:rPr lang="en-US" dirty="0"/>
-              <a:t>Point of Use Storage</a:t>
-            </a:r>
-          </a:p>
-          <a:p>
+              <a:t>Assign different connector types part numbers. Currently, the 3 different types </a:t>
+            </a:r>
+            <a:r>
+              <a:rPr lang="en-US"/>
+              <a:t>of Meritage </a:t>
+            </a:r>
             <a:r>
               <a:rPr lang="en-US" dirty="0"/>
-              <a:t>Better fitment of cushions and cushion covers</a:t>
-            </a:r>
-          </a:p>
-          <a:p>
+              <a:t>connectors arrive the same way, and under 1 part #. </a:t>
+            </a:r>
+            <a:endParaRPr lang="en-US" b="1" dirty="0"/>
+          </a:p>
+          <a:p>
+            <a:r>
+              <a:rPr dirty="0"/>
+              <a:t>Eliminate connector screw swaps &amp; reorientation</a:t>
+            </a:r>
             <a:r>
               <a:rPr lang="en-US" dirty="0"/>
-              <a:t>Improved connector reliability</a:t>
-            </a:r>
-          </a:p>
-          <a:p>
+              <a:t>: </a:t>
+            </a:r>
+            <a:r>
+              <a:rPr dirty="0"/>
+              <a:t>recovers ~</a:t>
+            </a:r>
             <a:r>
               <a:rPr lang="en-US" dirty="0"/>
-              <a:t>Clearer quality standards to reduce wait time between assembly and </a:t>
-            </a:r>
-            <a:r>
-              <a:rPr lang="en-US"/>
-              <a:t>packing approval</a:t>
-            </a:r>
-          </a:p>
-          <a:p>
-            <a:pPr/>
-            <a:r>
-              <a:t>Eliminate connector screw swaps &amp; reorientation — recovers ~1:40 of labor per unit to redeploy elsewhere</a:t>
-            </a:r>
-            <a:endParaRPr lang="en-US"/>
-          </a:p>
-          <a:p>
-            <a:pPr/>
-            <a:r>
-              <a:t>Pre-drill connector holes for screw entry — saves ~4 min per frame assembly (seat-frame assembly is a top bottleneck)</a:t>
-            </a:r>
-          </a:p>
-          <a:p>
-            <a:pPr/>
-            <a:r>
-              <a:t>Connectors pre-drilled 100% for leg pieces, and pre-drill mini-connectors where possible — improves every Meritage</a:t>
-            </a:r>
-          </a:p>
-          <a:p>
-            <a:pPr/>
-            <a:r>
-              <a:t>Receive leg pieces pre-assembled from manufacturing — ~90% are built identically, so move that work upstream</a:t>
+              <a:t>1</a:t>
+            </a:r>
+            <a:r>
+              <a:rPr dirty="0"/>
+              <a:t>1:40 of labor per unit to redeploy elsewhere</a:t>
+            </a:r>
+            <a:endParaRPr lang="en-US" dirty="0"/>
+          </a:p>
+          <a:p>
+            <a:r>
+              <a:rPr dirty="0"/>
+              <a:t>Pre-drill connector holes for screw entry</a:t>
+            </a:r>
+            <a:r>
+              <a:rPr lang="en-US" dirty="0"/>
+              <a:t>: </a:t>
+            </a:r>
+            <a:r>
+              <a:rPr dirty="0"/>
+              <a:t>saves </a:t>
+            </a:r>
+            <a:r>
+              <a:rPr lang="en-US" dirty="0"/>
+              <a:t> at least 6</a:t>
+            </a:r>
+            <a:r>
+              <a:rPr dirty="0"/>
+              <a:t> min per frame assembly (seat-frame assembly is a top bottleneck)</a:t>
+            </a:r>
+          </a:p>
+          <a:p>
+            <a:r>
+              <a:rPr dirty="0"/>
+              <a:t>Connectors pre-drilled 100% for leg pieces, and pre-drill mini-connectors where possible</a:t>
+            </a:r>
+            <a:r>
+              <a:rPr lang="en-US" dirty="0"/>
+              <a:t>:</a:t>
+            </a:r>
+            <a:r>
+              <a:rPr dirty="0"/>
+              <a:t> improves every Meritage</a:t>
+            </a:r>
+          </a:p>
+          <a:p>
+            <a:r>
+              <a:rPr dirty="0"/>
+              <a:t>Receive leg pieces pre-assembled from manufacturing</a:t>
+            </a:r>
+            <a:r>
+              <a:rPr lang="en-US" dirty="0"/>
+              <a:t>: </a:t>
+            </a:r>
+            <a:r>
+              <a:rPr dirty="0"/>
+              <a:t>~90% are built identically, so move that work upstream</a:t>
             </a:r>
           </a:p>
         </p:txBody>
@@ -4503,8 +5515,8 @@
 </p:sld>
 </file>
 
-<file path=ppt/slides/slide5.xml><?xml version="1.0" encoding="utf-8"?>
-<p:sld xmlns:a="http://schemas.openxmlformats.org/drawingml/2006/main" xmlns:p="http://schemas.openxmlformats.org/presentationml/2006/main" xmlns:r="http://schemas.openxmlformats.org/officeDocument/2006/relationships">
+<file path=ppt/slides/slide7.xml><?xml version="1.0" encoding="utf-8"?>
+<p:sld xmlns:a="http://schemas.openxmlformats.org/drawingml/2006/main" xmlns:r="http://schemas.openxmlformats.org/officeDocument/2006/relationships" xmlns:p="http://schemas.openxmlformats.org/presentationml/2006/main">
   <p:cSld>
     <p:spTree>
       <p:nvGrpSpPr>
@@ -4512,7 +5524,140 @@
         <p:cNvGrpSpPr/>
         <p:nvPr/>
       </p:nvGrpSpPr>
-      <p:grpSpPr/>
+      <p:grpSpPr>
+        <a:xfrm>
+          <a:off x="0" y="0"/>
+          <a:ext cx="0" cy="0"/>
+          <a:chOff x="0" y="0"/>
+          <a:chExt cx="0" cy="0"/>
+        </a:xfrm>
+      </p:grpSpPr>
+      <p:sp>
+        <p:nvSpPr>
+          <p:cNvPr id="2" name="Title 1">
+            <a:extLst>
+              <a:ext uri="{FF2B5EF4-FFF2-40B4-BE49-F238E27FC236}">
+                <a16:creationId xmlns:a16="http://schemas.microsoft.com/office/drawing/2014/main" id="{A6CA8A62-D0C7-6EBB-2F3B-10D1798206A0}"/>
+              </a:ext>
+            </a:extLst>
+          </p:cNvPr>
+          <p:cNvSpPr>
+            <a:spLocks noGrp="1"/>
+          </p:cNvSpPr>
+          <p:nvPr>
+            <p:ph type="title"/>
+          </p:nvPr>
+        </p:nvSpPr>
+        <p:spPr>
+          <a:xfrm>
+            <a:off x="3737610" y="602606"/>
+            <a:ext cx="4716780" cy="909701"/>
+          </a:xfrm>
+        </p:spPr>
+        <p:txBody>
+          <a:bodyPr>
+            <a:normAutofit fontScale="90000"/>
+          </a:bodyPr>
+          <a:lstStyle/>
+          <a:p>
+            <a:r>
+              <a:rPr lang="en-US" dirty="0"/>
+              <a:t>Key Takeaways - </a:t>
+            </a:r>
+            <a:r>
+              <a:rPr lang="en-US" dirty="0">
+                <a:solidFill>
+                  <a:srgbClr val="FF0000"/>
+                </a:solidFill>
+              </a:rPr>
+              <a:t>Sola</a:t>
+            </a:r>
+          </a:p>
+        </p:txBody>
+      </p:sp>
+      <p:sp>
+        <p:nvSpPr>
+          <p:cNvPr id="3" name="Text Placeholder 2">
+            <a:extLst>
+              <a:ext uri="{FF2B5EF4-FFF2-40B4-BE49-F238E27FC236}">
+                <a16:creationId xmlns:a16="http://schemas.microsoft.com/office/drawing/2014/main" id="{81773628-9B98-D01A-F206-8718B5EC1E0F}"/>
+              </a:ext>
+            </a:extLst>
+          </p:cNvPr>
+          <p:cNvSpPr>
+            <a:spLocks noGrp="1"/>
+          </p:cNvSpPr>
+          <p:nvPr>
+            <p:ph type="body" idx="1"/>
+          </p:nvPr>
+        </p:nvSpPr>
+        <p:spPr/>
+        <p:txBody>
+          <a:bodyPr/>
+          <a:lstStyle/>
+          <a:p>
+            <a:r>
+              <a:rPr lang="en-US" dirty="0"/>
+              <a:t>Sola Lounge (No-Arm)</a:t>
+            </a:r>
+            <a:r>
+              <a:rPr lang="en-US"/>
+              <a:t> Sofa assembly labor time: 124 min</a:t>
+            </a:r>
+          </a:p>
+          <a:p>
+            <a:r>
+              <a:rPr lang="en-US" dirty="0"/>
+              <a:t>Theoretical output based on cycle time (36.8 min), assuming parts are available from paint.</a:t>
+            </a:r>
+          </a:p>
+          <a:p>
+            <a:pPr lvl="1"/>
+            <a:r>
+              <a:rPr lang="en-US" dirty="0"/>
+              <a:t>~11 units per day (4 operators)</a:t>
+            </a:r>
+          </a:p>
+          <a:p>
+            <a:pPr lvl="1"/>
+            <a:r>
+              <a:rPr lang="en-US" dirty="0"/>
+              <a:t>Takt time required (demand of 10 units): 42 min</a:t>
+            </a:r>
+          </a:p>
+        </p:txBody>
+      </p:sp>
+    </p:spTree>
+    <p:extLst>
+      <p:ext uri="{BB962C8B-B14F-4D97-AF65-F5344CB8AC3E}">
+        <p14:creationId xmlns:p14="http://schemas.microsoft.com/office/powerpoint/2010/main" val="433969288"/>
+      </p:ext>
+    </p:extLst>
+  </p:cSld>
+  <p:clrMapOvr>
+    <a:masterClrMapping/>
+  </p:clrMapOvr>
+  <p:transition spd="med"/>
+</p:sld>
+</file>
+
+<file path=ppt/slides/slide8.xml><?xml version="1.0" encoding="utf-8"?>
+<p:sld xmlns:a="http://schemas.openxmlformats.org/drawingml/2006/main" xmlns:r="http://schemas.openxmlformats.org/officeDocument/2006/relationships" xmlns:p="http://schemas.openxmlformats.org/presentationml/2006/main">
+  <p:cSld>
+    <p:spTree>
+      <p:nvGrpSpPr>
+        <p:cNvPr id="1" name=""/>
+        <p:cNvGrpSpPr/>
+        <p:nvPr/>
+      </p:nvGrpSpPr>
+      <p:grpSpPr>
+        <a:xfrm>
+          <a:off x="0" y="0"/>
+          <a:ext cx="0" cy="0"/>
+          <a:chOff x="0" y="0"/>
+          <a:chExt cx="0" cy="0"/>
+        </a:xfrm>
+      </p:grpSpPr>
       <p:sp>
         <p:nvSpPr>
           <p:cNvPr id="2" name="Title 1"/>
@@ -4523,14 +5668,37 @@
             <p:ph type="title"/>
           </p:nvPr>
         </p:nvSpPr>
-        <p:spPr/>
+        <p:spPr>
+          <a:xfrm>
+            <a:off x="1838515" y="411506"/>
+            <a:ext cx="10134600" cy="909701"/>
+          </a:xfrm>
+        </p:spPr>
         <p:txBody>
           <a:bodyPr/>
           <a:lstStyle/>
           <a:p>
             <a:r>
+              <a:rPr dirty="0"/>
               <a:t>Operator Loading Chart by Task</a:t>
             </a:r>
+            <a:r>
+              <a:rPr lang="en-US" dirty="0"/>
+              <a:t> – </a:t>
+            </a:r>
+            <a:r>
+              <a:rPr lang="en-US" dirty="0">
+                <a:solidFill>
+                  <a:srgbClr val="FF0000"/>
+                </a:solidFill>
+              </a:rPr>
+              <a:t>Sola</a:t>
+            </a:r>
+            <a:endParaRPr dirty="0">
+              <a:solidFill>
+                <a:srgbClr val="FF0000"/>
+              </a:solidFill>
+            </a:endParaRPr>
           </a:p>
         </p:txBody>
       </p:sp>
@@ -4587,7 +5755,7 @@
           <a:noFill/>
         </p:spPr>
         <p:txBody>
-          <a:bodyPr wrap="square" lIns="0" rIns="0" tIns="0" bIns="0">
+          <a:bodyPr wrap="square" lIns="0" tIns="0" rIns="0" bIns="0">
             <a:spAutoFit/>
           </a:bodyPr>
           <a:lstStyle/>
@@ -4658,7 +5826,7 @@
           <a:noFill/>
         </p:spPr>
         <p:txBody>
-          <a:bodyPr wrap="square" lIns="0" rIns="0" tIns="0" bIns="0">
+          <a:bodyPr wrap="square" lIns="0" tIns="0" rIns="0" bIns="0">
             <a:spAutoFit/>
           </a:bodyPr>
           <a:lstStyle/>
@@ -4729,7 +5897,7 @@
           <a:noFill/>
         </p:spPr>
         <p:txBody>
-          <a:bodyPr wrap="square" lIns="0" rIns="0" tIns="0" bIns="0">
+          <a:bodyPr wrap="square" lIns="0" tIns="0" rIns="0" bIns="0">
             <a:spAutoFit/>
           </a:bodyPr>
           <a:lstStyle/>
@@ -4800,7 +5968,7 @@
           <a:noFill/>
         </p:spPr>
         <p:txBody>
-          <a:bodyPr wrap="square" lIns="0" rIns="0" tIns="0" bIns="0">
+          <a:bodyPr wrap="square" lIns="0" tIns="0" rIns="0" bIns="0">
             <a:spAutoFit/>
           </a:bodyPr>
           <a:lstStyle/>
@@ -4871,7 +6039,7 @@
           <a:noFill/>
         </p:spPr>
         <p:txBody>
-          <a:bodyPr wrap="square" lIns="0" rIns="0" tIns="0" bIns="0">
+          <a:bodyPr wrap="square" lIns="0" tIns="0" rIns="0" bIns="0">
             <a:spAutoFit/>
           </a:bodyPr>
           <a:lstStyle/>
@@ -4897,8 +6065,8 @@
         </p:nvSpPr>
         <p:spPr>
           <a:xfrm>
-            <a:off x="1650492" y="3919061"/>
-            <a:ext cx="644652" cy="1430178"/>
+            <a:off x="1838515" y="4717732"/>
+            <a:ext cx="805815" cy="631507"/>
           </a:xfrm>
           <a:prstGeom prst="rect">
             <a:avLst/>
@@ -4932,6 +6100,7 @@
           <a:lstStyle/>
           <a:p>
             <a:pPr algn="ctr"/>
+            <a:endParaRPr/>
           </a:p>
         </p:txBody>
       </p:sp>
@@ -4943,8 +6112,8 @@
         </p:nvSpPr>
         <p:spPr>
           <a:xfrm>
-            <a:off x="1650492" y="4524422"/>
-            <a:ext cx="644652" cy="219456"/>
+            <a:off x="1838515" y="4923758"/>
+            <a:ext cx="805815" cy="219456"/>
           </a:xfrm>
           <a:prstGeom prst="rect">
             <a:avLst/>
@@ -4952,7 +6121,7 @@
           <a:noFill/>
         </p:spPr>
         <p:txBody>
-          <a:bodyPr wrap="square" lIns="0" rIns="0" tIns="0" bIns="0">
+          <a:bodyPr wrap="square" lIns="0" tIns="0" rIns="0" bIns="0">
             <a:spAutoFit/>
           </a:bodyPr>
           <a:lstStyle/>
@@ -4978,8 +6147,8 @@
         </p:nvSpPr>
         <p:spPr>
           <a:xfrm>
-            <a:off x="1650492" y="3324701"/>
-            <a:ext cx="644652" cy="594359"/>
+            <a:off x="1838515" y="3851452"/>
+            <a:ext cx="805815" cy="866279"/>
           </a:xfrm>
           <a:prstGeom prst="rect">
             <a:avLst/>
@@ -5013,6 +6182,7 @@
           <a:lstStyle/>
           <a:p>
             <a:pPr algn="ctr"/>
+            <a:endParaRPr/>
           </a:p>
         </p:txBody>
       </p:sp>
@@ -5024,8 +6194,8 @@
         </p:nvSpPr>
         <p:spPr>
           <a:xfrm>
-            <a:off x="1650492" y="3512153"/>
-            <a:ext cx="644652" cy="219456"/>
+            <a:off x="1838515" y="4174864"/>
+            <a:ext cx="805815" cy="219456"/>
           </a:xfrm>
           <a:prstGeom prst="rect">
             <a:avLst/>
@@ -5033,7 +6203,7 @@
           <a:noFill/>
         </p:spPr>
         <p:txBody>
-          <a:bodyPr wrap="square" lIns="0" rIns="0" tIns="0" bIns="0">
+          <a:bodyPr wrap="square" lIns="0" tIns="0" rIns="0" bIns="0">
             <a:spAutoFit/>
           </a:bodyPr>
           <a:lstStyle/>
@@ -5053,84 +6223,14 @@
       </p:sp>
       <p:sp>
         <p:nvSpPr>
-          <p:cNvPr id="17" name="TextBox 16"/>
-          <p:cNvSpPr txBox="1"/>
-          <p:nvPr/>
-        </p:nvSpPr>
-        <p:spPr>
-          <a:xfrm>
-            <a:off x="1376172" y="3086957"/>
-            <a:ext cx="1193292" cy="201168"/>
-          </a:xfrm>
-          <a:prstGeom prst="rect">
-            <a:avLst/>
-          </a:prstGeom>
-          <a:noFill/>
-        </p:spPr>
-        <p:txBody>
-          <a:bodyPr wrap="square" lIns="0" rIns="0" tIns="0" bIns="0">
-            <a:spAutoFit/>
-          </a:bodyPr>
-          <a:lstStyle/>
-          <a:p>
-            <a:pPr algn="ctr"/>
-            <a:r>
-              <a:rPr sz="1000" b="1">
-                <a:solidFill>
-                  <a:srgbClr val="1F3864"/>
-                </a:solidFill>
-                <a:latin typeface="Calibri"/>
-              </a:rPr>
-              <a:t>27.2</a:t>
-            </a:r>
-          </a:p>
-        </p:txBody>
-      </p:sp>
-      <p:sp>
-        <p:nvSpPr>
-          <p:cNvPr id="18" name="TextBox 17"/>
-          <p:cNvSpPr txBox="1"/>
-          <p:nvPr/>
-        </p:nvSpPr>
-        <p:spPr>
-          <a:xfrm>
-            <a:off x="1376172" y="5404103"/>
-            <a:ext cx="1193292" cy="201168"/>
-          </a:xfrm>
-          <a:prstGeom prst="rect">
-            <a:avLst/>
-          </a:prstGeom>
-          <a:noFill/>
-        </p:spPr>
-        <p:txBody>
-          <a:bodyPr wrap="square" lIns="0" rIns="0" tIns="0" bIns="0">
-            <a:spAutoFit/>
-          </a:bodyPr>
-          <a:lstStyle/>
-          <a:p>
-            <a:pPr algn="ctr"/>
-            <a:r>
-              <a:rPr sz="1000" b="1">
-                <a:solidFill>
-                  <a:srgbClr val="404040"/>
-                </a:solidFill>
-                <a:latin typeface="Calibri"/>
-              </a:rPr>
-              <a:t>S1</a:t>
-            </a:r>
-          </a:p>
-        </p:txBody>
-      </p:sp>
-      <p:sp>
-        <p:nvSpPr>
-          <p:cNvPr id="19" name="Rectangle 18"/>
+          <p:cNvPr id="17" name="Rectangle 16"/>
           <p:cNvSpPr/>
           <p:nvPr/>
         </p:nvSpPr>
         <p:spPr>
           <a:xfrm>
-            <a:off x="2724912" y="2971800"/>
-            <a:ext cx="644652" cy="2377439"/>
+            <a:off x="1838515" y="2885617"/>
+            <a:ext cx="805815" cy="965834"/>
           </a:xfrm>
           <a:prstGeom prst="rect">
             <a:avLst/>
@@ -5164,19 +6264,20 @@
           <a:lstStyle/>
           <a:p>
             <a:pPr algn="ctr"/>
-          </a:p>
-        </p:txBody>
-      </p:sp>
-      <p:sp>
-        <p:nvSpPr>
-          <p:cNvPr id="20" name="TextBox 19"/>
+            <a:endParaRPr/>
+          </a:p>
+        </p:txBody>
+      </p:sp>
+      <p:sp>
+        <p:nvSpPr>
+          <p:cNvPr id="18" name="TextBox 17"/>
           <p:cNvSpPr txBox="1"/>
           <p:nvPr/>
         </p:nvSpPr>
         <p:spPr>
           <a:xfrm>
-            <a:off x="2724912" y="4050791"/>
-            <a:ext cx="644652" cy="219456"/>
+            <a:off x="1838515" y="3258807"/>
+            <a:ext cx="805815" cy="219456"/>
           </a:xfrm>
           <a:prstGeom prst="rect">
             <a:avLst/>
@@ -5184,7 +6285,7 @@
           <a:noFill/>
         </p:spPr>
         <p:txBody>
-          <a:bodyPr wrap="square" lIns="0" rIns="0" tIns="0" bIns="0">
+          <a:bodyPr wrap="square" lIns="0" tIns="0" rIns="0" bIns="0">
             <a:spAutoFit/>
           </a:bodyPr>
           <a:lstStyle/>
@@ -5204,84 +6305,14 @@
       </p:sp>
       <p:sp>
         <p:nvSpPr>
-          <p:cNvPr id="21" name="TextBox 20"/>
-          <p:cNvSpPr txBox="1"/>
-          <p:nvPr/>
-        </p:nvSpPr>
-        <p:spPr>
-          <a:xfrm>
-            <a:off x="2450592" y="2734056"/>
-            <a:ext cx="1193292" cy="201168"/>
-          </a:xfrm>
-          <a:prstGeom prst="rect">
-            <a:avLst/>
-          </a:prstGeom>
-          <a:noFill/>
-        </p:spPr>
-        <p:txBody>
-          <a:bodyPr wrap="square" lIns="0" rIns="0" tIns="0" bIns="0">
-            <a:spAutoFit/>
-          </a:bodyPr>
-          <a:lstStyle/>
-          <a:p>
-            <a:pPr algn="ctr"/>
-            <a:r>
-              <a:rPr sz="1000" b="1">
-                <a:solidFill>
-                  <a:srgbClr val="1F3864"/>
-                </a:solidFill>
-                <a:latin typeface="Calibri"/>
-              </a:rPr>
-              <a:t>32</a:t>
-            </a:r>
-          </a:p>
-        </p:txBody>
-      </p:sp>
-      <p:sp>
-        <p:nvSpPr>
-          <p:cNvPr id="22" name="TextBox 21"/>
-          <p:cNvSpPr txBox="1"/>
-          <p:nvPr/>
-        </p:nvSpPr>
-        <p:spPr>
-          <a:xfrm>
-            <a:off x="2450592" y="5404103"/>
-            <a:ext cx="1193292" cy="201168"/>
-          </a:xfrm>
-          <a:prstGeom prst="rect">
-            <a:avLst/>
-          </a:prstGeom>
-          <a:noFill/>
-        </p:spPr>
-        <p:txBody>
-          <a:bodyPr wrap="square" lIns="0" rIns="0" tIns="0" bIns="0">
-            <a:spAutoFit/>
-          </a:bodyPr>
-          <a:lstStyle/>
-          <a:p>
-            <a:pPr algn="ctr"/>
-            <a:r>
-              <a:rPr sz="1000" b="1">
-                <a:solidFill>
-                  <a:srgbClr val="404040"/>
-                </a:solidFill>
-                <a:latin typeface="Calibri"/>
-              </a:rPr>
-              <a:t>S2  x2</a:t>
-            </a:r>
-          </a:p>
-        </p:txBody>
-      </p:sp>
-      <p:sp>
-        <p:nvSpPr>
-          <p:cNvPr id="23" name="Rectangle 22"/>
+          <p:cNvPr id="19" name="Rectangle 18"/>
           <p:cNvSpPr/>
           <p:nvPr/>
         </p:nvSpPr>
         <p:spPr>
           <a:xfrm>
-            <a:off x="3799332" y="2303145"/>
-            <a:ext cx="644652" cy="3046094"/>
+            <a:off x="1838515" y="2613698"/>
+            <a:ext cx="805815" cy="271919"/>
           </a:xfrm>
           <a:prstGeom prst="rect">
             <a:avLst/>
@@ -5315,19 +6346,20 @@
           <a:lstStyle/>
           <a:p>
             <a:pPr algn="ctr"/>
-          </a:p>
-        </p:txBody>
-      </p:sp>
-      <p:sp>
-        <p:nvSpPr>
-          <p:cNvPr id="24" name="TextBox 23"/>
+            <a:endParaRPr/>
+          </a:p>
+        </p:txBody>
+      </p:sp>
+      <p:sp>
+        <p:nvSpPr>
+          <p:cNvPr id="20" name="TextBox 19"/>
           <p:cNvSpPr txBox="1"/>
           <p:nvPr/>
         </p:nvSpPr>
         <p:spPr>
           <a:xfrm>
-            <a:off x="3799332" y="3716464"/>
-            <a:ext cx="644652" cy="219456"/>
+            <a:off x="1838515" y="2639929"/>
+            <a:ext cx="805815" cy="219456"/>
           </a:xfrm>
           <a:prstGeom prst="rect">
             <a:avLst/>
@@ -5335,7 +6367,7 @@
           <a:noFill/>
         </p:spPr>
         <p:txBody>
-          <a:bodyPr wrap="square" lIns="0" rIns="0" tIns="0" bIns="0">
+          <a:bodyPr wrap="square" lIns="0" tIns="0" rIns="0" bIns="0">
             <a:spAutoFit/>
           </a:bodyPr>
           <a:lstStyle/>
@@ -5348,21 +6380,21 @@
                 </a:solidFill>
                 <a:latin typeface="Calibri"/>
               </a:rPr>
-              <a:t>5a</a:t>
-            </a:r>
-          </a:p>
-        </p:txBody>
-      </p:sp>
-      <p:sp>
-        <p:nvSpPr>
-          <p:cNvPr id="25" name="TextBox 24"/>
+              <a:t>5</a:t>
+            </a:r>
+          </a:p>
+        </p:txBody>
+      </p:sp>
+      <p:sp>
+        <p:nvSpPr>
+          <p:cNvPr id="21" name="TextBox 20"/>
           <p:cNvSpPr txBox="1"/>
           <p:nvPr/>
         </p:nvSpPr>
         <p:spPr>
           <a:xfrm>
-            <a:off x="3525012" y="2065401"/>
-            <a:ext cx="1193292" cy="201168"/>
+            <a:off x="1564195" y="2375954"/>
+            <a:ext cx="1354455" cy="201168"/>
           </a:xfrm>
           <a:prstGeom prst="rect">
             <a:avLst/>
@@ -5370,7 +6402,7 @@
           <a:noFill/>
         </p:spPr>
         <p:txBody>
-          <a:bodyPr wrap="square" lIns="0" rIns="0" tIns="0" bIns="0">
+          <a:bodyPr wrap="square" lIns="0" tIns="0" rIns="0" bIns="0">
             <a:spAutoFit/>
           </a:bodyPr>
           <a:lstStyle/>
@@ -5383,21 +6415,21 @@
                 </a:solidFill>
                 <a:latin typeface="Calibri"/>
               </a:rPr>
-              <a:t>41</a:t>
-            </a:r>
-          </a:p>
-        </p:txBody>
-      </p:sp>
-      <p:sp>
-        <p:nvSpPr>
-          <p:cNvPr id="26" name="TextBox 25"/>
+              <a:t>36.8</a:t>
+            </a:r>
+          </a:p>
+        </p:txBody>
+      </p:sp>
+      <p:sp>
+        <p:nvSpPr>
+          <p:cNvPr id="22" name="TextBox 21"/>
           <p:cNvSpPr txBox="1"/>
           <p:nvPr/>
         </p:nvSpPr>
         <p:spPr>
           <a:xfrm>
-            <a:off x="3525012" y="5404103"/>
-            <a:ext cx="1193292" cy="201168"/>
+            <a:off x="1564195" y="5404103"/>
+            <a:ext cx="1354455" cy="201168"/>
           </a:xfrm>
           <a:prstGeom prst="rect">
             <a:avLst/>
@@ -5405,7 +6437,7 @@
           <a:noFill/>
         </p:spPr>
         <p:txBody>
-          <a:bodyPr wrap="square" lIns="0" rIns="0" tIns="0" bIns="0">
+          <a:bodyPr wrap="square" lIns="0" tIns="0" rIns="0" bIns="0">
             <a:spAutoFit/>
           </a:bodyPr>
           <a:lstStyle/>
@@ -5418,27 +6450,27 @@
                 </a:solidFill>
                 <a:latin typeface="Calibri"/>
               </a:rPr>
-              <a:t>S3</a:t>
-            </a:r>
-          </a:p>
-        </p:txBody>
-      </p:sp>
-      <p:sp>
-        <p:nvSpPr>
-          <p:cNvPr id="27" name="Rectangle 26"/>
+              <a:t>S1</a:t>
+            </a:r>
+          </a:p>
+        </p:txBody>
+      </p:sp>
+      <p:sp>
+        <p:nvSpPr>
+          <p:cNvPr id="23" name="Rectangle 22"/>
           <p:cNvSpPr/>
           <p:nvPr/>
         </p:nvSpPr>
         <p:spPr>
           <a:xfrm>
-            <a:off x="4873752" y="4903470"/>
-            <a:ext cx="644652" cy="445769"/>
+            <a:off x="3450145" y="4086225"/>
+            <a:ext cx="805815" cy="1263014"/>
           </a:xfrm>
           <a:prstGeom prst="rect">
             <a:avLst/>
           </a:prstGeom>
           <a:solidFill>
-            <a:srgbClr val="5B9BD5"/>
+            <a:srgbClr val="ED7D31"/>
           </a:solidFill>
           <a:ln w="6350">
             <a:solidFill>
@@ -5466,19 +6498,20 @@
           <a:lstStyle/>
           <a:p>
             <a:pPr algn="ctr"/>
-          </a:p>
-        </p:txBody>
-      </p:sp>
-      <p:sp>
-        <p:nvSpPr>
-          <p:cNvPr id="28" name="TextBox 27"/>
+            <a:endParaRPr/>
+          </a:p>
+        </p:txBody>
+      </p:sp>
+      <p:sp>
+        <p:nvSpPr>
+          <p:cNvPr id="24" name="TextBox 23"/>
           <p:cNvSpPr txBox="1"/>
           <p:nvPr/>
         </p:nvSpPr>
         <p:spPr>
           <a:xfrm>
-            <a:off x="4873752" y="5016627"/>
-            <a:ext cx="644652" cy="219456"/>
+            <a:off x="3450145" y="4608004"/>
+            <a:ext cx="805815" cy="219456"/>
           </a:xfrm>
           <a:prstGeom prst="rect">
             <a:avLst/>
@@ -5486,7 +6519,7 @@
           <a:noFill/>
         </p:spPr>
         <p:txBody>
-          <a:bodyPr wrap="square" lIns="0" rIns="0" tIns="0" bIns="0">
+          <a:bodyPr wrap="square" lIns="0" tIns="0" rIns="0" bIns="0">
             <a:spAutoFit/>
           </a:bodyPr>
           <a:lstStyle/>
@@ -5499,27 +6532,27 @@
                 </a:solidFill>
                 <a:latin typeface="Calibri"/>
               </a:rPr>
-              <a:t>5b</a:t>
-            </a:r>
-          </a:p>
-        </p:txBody>
-      </p:sp>
-      <p:sp>
-        <p:nvSpPr>
-          <p:cNvPr id="29" name="Rectangle 28"/>
+              <a:t>6</a:t>
+            </a:r>
+          </a:p>
+        </p:txBody>
+      </p:sp>
+      <p:sp>
+        <p:nvSpPr>
+          <p:cNvPr id="25" name="Rectangle 24"/>
           <p:cNvSpPr/>
           <p:nvPr/>
         </p:nvSpPr>
         <p:spPr>
           <a:xfrm>
-            <a:off x="4873752" y="2414587"/>
-            <a:ext cx="644652" cy="2488882"/>
+            <a:off x="3450145" y="2786062"/>
+            <a:ext cx="805815" cy="1300162"/>
           </a:xfrm>
           <a:prstGeom prst="rect">
             <a:avLst/>
           </a:prstGeom>
           <a:solidFill>
-            <a:srgbClr val="ED7D31"/>
+            <a:srgbClr val="A5A5A5"/>
           </a:solidFill>
           <a:ln w="6350">
             <a:solidFill>
@@ -5547,19 +6580,20 @@
           <a:lstStyle/>
           <a:p>
             <a:pPr algn="ctr"/>
-          </a:p>
-        </p:txBody>
-      </p:sp>
-      <p:sp>
-        <p:nvSpPr>
-          <p:cNvPr id="30" name="TextBox 29"/>
+            <a:endParaRPr/>
+          </a:p>
+        </p:txBody>
+      </p:sp>
+      <p:sp>
+        <p:nvSpPr>
+          <p:cNvPr id="26" name="TextBox 25"/>
           <p:cNvSpPr txBox="1"/>
           <p:nvPr/>
         </p:nvSpPr>
         <p:spPr>
           <a:xfrm>
-            <a:off x="4873752" y="3549300"/>
-            <a:ext cx="644652" cy="219456"/>
+            <a:off x="3450145" y="3326415"/>
+            <a:ext cx="805815" cy="219456"/>
           </a:xfrm>
           <a:prstGeom prst="rect">
             <a:avLst/>
@@ -5567,7 +6601,7 @@
           <a:noFill/>
         </p:spPr>
         <p:txBody>
-          <a:bodyPr wrap="square" lIns="0" rIns="0" tIns="0" bIns="0">
+          <a:bodyPr wrap="square" lIns="0" tIns="0" rIns="0" bIns="0">
             <a:spAutoFit/>
           </a:bodyPr>
           <a:lstStyle/>
@@ -5580,21 +6614,21 @@
                 </a:solidFill>
                 <a:latin typeface="Calibri"/>
               </a:rPr>
-              <a:t>6a</a:t>
-            </a:r>
-          </a:p>
-        </p:txBody>
-      </p:sp>
-      <p:sp>
-        <p:nvSpPr>
-          <p:cNvPr id="31" name="TextBox 30"/>
+              <a:t>7</a:t>
+            </a:r>
+          </a:p>
+        </p:txBody>
+      </p:sp>
+      <p:sp>
+        <p:nvSpPr>
+          <p:cNvPr id="27" name="TextBox 26"/>
           <p:cNvSpPr txBox="1"/>
           <p:nvPr/>
         </p:nvSpPr>
         <p:spPr>
           <a:xfrm>
-            <a:off x="4599432" y="2176843"/>
-            <a:ext cx="1193292" cy="201168"/>
+            <a:off x="3175825" y="2548318"/>
+            <a:ext cx="1354455" cy="201168"/>
           </a:xfrm>
           <a:prstGeom prst="rect">
             <a:avLst/>
@@ -5602,7 +6636,7 @@
           <a:noFill/>
         </p:spPr>
         <p:txBody>
-          <a:bodyPr wrap="square" lIns="0" rIns="0" tIns="0" bIns="0">
+          <a:bodyPr wrap="square" lIns="0" tIns="0" rIns="0" bIns="0">
             <a:spAutoFit/>
           </a:bodyPr>
           <a:lstStyle/>
@@ -5615,21 +6649,21 @@
                 </a:solidFill>
                 <a:latin typeface="Calibri"/>
               </a:rPr>
-              <a:t>39.5</a:t>
-            </a:r>
-          </a:p>
-        </p:txBody>
-      </p:sp>
-      <p:sp>
-        <p:nvSpPr>
-          <p:cNvPr id="32" name="TextBox 31"/>
+              <a:t>34.5</a:t>
+            </a:r>
+          </a:p>
+        </p:txBody>
+      </p:sp>
+      <p:sp>
+        <p:nvSpPr>
+          <p:cNvPr id="28" name="TextBox 27"/>
           <p:cNvSpPr txBox="1"/>
           <p:nvPr/>
         </p:nvSpPr>
         <p:spPr>
           <a:xfrm>
-            <a:off x="4599432" y="5404103"/>
-            <a:ext cx="1193292" cy="201168"/>
+            <a:off x="3175825" y="5404103"/>
+            <a:ext cx="1354455" cy="201168"/>
           </a:xfrm>
           <a:prstGeom prst="rect">
             <a:avLst/>
@@ -5637,7 +6671,7 @@
           <a:noFill/>
         </p:spPr>
         <p:txBody>
-          <a:bodyPr wrap="square" lIns="0" rIns="0" tIns="0" bIns="0">
+          <a:bodyPr wrap="square" lIns="0" tIns="0" rIns="0" bIns="0">
             <a:spAutoFit/>
           </a:bodyPr>
           <a:lstStyle/>
@@ -5650,27 +6684,27 @@
                 </a:solidFill>
                 <a:latin typeface="Calibri"/>
               </a:rPr>
-              <a:t>S4</a:t>
-            </a:r>
-          </a:p>
-        </p:txBody>
-      </p:sp>
-      <p:sp>
-        <p:nvSpPr>
-          <p:cNvPr id="33" name="Rectangle 32"/>
+              <a:t>S2</a:t>
+            </a:r>
+          </a:p>
+        </p:txBody>
+      </p:sp>
+      <p:sp>
+        <p:nvSpPr>
+          <p:cNvPr id="29" name="Rectangle 28"/>
           <p:cNvSpPr/>
           <p:nvPr/>
         </p:nvSpPr>
         <p:spPr>
           <a:xfrm>
-            <a:off x="5948172" y="4606290"/>
-            <a:ext cx="644652" cy="742949"/>
+            <a:off x="5061775" y="2897505"/>
+            <a:ext cx="805815" cy="2451734"/>
           </a:xfrm>
           <a:prstGeom prst="rect">
             <a:avLst/>
           </a:prstGeom>
           <a:solidFill>
-            <a:srgbClr val="ED7D31"/>
+            <a:srgbClr val="843C0C"/>
           </a:solidFill>
           <a:ln w="6350">
             <a:solidFill>
@@ -5698,19 +6732,20 @@
           <a:lstStyle/>
           <a:p>
             <a:pPr algn="ctr"/>
-          </a:p>
-        </p:txBody>
-      </p:sp>
-      <p:sp>
-        <p:nvSpPr>
-          <p:cNvPr id="34" name="TextBox 33"/>
+            <a:endParaRPr/>
+          </a:p>
+        </p:txBody>
+      </p:sp>
+      <p:sp>
+        <p:nvSpPr>
+          <p:cNvPr id="30" name="TextBox 29"/>
           <p:cNvSpPr txBox="1"/>
           <p:nvPr/>
         </p:nvSpPr>
         <p:spPr>
           <a:xfrm>
-            <a:off x="5948172" y="4868037"/>
-            <a:ext cx="644652" cy="219456"/>
+            <a:off x="5061775" y="4013644"/>
+            <a:ext cx="805815" cy="219456"/>
           </a:xfrm>
           <a:prstGeom prst="rect">
             <a:avLst/>
@@ -5718,7 +6753,7 @@
           <a:noFill/>
         </p:spPr>
         <p:txBody>
-          <a:bodyPr wrap="square" lIns="0" rIns="0" tIns="0" bIns="0">
+          <a:bodyPr wrap="square" lIns="0" tIns="0" rIns="0" bIns="0">
             <a:spAutoFit/>
           </a:bodyPr>
           <a:lstStyle/>
@@ -5731,27 +6766,97 @@
                 </a:solidFill>
                 <a:latin typeface="Calibri"/>
               </a:rPr>
-              <a:t>6b</a:t>
-            </a:r>
-          </a:p>
-        </p:txBody>
-      </p:sp>
-      <p:sp>
-        <p:nvSpPr>
-          <p:cNvPr id="35" name="Rectangle 34"/>
+              <a:t>8</a:t>
+            </a:r>
+          </a:p>
+        </p:txBody>
+      </p:sp>
+      <p:sp>
+        <p:nvSpPr>
+          <p:cNvPr id="31" name="TextBox 30"/>
+          <p:cNvSpPr txBox="1"/>
+          <p:nvPr/>
+        </p:nvSpPr>
+        <p:spPr>
+          <a:xfrm>
+            <a:off x="4787455" y="2659761"/>
+            <a:ext cx="1354455" cy="201168"/>
+          </a:xfrm>
+          <a:prstGeom prst="rect">
+            <a:avLst/>
+          </a:prstGeom>
+          <a:noFill/>
+        </p:spPr>
+        <p:txBody>
+          <a:bodyPr wrap="square" lIns="0" tIns="0" rIns="0" bIns="0">
+            <a:spAutoFit/>
+          </a:bodyPr>
+          <a:lstStyle/>
+          <a:p>
+            <a:pPr algn="ctr"/>
+            <a:r>
+              <a:rPr sz="1000" b="1">
+                <a:solidFill>
+                  <a:srgbClr val="1F3864"/>
+                </a:solidFill>
+                <a:latin typeface="Calibri"/>
+              </a:rPr>
+              <a:t>33</a:t>
+            </a:r>
+          </a:p>
+        </p:txBody>
+      </p:sp>
+      <p:sp>
+        <p:nvSpPr>
+          <p:cNvPr id="32" name="TextBox 31"/>
+          <p:cNvSpPr txBox="1"/>
+          <p:nvPr/>
+        </p:nvSpPr>
+        <p:spPr>
+          <a:xfrm>
+            <a:off x="4787455" y="5404103"/>
+            <a:ext cx="1354455" cy="201168"/>
+          </a:xfrm>
+          <a:prstGeom prst="rect">
+            <a:avLst/>
+          </a:prstGeom>
+          <a:noFill/>
+        </p:spPr>
+        <p:txBody>
+          <a:bodyPr wrap="square" lIns="0" tIns="0" rIns="0" bIns="0">
+            <a:spAutoFit/>
+          </a:bodyPr>
+          <a:lstStyle/>
+          <a:p>
+            <a:pPr algn="ctr"/>
+            <a:r>
+              <a:rPr sz="1000" b="1">
+                <a:solidFill>
+                  <a:srgbClr val="404040"/>
+                </a:solidFill>
+                <a:latin typeface="Calibri"/>
+              </a:rPr>
+              <a:t>S3</a:t>
+            </a:r>
+          </a:p>
+        </p:txBody>
+      </p:sp>
+      <p:sp>
+        <p:nvSpPr>
+          <p:cNvPr id="33" name="Rectangle 32"/>
           <p:cNvSpPr/>
           <p:nvPr/>
         </p:nvSpPr>
         <p:spPr>
           <a:xfrm>
-            <a:off x="5948172" y="3268979"/>
-            <a:ext cx="644652" cy="1337310"/>
+            <a:off x="6673405" y="4352944"/>
+            <a:ext cx="805815" cy="996295"/>
           </a:xfrm>
           <a:prstGeom prst="rect">
             <a:avLst/>
           </a:prstGeom>
           <a:solidFill>
-            <a:srgbClr val="A5A5A5"/>
+            <a:srgbClr val="548235"/>
           </a:solidFill>
           <a:ln w="6350">
             <a:solidFill>
@@ -5779,19 +6884,20 @@
           <a:lstStyle/>
           <a:p>
             <a:pPr algn="ctr"/>
-          </a:p>
-        </p:txBody>
-      </p:sp>
-      <p:sp>
-        <p:nvSpPr>
-          <p:cNvPr id="36" name="TextBox 35"/>
+            <a:endParaRPr/>
+          </a:p>
+        </p:txBody>
+      </p:sp>
+      <p:sp>
+        <p:nvSpPr>
+          <p:cNvPr id="34" name="TextBox 33"/>
           <p:cNvSpPr txBox="1"/>
           <p:nvPr/>
         </p:nvSpPr>
         <p:spPr>
           <a:xfrm>
-            <a:off x="5948172" y="3827906"/>
-            <a:ext cx="644652" cy="219456"/>
+            <a:off x="6673405" y="4741364"/>
+            <a:ext cx="805815" cy="219456"/>
           </a:xfrm>
           <a:prstGeom prst="rect">
             <a:avLst/>
@@ -5799,7 +6905,7 @@
           <a:noFill/>
         </p:spPr>
         <p:txBody>
-          <a:bodyPr wrap="square" lIns="0" rIns="0" tIns="0" bIns="0">
+          <a:bodyPr wrap="square" lIns="0" tIns="0" rIns="0" bIns="0">
             <a:spAutoFit/>
           </a:bodyPr>
           <a:lstStyle/>
@@ -5812,27 +6918,27 @@
                 </a:solidFill>
                 <a:latin typeface="Calibri"/>
               </a:rPr>
-              <a:t>7</a:t>
-            </a:r>
-          </a:p>
-        </p:txBody>
-      </p:sp>
-      <p:sp>
-        <p:nvSpPr>
-          <p:cNvPr id="37" name="Rectangle 36"/>
+              <a:t>9</a:t>
+            </a:r>
+          </a:p>
+        </p:txBody>
+      </p:sp>
+      <p:sp>
+        <p:nvSpPr>
+          <p:cNvPr id="35" name="Rectangle 34"/>
           <p:cNvSpPr/>
           <p:nvPr/>
         </p:nvSpPr>
         <p:spPr>
           <a:xfrm>
-            <a:off x="5948172" y="2897504"/>
-            <a:ext cx="644652" cy="371474"/>
+            <a:off x="6673405" y="3858139"/>
+            <a:ext cx="805815" cy="494804"/>
           </a:xfrm>
           <a:prstGeom prst="rect">
             <a:avLst/>
           </a:prstGeom>
           <a:solidFill>
-            <a:srgbClr val="997300"/>
+            <a:srgbClr val="843C0C"/>
           </a:solidFill>
           <a:ln w="6350">
             <a:solidFill>
@@ -5860,19 +6966,20 @@
           <a:lstStyle/>
           <a:p>
             <a:pPr algn="ctr"/>
-          </a:p>
-        </p:txBody>
-      </p:sp>
-      <p:sp>
-        <p:nvSpPr>
-          <p:cNvPr id="38" name="TextBox 37"/>
+            <a:endParaRPr/>
+          </a:p>
+        </p:txBody>
+      </p:sp>
+      <p:sp>
+        <p:nvSpPr>
+          <p:cNvPr id="36" name="TextBox 35"/>
           <p:cNvSpPr txBox="1"/>
           <p:nvPr/>
         </p:nvSpPr>
         <p:spPr>
           <a:xfrm>
-            <a:off x="5948172" y="2973514"/>
-            <a:ext cx="644652" cy="219456"/>
+            <a:off x="6673405" y="3995813"/>
+            <a:ext cx="805815" cy="219456"/>
           </a:xfrm>
           <a:prstGeom prst="rect">
             <a:avLst/>
@@ -5880,239 +6987,7 @@
           <a:noFill/>
         </p:spPr>
         <p:txBody>
-          <a:bodyPr wrap="square" lIns="0" rIns="0" tIns="0" bIns="0">
-            <a:spAutoFit/>
-          </a:bodyPr>
-          <a:lstStyle/>
-          <a:p>
-            <a:pPr algn="ctr"/>
-            <a:r>
-              <a:rPr sz="900" b="1">
-                <a:solidFill>
-                  <a:srgbClr val="FFFFFF"/>
-                </a:solidFill>
-                <a:latin typeface="Calibri"/>
-              </a:rPr>
-              <a:t>8</a:t>
-            </a:r>
-          </a:p>
-        </p:txBody>
-      </p:sp>
-      <p:sp>
-        <p:nvSpPr>
-          <p:cNvPr id="39" name="Rectangle 38"/>
-          <p:cNvSpPr/>
-          <p:nvPr/>
-        </p:nvSpPr>
-        <p:spPr>
-          <a:xfrm>
-            <a:off x="5948172" y="2303145"/>
-            <a:ext cx="644652" cy="594359"/>
-          </a:xfrm>
-          <a:prstGeom prst="rect">
-            <a:avLst/>
-          </a:prstGeom>
-          <a:solidFill>
-            <a:srgbClr val="548235"/>
-          </a:solidFill>
-          <a:ln w="6350">
-            <a:solidFill>
-              <a:srgbClr val="FFFFFF"/>
-            </a:solidFill>
-          </a:ln>
-          <a:effectLst/>
-        </p:spPr>
-        <p:style>
-          <a:lnRef idx="1">
-            <a:schemeClr val="accent1"/>
-          </a:lnRef>
-          <a:fillRef idx="3">
-            <a:schemeClr val="accent1"/>
-          </a:fillRef>
-          <a:effectRef idx="2">
-            <a:schemeClr val="accent1"/>
-          </a:effectRef>
-          <a:fontRef idx="minor">
-            <a:schemeClr val="lt1"/>
-          </a:fontRef>
-        </p:style>
-        <p:txBody>
-          <a:bodyPr rtlCol="0" anchor="ctr"/>
-          <a:lstStyle/>
-          <a:p>
-            <a:pPr algn="ctr"/>
-          </a:p>
-        </p:txBody>
-      </p:sp>
-      <p:sp>
-        <p:nvSpPr>
-          <p:cNvPr id="40" name="TextBox 39"/>
-          <p:cNvSpPr txBox="1"/>
-          <p:nvPr/>
-        </p:nvSpPr>
-        <p:spPr>
-          <a:xfrm>
-            <a:off x="5948172" y="2490597"/>
-            <a:ext cx="644652" cy="219456"/>
-          </a:xfrm>
-          <a:prstGeom prst="rect">
-            <a:avLst/>
-          </a:prstGeom>
-          <a:noFill/>
-        </p:spPr>
-        <p:txBody>
-          <a:bodyPr wrap="square" lIns="0" rIns="0" tIns="0" bIns="0">
-            <a:spAutoFit/>
-          </a:bodyPr>
-          <a:lstStyle/>
-          <a:p>
-            <a:pPr algn="ctr"/>
-            <a:r>
-              <a:rPr sz="900" b="1">
-                <a:solidFill>
-                  <a:srgbClr val="FFFFFF"/>
-                </a:solidFill>
-                <a:latin typeface="Calibri"/>
-              </a:rPr>
-              <a:t>9</a:t>
-            </a:r>
-          </a:p>
-        </p:txBody>
-      </p:sp>
-      <p:sp>
-        <p:nvSpPr>
-          <p:cNvPr id="41" name="TextBox 40"/>
-          <p:cNvSpPr txBox="1"/>
-          <p:nvPr/>
-        </p:nvSpPr>
-        <p:spPr>
-          <a:xfrm>
-            <a:off x="5673852" y="2065401"/>
-            <a:ext cx="1193292" cy="201168"/>
-          </a:xfrm>
-          <a:prstGeom prst="rect">
-            <a:avLst/>
-          </a:prstGeom>
-          <a:noFill/>
-        </p:spPr>
-        <p:txBody>
-          <a:bodyPr wrap="square" lIns="0" rIns="0" tIns="0" bIns="0">
-            <a:spAutoFit/>
-          </a:bodyPr>
-          <a:lstStyle/>
-          <a:p>
-            <a:pPr algn="ctr"/>
-            <a:r>
-              <a:rPr sz="1000" b="1">
-                <a:solidFill>
-                  <a:srgbClr val="1F3864"/>
-                </a:solidFill>
-                <a:latin typeface="Calibri"/>
-              </a:rPr>
-              <a:t>41</a:t>
-            </a:r>
-          </a:p>
-        </p:txBody>
-      </p:sp>
-      <p:sp>
-        <p:nvSpPr>
-          <p:cNvPr id="42" name="TextBox 41"/>
-          <p:cNvSpPr txBox="1"/>
-          <p:nvPr/>
-        </p:nvSpPr>
-        <p:spPr>
-          <a:xfrm>
-            <a:off x="5673852" y="5404103"/>
-            <a:ext cx="1193292" cy="201168"/>
-          </a:xfrm>
-          <a:prstGeom prst="rect">
-            <a:avLst/>
-          </a:prstGeom>
-          <a:noFill/>
-        </p:spPr>
-        <p:txBody>
-          <a:bodyPr wrap="square" lIns="0" rIns="0" tIns="0" bIns="0">
-            <a:spAutoFit/>
-          </a:bodyPr>
-          <a:lstStyle/>
-          <a:p>
-            <a:pPr algn="ctr"/>
-            <a:r>
-              <a:rPr sz="1000" b="1">
-                <a:solidFill>
-                  <a:srgbClr val="404040"/>
-                </a:solidFill>
-                <a:latin typeface="Calibri"/>
-              </a:rPr>
-              <a:t>S5</a:t>
-            </a:r>
-          </a:p>
-        </p:txBody>
-      </p:sp>
-      <p:sp>
-        <p:nvSpPr>
-          <p:cNvPr id="43" name="Rectangle 42"/>
-          <p:cNvSpPr/>
-          <p:nvPr/>
-        </p:nvSpPr>
-        <p:spPr>
-          <a:xfrm>
-            <a:off x="7022592" y="3677602"/>
-            <a:ext cx="644652" cy="1671637"/>
-          </a:xfrm>
-          <a:prstGeom prst="rect">
-            <a:avLst/>
-          </a:prstGeom>
-          <a:solidFill>
-            <a:srgbClr val="843C0C"/>
-          </a:solidFill>
-          <a:ln w="6350">
-            <a:solidFill>
-              <a:srgbClr val="FFFFFF"/>
-            </a:solidFill>
-          </a:ln>
-          <a:effectLst/>
-        </p:spPr>
-        <p:style>
-          <a:lnRef idx="1">
-            <a:schemeClr val="accent1"/>
-          </a:lnRef>
-          <a:fillRef idx="3">
-            <a:schemeClr val="accent1"/>
-          </a:fillRef>
-          <a:effectRef idx="2">
-            <a:schemeClr val="accent1"/>
-          </a:effectRef>
-          <a:fontRef idx="minor">
-            <a:schemeClr val="lt1"/>
-          </a:fontRef>
-        </p:style>
-        <p:txBody>
-          <a:bodyPr rtlCol="0" anchor="ctr"/>
-          <a:lstStyle/>
-          <a:p>
-            <a:pPr algn="ctr"/>
-          </a:p>
-        </p:txBody>
-      </p:sp>
-      <p:sp>
-        <p:nvSpPr>
-          <p:cNvPr id="44" name="TextBox 43"/>
-          <p:cNvSpPr txBox="1"/>
-          <p:nvPr/>
-        </p:nvSpPr>
-        <p:spPr>
-          <a:xfrm>
-            <a:off x="7022592" y="4403693"/>
-            <a:ext cx="644652" cy="219456"/>
-          </a:xfrm>
-          <a:prstGeom prst="rect">
-            <a:avLst/>
-          </a:prstGeom>
-          <a:noFill/>
-        </p:spPr>
-        <p:txBody>
-          <a:bodyPr wrap="square" lIns="0" rIns="0" tIns="0" bIns="0">
+          <a:bodyPr wrap="square" lIns="0" tIns="0" rIns="0" bIns="0">
             <a:spAutoFit/>
           </a:bodyPr>
           <a:lstStyle/>
@@ -6132,60 +7007,14 @@
       </p:sp>
       <p:sp>
         <p:nvSpPr>
-          <p:cNvPr id="45" name="Rectangle 44"/>
-          <p:cNvSpPr/>
-          <p:nvPr/>
-        </p:nvSpPr>
-        <p:spPr>
-          <a:xfrm>
-            <a:off x="7022592" y="2340292"/>
-            <a:ext cx="644652" cy="1337310"/>
-          </a:xfrm>
-          <a:prstGeom prst="rect">
-            <a:avLst/>
-          </a:prstGeom>
-          <a:solidFill>
-            <a:srgbClr val="7B7B7B"/>
-          </a:solidFill>
-          <a:ln w="6350">
-            <a:solidFill>
-              <a:srgbClr val="FFFFFF"/>
-            </a:solidFill>
-          </a:ln>
-          <a:effectLst/>
-        </p:spPr>
-        <p:style>
-          <a:lnRef idx="1">
-            <a:schemeClr val="accent1"/>
-          </a:lnRef>
-          <a:fillRef idx="3">
-            <a:schemeClr val="accent1"/>
-          </a:fillRef>
-          <a:effectRef idx="2">
-            <a:schemeClr val="accent1"/>
-          </a:effectRef>
-          <a:fontRef idx="minor">
-            <a:schemeClr val="lt1"/>
-          </a:fontRef>
-        </p:style>
-        <p:txBody>
-          <a:bodyPr rtlCol="0" anchor="ctr"/>
-          <a:lstStyle/>
-          <a:p>
-            <a:pPr algn="ctr"/>
-          </a:p>
-        </p:txBody>
-      </p:sp>
-      <p:sp>
-        <p:nvSpPr>
-          <p:cNvPr id="46" name="TextBox 45"/>
+          <p:cNvPr id="37" name="TextBox 36"/>
           <p:cNvSpPr txBox="1"/>
           <p:nvPr/>
         </p:nvSpPr>
         <p:spPr>
           <a:xfrm>
-            <a:off x="7022592" y="2899219"/>
-            <a:ext cx="644652" cy="219456"/>
+            <a:off x="6399085" y="3620395"/>
+            <a:ext cx="1354455" cy="201168"/>
           </a:xfrm>
           <a:prstGeom prst="rect">
             <a:avLst/>
@@ -6193,88 +7022,7 @@
           <a:noFill/>
         </p:spPr>
         <p:txBody>
-          <a:bodyPr wrap="square" lIns="0" rIns="0" tIns="0" bIns="0">
-            <a:spAutoFit/>
-          </a:bodyPr>
-          <a:lstStyle/>
-          <a:p>
-            <a:pPr algn="ctr"/>
-            <a:r>
-              <a:rPr sz="900" b="1">
-                <a:solidFill>
-                  <a:srgbClr val="FFFFFF"/>
-                </a:solidFill>
-                <a:latin typeface="Calibri"/>
-              </a:rPr>
-              <a:t>11</a:t>
-            </a:r>
-          </a:p>
-        </p:txBody>
-      </p:sp>
-      <p:sp>
-        <p:nvSpPr>
-          <p:cNvPr id="47" name="Rectangle 46"/>
-          <p:cNvSpPr/>
-          <p:nvPr/>
-        </p:nvSpPr>
-        <p:spPr>
-          <a:xfrm>
-            <a:off x="7022592" y="2265997"/>
-            <a:ext cx="644652" cy="74294"/>
-          </a:xfrm>
-          <a:prstGeom prst="rect">
-            <a:avLst/>
-          </a:prstGeom>
-          <a:solidFill>
-            <a:srgbClr val="BF8F00"/>
-          </a:solidFill>
-          <a:ln w="6350">
-            <a:solidFill>
-              <a:srgbClr val="FFFFFF"/>
-            </a:solidFill>
-          </a:ln>
-          <a:effectLst/>
-        </p:spPr>
-        <p:style>
-          <a:lnRef idx="1">
-            <a:schemeClr val="accent1"/>
-          </a:lnRef>
-          <a:fillRef idx="3">
-            <a:schemeClr val="accent1"/>
-          </a:fillRef>
-          <a:effectRef idx="2">
-            <a:schemeClr val="accent1"/>
-          </a:effectRef>
-          <a:fontRef idx="minor">
-            <a:schemeClr val="lt1"/>
-          </a:fontRef>
-        </p:style>
-        <p:txBody>
-          <a:bodyPr rtlCol="0" anchor="ctr"/>
-          <a:lstStyle/>
-          <a:p>
-            <a:pPr algn="ctr"/>
-          </a:p>
-        </p:txBody>
-      </p:sp>
-      <p:sp>
-        <p:nvSpPr>
-          <p:cNvPr id="48" name="TextBox 47"/>
-          <p:cNvSpPr txBox="1"/>
-          <p:nvPr/>
-        </p:nvSpPr>
-        <p:spPr>
-          <a:xfrm>
-            <a:off x="6748272" y="2028253"/>
-            <a:ext cx="1193292" cy="201168"/>
-          </a:xfrm>
-          <a:prstGeom prst="rect">
-            <a:avLst/>
-          </a:prstGeom>
-          <a:noFill/>
-        </p:spPr>
-        <p:txBody>
-          <a:bodyPr wrap="square" lIns="0" rIns="0" tIns="0" bIns="0">
+          <a:bodyPr wrap="square" lIns="0" tIns="0" rIns="0" bIns="0">
             <a:spAutoFit/>
           </a:bodyPr>
           <a:lstStyle/>
@@ -6287,21 +7035,21 @@
                 </a:solidFill>
                 <a:latin typeface="Calibri"/>
               </a:rPr>
-              <a:t>41.5</a:t>
-            </a:r>
-          </a:p>
-        </p:txBody>
-      </p:sp>
-      <p:sp>
-        <p:nvSpPr>
-          <p:cNvPr id="49" name="TextBox 48"/>
+              <a:t>20.1</a:t>
+            </a:r>
+          </a:p>
+        </p:txBody>
+      </p:sp>
+      <p:sp>
+        <p:nvSpPr>
+          <p:cNvPr id="38" name="TextBox 37"/>
           <p:cNvSpPr txBox="1"/>
           <p:nvPr/>
         </p:nvSpPr>
         <p:spPr>
           <a:xfrm>
-            <a:off x="6748272" y="5404103"/>
-            <a:ext cx="1193292" cy="201168"/>
+            <a:off x="6399085" y="5404103"/>
+            <a:ext cx="1354455" cy="201168"/>
           </a:xfrm>
           <a:prstGeom prst="rect">
             <a:avLst/>
@@ -6309,7 +7057,7 @@
           <a:noFill/>
         </p:spPr>
         <p:txBody>
-          <a:bodyPr wrap="square" lIns="0" rIns="0" tIns="0" bIns="0">
+          <a:bodyPr wrap="square" lIns="0" tIns="0" rIns="0" bIns="0">
             <a:spAutoFit/>
           </a:bodyPr>
           <a:lstStyle/>
@@ -6322,14 +7070,14 @@
                 </a:solidFill>
                 <a:latin typeface="Calibri"/>
               </a:rPr>
-              <a:t>S6</a:t>
+              <a:t>S4</a:t>
             </a:r>
           </a:p>
         </p:txBody>
       </p:sp>
       <p:cxnSp>
         <p:nvCxnSpPr>
-          <p:cNvPr id="50" name="Connector 49"/>
+          <p:cNvPr id="39" name="Connector 38"/>
           <p:cNvCxnSpPr/>
           <p:nvPr/>
         </p:nvCxnSpPr>
@@ -6366,7 +7114,7 @@
       </p:cxnSp>
       <p:sp>
         <p:nvSpPr>
-          <p:cNvPr id="51" name="TextBox 50"/>
+          <p:cNvPr id="40" name="TextBox 39"/>
           <p:cNvSpPr txBox="1"/>
           <p:nvPr/>
         </p:nvSpPr>
@@ -6381,7 +7129,7 @@
           <a:noFill/>
         </p:spPr>
         <p:txBody>
-          <a:bodyPr wrap="square" lIns="0" rIns="0" tIns="0" bIns="0">
+          <a:bodyPr wrap="square" lIns="0" tIns="0" rIns="0" bIns="0">
             <a:spAutoFit/>
           </a:bodyPr>
           <a:lstStyle/>
@@ -6401,7 +7149,7 @@
       </p:sp>
       <p:sp>
         <p:nvSpPr>
-          <p:cNvPr id="52" name="TextBox 51"/>
+          <p:cNvPr id="41" name="TextBox 40"/>
           <p:cNvSpPr txBox="1"/>
           <p:nvPr/>
         </p:nvSpPr>
@@ -6416,7 +7164,7 @@
           <a:noFill/>
         </p:spPr>
         <p:txBody>
-          <a:bodyPr wrap="square" lIns="0" rIns="0" tIns="0" bIns="0">
+          <a:bodyPr wrap="square" lIns="0" tIns="0" rIns="0" bIns="0">
             <a:spAutoFit/>
           </a:bodyPr>
           <a:lstStyle/>
@@ -6436,7 +7184,7 @@
       </p:sp>
       <p:sp>
         <p:nvSpPr>
-          <p:cNvPr id="53" name="Rectangle 52"/>
+          <p:cNvPr id="42" name="Rectangle 41"/>
           <p:cNvSpPr/>
           <p:nvPr/>
         </p:nvSpPr>
@@ -6475,12 +7223,13 @@
           <a:lstStyle/>
           <a:p>
             <a:pPr algn="ctr"/>
-          </a:p>
-        </p:txBody>
-      </p:sp>
-      <p:sp>
-        <p:nvSpPr>
-          <p:cNvPr id="54" name="TextBox 53"/>
+            <a:endParaRPr/>
+          </a:p>
+        </p:txBody>
+      </p:sp>
+      <p:sp>
+        <p:nvSpPr>
+          <p:cNvPr id="43" name="TextBox 42"/>
           <p:cNvSpPr txBox="1"/>
           <p:nvPr/>
         </p:nvSpPr>
@@ -6495,7 +7244,7 @@
           <a:noFill/>
         </p:spPr>
         <p:txBody>
-          <a:bodyPr wrap="square" lIns="0" rIns="0" tIns="0" bIns="0">
+          <a:bodyPr wrap="square" lIns="0" tIns="0" rIns="0" bIns="0">
             <a:spAutoFit/>
           </a:bodyPr>
           <a:lstStyle/>
@@ -6517,20 +7266,20 @@
                 </a:solidFill>
                 <a:latin typeface="Calibri"/>
               </a:rPr>
-              <a:t>Connector Prep</a:t>
-            </a:r>
-          </a:p>
-        </p:txBody>
-      </p:sp>
-      <p:sp>
-        <p:nvSpPr>
-          <p:cNvPr id="55" name="Rectangle 54"/>
+              <a:t>Rivet Nut Installation</a:t>
+            </a:r>
+          </a:p>
+        </p:txBody>
+      </p:sp>
+      <p:sp>
+        <p:nvSpPr>
+          <p:cNvPr id="44" name="Rectangle 43"/>
           <p:cNvSpPr/>
           <p:nvPr/>
         </p:nvSpPr>
         <p:spPr>
           <a:xfrm>
-            <a:off x="8229600" y="2071116"/>
+            <a:off x="8229600" y="2103120"/>
             <a:ext cx="146304" cy="146304"/>
           </a:xfrm>
           <a:prstGeom prst="rect">
@@ -6563,18 +7312,19 @@
           <a:lstStyle/>
           <a:p>
             <a:pPr algn="ctr"/>
-          </a:p>
-        </p:txBody>
-      </p:sp>
-      <p:sp>
-        <p:nvSpPr>
-          <p:cNvPr id="56" name="TextBox 55"/>
+            <a:endParaRPr/>
+          </a:p>
+        </p:txBody>
+      </p:sp>
+      <p:sp>
+        <p:nvSpPr>
+          <p:cNvPr id="45" name="TextBox 44"/>
           <p:cNvSpPr txBox="1"/>
           <p:nvPr/>
         </p:nvSpPr>
         <p:spPr>
           <a:xfrm>
-            <a:off x="8467344" y="2034540"/>
+            <a:off x="8467344" y="2066543"/>
             <a:ext cx="2834640" cy="274320"/>
           </a:xfrm>
           <a:prstGeom prst="rect">
@@ -6583,7 +7333,7 @@
           <a:noFill/>
         </p:spPr>
         <p:txBody>
-          <a:bodyPr wrap="square" lIns="0" rIns="0" tIns="0" bIns="0">
+          <a:bodyPr wrap="square" lIns="0" tIns="0" rIns="0" bIns="0">
             <a:spAutoFit/>
           </a:bodyPr>
           <a:lstStyle/>
@@ -6605,20 +7355,20 @@
                 </a:solidFill>
                 <a:latin typeface="Calibri"/>
               </a:rPr>
-              <a:t>Leg Assembly</a:t>
-            </a:r>
-          </a:p>
-        </p:txBody>
-      </p:sp>
-      <p:sp>
-        <p:nvSpPr>
-          <p:cNvPr id="57" name="Rectangle 56"/>
+              <a:t>Connector Pre-Assembly</a:t>
+            </a:r>
+          </a:p>
+        </p:txBody>
+      </p:sp>
+      <p:sp>
+        <p:nvSpPr>
+          <p:cNvPr id="46" name="Rectangle 45"/>
           <p:cNvSpPr/>
           <p:nvPr/>
         </p:nvSpPr>
         <p:spPr>
           <a:xfrm>
-            <a:off x="8229600" y="2386584"/>
+            <a:off x="8229600" y="2450592"/>
             <a:ext cx="146304" cy="146304"/>
           </a:xfrm>
           <a:prstGeom prst="rect">
@@ -6651,18 +7401,19 @@
           <a:lstStyle/>
           <a:p>
             <a:pPr algn="ctr"/>
-          </a:p>
-        </p:txBody>
-      </p:sp>
-      <p:sp>
-        <p:nvSpPr>
-          <p:cNvPr id="58" name="TextBox 57"/>
+            <a:endParaRPr/>
+          </a:p>
+        </p:txBody>
+      </p:sp>
+      <p:sp>
+        <p:nvSpPr>
+          <p:cNvPr id="47" name="TextBox 46"/>
           <p:cNvSpPr txBox="1"/>
           <p:nvPr/>
         </p:nvSpPr>
         <p:spPr>
           <a:xfrm>
-            <a:off x="8467344" y="2350008"/>
+            <a:off x="8467344" y="2414016"/>
             <a:ext cx="2834640" cy="274320"/>
           </a:xfrm>
           <a:prstGeom prst="rect">
@@ -6671,7 +7422,7 @@
           <a:noFill/>
         </p:spPr>
         <p:txBody>
-          <a:bodyPr wrap="square" lIns="0" rIns="0" tIns="0" bIns="0">
+          <a:bodyPr wrap="square" lIns="0" tIns="0" rIns="0" bIns="0">
             <a:spAutoFit/>
           </a:bodyPr>
           <a:lstStyle/>
@@ -6693,20 +7444,20 @@
                 </a:solidFill>
                 <a:latin typeface="Calibri"/>
               </a:rPr>
-              <a:t>Arms Assembly</a:t>
-            </a:r>
-          </a:p>
-        </p:txBody>
-      </p:sp>
-      <p:sp>
-        <p:nvSpPr>
-          <p:cNvPr id="59" name="Rectangle 58"/>
+              <a:t>Connector Plate Installation</a:t>
+            </a:r>
+          </a:p>
+        </p:txBody>
+      </p:sp>
+      <p:sp>
+        <p:nvSpPr>
+          <p:cNvPr id="48" name="Rectangle 47"/>
           <p:cNvSpPr/>
           <p:nvPr/>
         </p:nvSpPr>
         <p:spPr>
           <a:xfrm>
-            <a:off x="8229600" y="2702051"/>
+            <a:off x="8229600" y="2798064"/>
             <a:ext cx="146304" cy="146304"/>
           </a:xfrm>
           <a:prstGeom prst="rect">
@@ -6739,18 +7490,19 @@
           <a:lstStyle/>
           <a:p>
             <a:pPr algn="ctr"/>
-          </a:p>
-        </p:txBody>
-      </p:sp>
-      <p:sp>
-        <p:nvSpPr>
-          <p:cNvPr id="60" name="TextBox 59"/>
+            <a:endParaRPr/>
+          </a:p>
+        </p:txBody>
+      </p:sp>
+      <p:sp>
+        <p:nvSpPr>
+          <p:cNvPr id="49" name="TextBox 48"/>
           <p:cNvSpPr txBox="1"/>
           <p:nvPr/>
         </p:nvSpPr>
         <p:spPr>
           <a:xfrm>
-            <a:off x="8467344" y="2665475"/>
+            <a:off x="8467344" y="2761488"/>
             <a:ext cx="2834640" cy="274320"/>
           </a:xfrm>
           <a:prstGeom prst="rect">
@@ -6759,7 +7511,7 @@
           <a:noFill/>
         </p:spPr>
         <p:txBody>
-          <a:bodyPr wrap="square" lIns="0" rIns="0" tIns="0" bIns="0">
+          <a:bodyPr wrap="square" lIns="0" tIns="0" rIns="0" bIns="0">
             <a:spAutoFit/>
           </a:bodyPr>
           <a:lstStyle/>
@@ -6781,20 +7533,20 @@
                 </a:solidFill>
                 <a:latin typeface="Calibri"/>
               </a:rPr>
-              <a:t>Seat Frame Assembly</a:t>
-            </a:r>
-          </a:p>
-        </p:txBody>
-      </p:sp>
-      <p:sp>
-        <p:nvSpPr>
-          <p:cNvPr id="61" name="Rectangle 60"/>
+              <a:t>Connector Attachment</a:t>
+            </a:r>
+          </a:p>
+        </p:txBody>
+      </p:sp>
+      <p:sp>
+        <p:nvSpPr>
+          <p:cNvPr id="50" name="Rectangle 49"/>
           <p:cNvSpPr/>
           <p:nvPr/>
         </p:nvSpPr>
         <p:spPr>
           <a:xfrm>
-            <a:off x="8229600" y="3017520"/>
+            <a:off x="8229600" y="3145536"/>
             <a:ext cx="146304" cy="146304"/>
           </a:xfrm>
           <a:prstGeom prst="rect">
@@ -6827,18 +7579,19 @@
           <a:lstStyle/>
           <a:p>
             <a:pPr algn="ctr"/>
-          </a:p>
-        </p:txBody>
-      </p:sp>
-      <p:sp>
-        <p:nvSpPr>
-          <p:cNvPr id="62" name="TextBox 61"/>
+            <a:endParaRPr/>
+          </a:p>
+        </p:txBody>
+      </p:sp>
+      <p:sp>
+        <p:nvSpPr>
+          <p:cNvPr id="51" name="TextBox 50"/>
           <p:cNvSpPr txBox="1"/>
           <p:nvPr/>
         </p:nvSpPr>
         <p:spPr>
           <a:xfrm>
-            <a:off x="8467344" y="2980944"/>
+            <a:off x="8467344" y="3108960"/>
             <a:ext cx="2834640" cy="274320"/>
           </a:xfrm>
           <a:prstGeom prst="rect">
@@ -6847,7 +7600,7 @@
           <a:noFill/>
         </p:spPr>
         <p:txBody>
-          <a:bodyPr wrap="square" lIns="0" rIns="0" tIns="0" bIns="0">
+          <a:bodyPr wrap="square" lIns="0" tIns="0" rIns="0" bIns="0">
             <a:spAutoFit/>
           </a:bodyPr>
           <a:lstStyle/>
@@ -6869,20 +7622,20 @@
                 </a:solidFill>
                 <a:latin typeface="Calibri"/>
               </a:rPr>
-              <a:t>Back Frame Assembly</a:t>
-            </a:r>
-          </a:p>
-        </p:txBody>
-      </p:sp>
-      <p:sp>
-        <p:nvSpPr>
-          <p:cNvPr id="63" name="Rectangle 62"/>
+              <a:t>Frame Sub-Assembly</a:t>
+            </a:r>
+          </a:p>
+        </p:txBody>
+      </p:sp>
+      <p:sp>
+        <p:nvSpPr>
+          <p:cNvPr id="52" name="Rectangle 51"/>
           <p:cNvSpPr/>
           <p:nvPr/>
         </p:nvSpPr>
         <p:spPr>
           <a:xfrm>
-            <a:off x="8229600" y="3332988"/>
+            <a:off x="8229600" y="3493008"/>
             <a:ext cx="146304" cy="146304"/>
           </a:xfrm>
           <a:prstGeom prst="rect">
@@ -6915,18 +7668,19 @@
           <a:lstStyle/>
           <a:p>
             <a:pPr algn="ctr"/>
-          </a:p>
-        </p:txBody>
-      </p:sp>
-      <p:sp>
-        <p:nvSpPr>
-          <p:cNvPr id="64" name="TextBox 63"/>
+            <a:endParaRPr/>
+          </a:p>
+        </p:txBody>
+      </p:sp>
+      <p:sp>
+        <p:nvSpPr>
+          <p:cNvPr id="53" name="TextBox 52"/>
           <p:cNvSpPr txBox="1"/>
           <p:nvPr/>
         </p:nvSpPr>
         <p:spPr>
           <a:xfrm>
-            <a:off x="8467344" y="3296412"/>
+            <a:off x="8467344" y="3456432"/>
             <a:ext cx="2834640" cy="274320"/>
           </a:xfrm>
           <a:prstGeom prst="rect">
@@ -6935,7 +7689,7 @@
           <a:noFill/>
         </p:spPr>
         <p:txBody>
-          <a:bodyPr wrap="square" lIns="0" rIns="0" tIns="0" bIns="0">
+          <a:bodyPr wrap="square" lIns="0" tIns="0" rIns="0" bIns="0">
             <a:spAutoFit/>
           </a:bodyPr>
           <a:lstStyle/>
@@ -6957,27 +7711,27 @@
                 </a:solidFill>
                 <a:latin typeface="Calibri"/>
               </a:rPr>
-              <a:t>Attaching Arms</a:t>
-            </a:r>
-          </a:p>
-        </p:txBody>
-      </p:sp>
-      <p:sp>
-        <p:nvSpPr>
-          <p:cNvPr id="65" name="Rectangle 64"/>
+              <a:t>Frame Connection Assembly</a:t>
+            </a:r>
+          </a:p>
+        </p:txBody>
+      </p:sp>
+      <p:sp>
+        <p:nvSpPr>
+          <p:cNvPr id="54" name="Rectangle 53"/>
           <p:cNvSpPr/>
           <p:nvPr/>
         </p:nvSpPr>
         <p:spPr>
           <a:xfrm>
-            <a:off x="8229600" y="3648456"/>
+            <a:off x="8229600" y="3840479"/>
             <a:ext cx="146304" cy="146304"/>
           </a:xfrm>
           <a:prstGeom prst="rect">
             <a:avLst/>
           </a:prstGeom>
           <a:solidFill>
-            <a:srgbClr val="997300"/>
+            <a:srgbClr val="843C0C"/>
           </a:solidFill>
           <a:ln>
             <a:noFill/>
@@ -7003,18 +7757,19 @@
           <a:lstStyle/>
           <a:p>
             <a:pPr algn="ctr"/>
-          </a:p>
-        </p:txBody>
-      </p:sp>
-      <p:sp>
-        <p:nvSpPr>
-          <p:cNvPr id="66" name="TextBox 65"/>
+            <a:endParaRPr/>
+          </a:p>
+        </p:txBody>
+      </p:sp>
+      <p:sp>
+        <p:nvSpPr>
+          <p:cNvPr id="55" name="TextBox 54"/>
           <p:cNvSpPr txBox="1"/>
           <p:nvPr/>
         </p:nvSpPr>
         <p:spPr>
           <a:xfrm>
-            <a:off x="8467344" y="3611879"/>
+            <a:off x="8467344" y="3803904"/>
             <a:ext cx="2834640" cy="274320"/>
           </a:xfrm>
           <a:prstGeom prst="rect">
@@ -7023,7 +7778,7 @@
           <a:noFill/>
         </p:spPr>
         <p:txBody>
-          <a:bodyPr wrap="square" lIns="0" rIns="0" tIns="0" bIns="0">
+          <a:bodyPr wrap="square" lIns="0" tIns="0" rIns="0" bIns="0">
             <a:spAutoFit/>
           </a:bodyPr>
           <a:lstStyle/>
@@ -7045,20 +7800,20 @@
                 </a:solidFill>
                 <a:latin typeface="Calibri"/>
               </a:rPr>
-              <a:t>Attaching Back Support</a:t>
-            </a:r>
-          </a:p>
-        </p:txBody>
-      </p:sp>
-      <p:sp>
-        <p:nvSpPr>
-          <p:cNvPr id="67" name="Rectangle 66"/>
+              <a:t>Seat Support Frame Assembly</a:t>
+            </a:r>
+          </a:p>
+        </p:txBody>
+      </p:sp>
+      <p:sp>
+        <p:nvSpPr>
+          <p:cNvPr id="56" name="Rectangle 55"/>
           <p:cNvSpPr/>
           <p:nvPr/>
         </p:nvSpPr>
         <p:spPr>
           <a:xfrm>
-            <a:off x="8229600" y="3963923"/>
+            <a:off x="8229600" y="4187952"/>
             <a:ext cx="146304" cy="146304"/>
           </a:xfrm>
           <a:prstGeom prst="rect">
@@ -7091,18 +7846,19 @@
           <a:lstStyle/>
           <a:p>
             <a:pPr algn="ctr"/>
-          </a:p>
-        </p:txBody>
-      </p:sp>
-      <p:sp>
-        <p:nvSpPr>
-          <p:cNvPr id="68" name="TextBox 67"/>
+            <a:endParaRPr/>
+          </a:p>
+        </p:txBody>
+      </p:sp>
+      <p:sp>
+        <p:nvSpPr>
+          <p:cNvPr id="57" name="TextBox 56"/>
           <p:cNvSpPr txBox="1"/>
           <p:nvPr/>
         </p:nvSpPr>
         <p:spPr>
           <a:xfrm>
-            <a:off x="8467344" y="3927348"/>
+            <a:off x="8467344" y="4151376"/>
             <a:ext cx="2834640" cy="274320"/>
           </a:xfrm>
           <a:prstGeom prst="rect">
@@ -7111,7 +7867,7 @@
           <a:noFill/>
         </p:spPr>
         <p:txBody>
-          <a:bodyPr wrap="square" lIns="0" rIns="0" tIns="0" bIns="0">
+          <a:bodyPr wrap="square" lIns="0" tIns="0" rIns="0" bIns="0">
             <a:spAutoFit/>
           </a:bodyPr>
           <a:lstStyle/>
@@ -7133,20 +7889,20 @@
                 </a:solidFill>
                 <a:latin typeface="Calibri"/>
               </a:rPr>
-              <a:t>Leg Finishing</a:t>
-            </a:r>
-          </a:p>
-        </p:txBody>
-      </p:sp>
-      <p:sp>
-        <p:nvSpPr>
-          <p:cNvPr id="69" name="Rectangle 68"/>
+              <a:t>Trellis Frame Installation</a:t>
+            </a:r>
+          </a:p>
+        </p:txBody>
+      </p:sp>
+      <p:sp>
+        <p:nvSpPr>
+          <p:cNvPr id="58" name="Rectangle 57"/>
           <p:cNvSpPr/>
           <p:nvPr/>
         </p:nvSpPr>
         <p:spPr>
           <a:xfrm>
-            <a:off x="8229600" y="4279392"/>
+            <a:off x="8229600" y="4535423"/>
             <a:ext cx="146304" cy="146304"/>
           </a:xfrm>
           <a:prstGeom prst="rect">
@@ -7179,18 +7935,19 @@
           <a:lstStyle/>
           <a:p>
             <a:pPr algn="ctr"/>
-          </a:p>
-        </p:txBody>
-      </p:sp>
-      <p:sp>
-        <p:nvSpPr>
-          <p:cNvPr id="70" name="TextBox 69"/>
+            <a:endParaRPr/>
+          </a:p>
+        </p:txBody>
+      </p:sp>
+      <p:sp>
+        <p:nvSpPr>
+          <p:cNvPr id="59" name="TextBox 58"/>
           <p:cNvSpPr txBox="1"/>
           <p:nvPr/>
         </p:nvSpPr>
         <p:spPr>
           <a:xfrm>
-            <a:off x="8467344" y="4242816"/>
+            <a:off x="8467344" y="4498848"/>
             <a:ext cx="2834640" cy="274320"/>
           </a:xfrm>
           <a:prstGeom prst="rect">
@@ -7199,7 +7956,7 @@
           <a:noFill/>
         </p:spPr>
         <p:txBody>
-          <a:bodyPr wrap="square" lIns="0" rIns="0" tIns="0" bIns="0">
+          <a:bodyPr wrap="square" lIns="0" tIns="0" rIns="0" bIns="0">
             <a:spAutoFit/>
           </a:bodyPr>
           <a:lstStyle/>
@@ -7221,65 +7978,21 @@
                 </a:solidFill>
                 <a:latin typeface="Calibri"/>
               </a:rPr>
-              <a:t>Seat Support Frame</a:t>
-            </a:r>
-          </a:p>
-        </p:txBody>
-      </p:sp>
-      <p:sp>
-        <p:nvSpPr>
-          <p:cNvPr id="71" name="Rectangle 70"/>
-          <p:cNvSpPr/>
-          <p:nvPr/>
-        </p:nvSpPr>
-        <p:spPr>
-          <a:xfrm>
-            <a:off x="8229600" y="4594859"/>
-            <a:ext cx="146304" cy="146304"/>
-          </a:xfrm>
-          <a:prstGeom prst="rect">
-            <a:avLst/>
-          </a:prstGeom>
-          <a:solidFill>
-            <a:srgbClr val="7B7B7B"/>
-          </a:solidFill>
-          <a:ln>
-            <a:noFill/>
-          </a:ln>
-          <a:effectLst/>
-        </p:spPr>
-        <p:style>
-          <a:lnRef idx="1">
-            <a:schemeClr val="accent1"/>
-          </a:lnRef>
-          <a:fillRef idx="3">
-            <a:schemeClr val="accent1"/>
-          </a:fillRef>
-          <a:effectRef idx="2">
-            <a:schemeClr val="accent1"/>
-          </a:effectRef>
-          <a:fontRef idx="minor">
-            <a:schemeClr val="lt1"/>
-          </a:fontRef>
-        </p:style>
-        <p:txBody>
-          <a:bodyPr rtlCol="0" anchor="ctr"/>
-          <a:lstStyle/>
-          <a:p>
-            <a:pPr algn="ctr"/>
-          </a:p>
-        </p:txBody>
-      </p:sp>
-      <p:sp>
-        <p:nvSpPr>
-          <p:cNvPr id="72" name="TextBox 71"/>
+              <a:t>Corner Cap &amp; End Cap</a:t>
+            </a:r>
+          </a:p>
+        </p:txBody>
+      </p:sp>
+      <p:sp>
+        <p:nvSpPr>
+          <p:cNvPr id="60" name="TextBox 59"/>
           <p:cNvSpPr txBox="1"/>
           <p:nvPr/>
         </p:nvSpPr>
         <p:spPr>
           <a:xfrm>
-            <a:off x="8467344" y="4558283"/>
-            <a:ext cx="2834640" cy="274320"/>
+            <a:off x="1024128" y="5806440"/>
+            <a:ext cx="10241280" cy="457200"/>
           </a:xfrm>
           <a:prstGeom prst="rect">
             <a:avLst/>
@@ -7287,139 +8000,7 @@
           <a:noFill/>
         </p:spPr>
         <p:txBody>
-          <a:bodyPr wrap="square" lIns="0" rIns="0" tIns="0" bIns="0">
-            <a:spAutoFit/>
-          </a:bodyPr>
-          <a:lstStyle/>
-          <a:p>
-            <a:pPr algn="l"/>
-            <a:r>
-              <a:rPr sz="950" b="1">
-                <a:solidFill>
-                  <a:srgbClr val="1F3864"/>
-                </a:solidFill>
-                <a:latin typeface="Calibri"/>
-              </a:rPr>
-              <a:t>#11  </a:t>
-            </a:r>
-            <a:r>
-              <a:rPr sz="950" b="0">
-                <a:solidFill>
-                  <a:srgbClr val="404040"/>
-                </a:solidFill>
-                <a:latin typeface="Calibri"/>
-              </a:rPr>
-              <a:t>Attaching Seat Frame</a:t>
-            </a:r>
-          </a:p>
-        </p:txBody>
-      </p:sp>
-      <p:sp>
-        <p:nvSpPr>
-          <p:cNvPr id="73" name="Rectangle 72"/>
-          <p:cNvSpPr/>
-          <p:nvPr/>
-        </p:nvSpPr>
-        <p:spPr>
-          <a:xfrm>
-            <a:off x="8229600" y="4910327"/>
-            <a:ext cx="146304" cy="146304"/>
-          </a:xfrm>
-          <a:prstGeom prst="rect">
-            <a:avLst/>
-          </a:prstGeom>
-          <a:solidFill>
-            <a:srgbClr val="BF8F00"/>
-          </a:solidFill>
-          <a:ln>
-            <a:noFill/>
-          </a:ln>
-          <a:effectLst/>
-        </p:spPr>
-        <p:style>
-          <a:lnRef idx="1">
-            <a:schemeClr val="accent1"/>
-          </a:lnRef>
-          <a:fillRef idx="3">
-            <a:schemeClr val="accent1"/>
-          </a:fillRef>
-          <a:effectRef idx="2">
-            <a:schemeClr val="accent1"/>
-          </a:effectRef>
-          <a:fontRef idx="minor">
-            <a:schemeClr val="lt1"/>
-          </a:fontRef>
-        </p:style>
-        <p:txBody>
-          <a:bodyPr rtlCol="0" anchor="ctr"/>
-          <a:lstStyle/>
-          <a:p>
-            <a:pPr algn="ctr"/>
-          </a:p>
-        </p:txBody>
-      </p:sp>
-      <p:sp>
-        <p:nvSpPr>
-          <p:cNvPr id="74" name="TextBox 73"/>
-          <p:cNvSpPr txBox="1"/>
-          <p:nvPr/>
-        </p:nvSpPr>
-        <p:spPr>
-          <a:xfrm>
-            <a:off x="8467344" y="4873752"/>
-            <a:ext cx="2834640" cy="274320"/>
-          </a:xfrm>
-          <a:prstGeom prst="rect">
-            <a:avLst/>
-          </a:prstGeom>
-          <a:noFill/>
-        </p:spPr>
-        <p:txBody>
-          <a:bodyPr wrap="square" lIns="0" rIns="0" tIns="0" bIns="0">
-            <a:spAutoFit/>
-          </a:bodyPr>
-          <a:lstStyle/>
-          <a:p>
-            <a:pPr algn="l"/>
-            <a:r>
-              <a:rPr sz="950" b="1">
-                <a:solidFill>
-                  <a:srgbClr val="1F3864"/>
-                </a:solidFill>
-                <a:latin typeface="Calibri"/>
-              </a:rPr>
-              <a:t>#12  </a:t>
-            </a:r>
-            <a:r>
-              <a:rPr sz="950" b="0">
-                <a:solidFill>
-                  <a:srgbClr val="404040"/>
-                </a:solidFill>
-                <a:latin typeface="Calibri"/>
-              </a:rPr>
-              <a:t>Attach TUUCI Plate</a:t>
-            </a:r>
-          </a:p>
-        </p:txBody>
-      </p:sp>
-      <p:sp>
-        <p:nvSpPr>
-          <p:cNvPr id="75" name="TextBox 74"/>
-          <p:cNvSpPr txBox="1"/>
-          <p:nvPr/>
-        </p:nvSpPr>
-        <p:spPr>
-          <a:xfrm>
-            <a:off x="1024128" y="5806440"/>
-            <a:ext cx="10241280" cy="365760"/>
-          </a:xfrm>
-          <a:prstGeom prst="rect">
-            <a:avLst/>
-          </a:prstGeom>
-          <a:noFill/>
-        </p:spPr>
-        <p:txBody>
-          <a:bodyPr wrap="square" lIns="0" rIns="0" tIns="0" bIns="0">
+          <a:bodyPr wrap="square" lIns="0" tIns="0" rIns="0" bIns="0">
             <a:spAutoFit/>
           </a:bodyPr>
           <a:lstStyle/>
@@ -7432,16 +8013,7 @@
                 </a:solidFill>
                 <a:latin typeface="Calibri"/>
               </a:rPr>
-              <a:t>Takt 42 min   ·   Cycle time 41.5 min   ·   Capacity ~10 units/day   ·   88% line efficiency   ·   </a:t>
-            </a:r>
-            <a:r>
-              <a:rPr sz="1100" b="0">
-                <a:solidFill>
-                  <a:srgbClr val="404040"/>
-                </a:solidFill>
-                <a:latin typeface="Calibri"/>
-              </a:rPr>
-              <a:t>S2 = Arms built by 2 operators (64 → 32 min); Seat Frame (#5) &amp; Back Frame (#6) split across stations.</a:t>
+              <a:t>Takt 42 min   ·   Cycle time 36.8 min   ·   Capacity ~11 units/day   ·   84% line efficiency   ·   Seat Support (#8, 33 min) is the bottleneck — splitting it 2-up unlocks more output.</a:t>
             </a:r>
           </a:p>
         </p:txBody>
@@ -7451,6 +8023,151 @@
   <p:clrMapOvr>
     <a:masterClrMapping/>
   </p:clrMapOvr>
+</p:sld>
+</file>
+
+<file path=ppt/slides/slide9.xml><?xml version="1.0" encoding="utf-8"?>
+<p:sld xmlns:a="http://schemas.openxmlformats.org/drawingml/2006/main" xmlns:r="http://schemas.openxmlformats.org/officeDocument/2006/relationships" xmlns:p="http://schemas.openxmlformats.org/presentationml/2006/main">
+  <p:cSld>
+    <p:spTree>
+      <p:nvGrpSpPr>
+        <p:cNvPr id="1" name=""/>
+        <p:cNvGrpSpPr/>
+        <p:nvPr/>
+      </p:nvGrpSpPr>
+      <p:grpSpPr>
+        <a:xfrm>
+          <a:off x="0" y="0"/>
+          <a:ext cx="0" cy="0"/>
+          <a:chOff x="0" y="0"/>
+          <a:chExt cx="0" cy="0"/>
+        </a:xfrm>
+      </p:grpSpPr>
+      <p:sp>
+        <p:nvSpPr>
+          <p:cNvPr id="2" name="Title 1">
+            <a:extLst>
+              <a:ext uri="{FF2B5EF4-FFF2-40B4-BE49-F238E27FC236}">
+                <a16:creationId xmlns:a16="http://schemas.microsoft.com/office/drawing/2014/main" id="{5354F6A0-47EF-52F0-F471-A3C9F254EFB8}"/>
+              </a:ext>
+            </a:extLst>
+          </p:cNvPr>
+          <p:cNvSpPr>
+            <a:spLocks noGrp="1"/>
+          </p:cNvSpPr>
+          <p:nvPr>
+            <p:ph type="title"/>
+          </p:nvPr>
+        </p:nvSpPr>
+        <p:spPr/>
+        <p:txBody>
+          <a:bodyPr/>
+          <a:lstStyle/>
+          <a:p>
+            <a:r>
+              <a:rPr lang="en-US" dirty="0"/>
+              <a:t>Improvements – </a:t>
+            </a:r>
+            <a:r>
+              <a:rPr lang="en-US" dirty="0">
+                <a:solidFill>
+                  <a:srgbClr val="FF0000"/>
+                </a:solidFill>
+              </a:rPr>
+              <a:t>Sola</a:t>
+            </a:r>
+          </a:p>
+        </p:txBody>
+      </p:sp>
+      <p:sp>
+        <p:nvSpPr>
+          <p:cNvPr id="3" name="Text Placeholder 2">
+            <a:extLst>
+              <a:ext uri="{FF2B5EF4-FFF2-40B4-BE49-F238E27FC236}">
+                <a16:creationId xmlns:a16="http://schemas.microsoft.com/office/drawing/2014/main" id="{0C309034-701E-75E5-9BB2-7BA8BB756C60}"/>
+              </a:ext>
+            </a:extLst>
+          </p:cNvPr>
+          <p:cNvSpPr>
+            <a:spLocks noGrp="1"/>
+          </p:cNvSpPr>
+          <p:nvPr>
+            <p:ph type="body" idx="1"/>
+          </p:nvPr>
+        </p:nvSpPr>
+        <p:spPr>
+          <a:xfrm>
+            <a:off x="1027337" y="1366966"/>
+            <a:ext cx="10135963" cy="4348034"/>
+          </a:xfrm>
+        </p:spPr>
+        <p:txBody>
+          <a:bodyPr>
+            <a:normAutofit fontScale="92500" lnSpcReduction="10000"/>
+          </a:bodyPr>
+          <a:lstStyle/>
+          <a:p>
+            <a:r>
+              <a:rPr dirty="0"/>
+              <a:t>Balance the line to takt: 4-station layout, every station under the 42-min takt (~11 units/day at ~84% efficiency)</a:t>
+            </a:r>
+          </a:p>
+          <a:p>
+            <a:r>
+              <a:rPr dirty="0"/>
+              <a:t>Split the Seat Support / trellis assembly (#8, 33 min) the bottleneck; multiple slats make it parallelizable, so 2 builders unlock more output</a:t>
+            </a:r>
+          </a:p>
+          <a:p>
+            <a:r>
+              <a:rPr dirty="0"/>
+              <a:t>Connectors delivered correct &amp; pre-drilled (Connector Pre-Assembly + Plate + Attachment ≈ 28 min </a:t>
+            </a:r>
+            <a:r>
+              <a:t>combined) </a:t>
+            </a:r>
+            <a:r>
+              <a:rPr dirty="0"/>
+              <a:t>cut prep and drilling time</a:t>
+            </a:r>
+          </a:p>
+          <a:p>
+            <a:r>
+              <a:rPr dirty="0"/>
+              <a:t>Rivet nuts pre-installed by the supplier where possible (Rivet Nut Installation, #2)</a:t>
+            </a:r>
+          </a:p>
+          <a:p>
+            <a:r>
+              <a:rPr dirty="0"/>
+              <a:t>Point-of-use storage / kit parts per unit to cut walking and fetching</a:t>
+            </a:r>
+          </a:p>
+          <a:p>
+            <a:r>
+              <a:rPr dirty="0"/>
+              <a:t>Standardize cordless tools &amp; batteries and stage a tool set at each station</a:t>
+            </a:r>
+          </a:p>
+          <a:p>
+            <a:r>
+              <a:rPr dirty="0"/>
+              <a:t>Clearer quality standards to reduce wait time between assembly and packing approval</a:t>
+            </a:r>
+          </a:p>
+        </p:txBody>
+      </p:sp>
+    </p:spTree>
+    <p:extLst>
+      <p:ext uri="{BB962C8B-B14F-4D97-AF65-F5344CB8AC3E}">
+        <p14:creationId xmlns:p14="http://schemas.microsoft.com/office/powerpoint/2010/main" val="1215293112"/>
+      </p:ext>
+    </p:extLst>
+  </p:cSld>
+  <p:clrMapOvr>
+    <a:masterClrMapping/>
+  </p:clrMapOvr>
+  <p:transition spd="med"/>
 </p:sld>
 </file>
 

</xml_diff>

<commit_message>
Populate Swivel slides; break out packing-for-shipping labor
- Swivel Chair: 215.5 min total = 204 assembly + 11.5 packing (box/pallet +
  cushion/foam/nylon wrap), ~5% of labor; flagged as not included in
  Meritage/Sola totals (assembly-only)
- Bottleneck: Backrest & Arms Frame (Step 4) = 90 min, 42% of build; as-is
  caps output ~4-5/day, splitting is the unlock
- Improvements: split Step 4, supplier-correct connectors, eliminate
  paint-on-threads waste, POU storage/tooling, upstream pre-assembly, QC

Co-Authored-By: Claude Fable 5 <noreply@anthropic.com>
Claude-Session: https://claude.ai/code/session_019MdxDfxB8wg2Ht2aZSuwqK
</commit_message>
<xml_diff>
--- a/standard-work/standalone/Meritage_3Seater_Standard_Work.pptx
+++ b/standard-work/standalone/Meritage_3Seater_Standard_Work.pptx
@@ -4549,7 +4549,41 @@
           <a:bodyPr/>
           <a:lstStyle/>
           <a:p>
+            <a:pPr/>
+            <a:r>
+              <a:t>Swivel Chair assembly labor time: 204 min  (+ 11.5 min packing for shipping = 215.5 min total)</a:t>
+            </a:r>
             <a:endParaRPr lang="en-US"/>
+          </a:p>
+          <a:p>
+            <a:pPr/>
+            <a:r>
+              <a:t>Packing for shipping: 11.5 min (~5% of labor) — box &amp; pallet build + cushion, PE-foam and nylon wrap</a:t>
+            </a:r>
+          </a:p>
+          <a:p>
+            <a:pPr lvl="1"/>
+            <a:r>
+              <a:t>Not included in the Meritage or Sola totals (those are assembly-only) — compare to 204 min assembly for apples-to-apples</a:t>
+            </a:r>
+          </a:p>
+          <a:p>
+            <a:pPr/>
+            <a:r>
+              <a:t>Bottleneck: Backrest &amp; Arms Frame (Step 4) = 90 min — 42% of the build (~50 min is connector/bar attachment)</a:t>
+            </a:r>
+          </a:p>
+          <a:p>
+            <a:pPr lvl="1"/>
+            <a:r>
+              <a:t>As-is this 90-min step caps output at ~4–5 chairs/day; splitting it is the key unlock</a:t>
+            </a:r>
+          </a:p>
+          <a:p>
+            <a:pPr/>
+            <a:r>
+              <a:t>Takt time required (demand of 10 units): 42 min</a:t>
+            </a:r>
           </a:p>
         </p:txBody>
       </p:sp>
@@ -4651,7 +4685,41 @@
           <a:bodyPr/>
           <a:lstStyle/>
           <a:p>
+            <a:pPr/>
+            <a:r>
+              <a:t>Split the Backrest &amp; Arms Frame assembly (Step 4, 90 min — 42% of the build); ~50 min is connector/bar attachment that can likely run in parallel — the single biggest lever</a:t>
+            </a:r>
             <a:endParaRPr lang="en-US" dirty="0"/>
+          </a:p>
+          <a:p>
+            <a:pPr/>
+            <a:r>
+              <a:t>Connectors delivered correct &amp; pre-drilled (Step 1: 16 connectors are screw-swapped &amp; reoriented, ~11 min) — same supplier fix as Meritage/Sola</a:t>
+            </a:r>
+          </a:p>
+          <a:p>
+            <a:pPr/>
+            <a:r>
+              <a:t>Eliminate paint-on-threads rework (Step 6 flags drilling paint off threads as waste) — fix threading at paint so no cleanup on the line</a:t>
+            </a:r>
+          </a:p>
+          <a:p>
+            <a:pPr/>
+            <a:r>
+              <a:t>Point-of-use storage &amp; standardized tooling staged at each station</a:t>
+            </a:r>
+          </a:p>
+          <a:p>
+            <a:pPr/>
+            <a:r>
+              <a:t>Pre-assemble base / swivel-plate components upstream where possible</a:t>
+            </a:r>
+          </a:p>
+          <a:p>
+            <a:pPr/>
+            <a:r>
+              <a:t>Clearer quality standards to reduce wait time between assembly and packing</a:t>
+            </a:r>
           </a:p>
         </p:txBody>
       </p:sp>

</xml_diff>

<commit_message>
Correct swivel packing times (9.3 + 13.6 = 23 min)
- Packing for shipping now 23 min (box/pallet 9.3 + cushion/foam/nylon 13.6),
  ~10% of labor; total 227 min (204 assembly + 23 packing)
- Bottleneck Step 4 (90 min) now 40% of build

Co-Authored-By: Claude Fable 5 <noreply@anthropic.com>
Claude-Session: https://claude.ai/code/session_019MdxDfxB8wg2Ht2aZSuwqK
</commit_message>
<xml_diff>
--- a/standard-work/standalone/Meritage_3Seater_Standard_Work.pptx
+++ b/standard-work/standalone/Meritage_3Seater_Standard_Work.pptx
@@ -4551,14 +4551,14 @@
           <a:p>
             <a:pPr/>
             <a:r>
-              <a:t>Swivel Chair assembly labor time: 204 min  (+ 11.5 min packing for shipping = 215.5 min total)</a:t>
+              <a:t>Swivel Chair assembly labor time: 204 min  (+ 23 min packing for shipping = 227 min total)</a:t>
             </a:r>
             <a:endParaRPr lang="en-US"/>
           </a:p>
           <a:p>
             <a:pPr/>
             <a:r>
-              <a:t>Packing for shipping: 11.5 min (~5% of labor) — box &amp; pallet build + cushion, PE-foam and nylon wrap</a:t>
+              <a:t>Packing for shipping: 23 min (~10% of labor) — box &amp; pallet build (9.3 min) + cushion, PE-foam &amp; nylon wrap (13.6 min)</a:t>
             </a:r>
           </a:p>
           <a:p>
@@ -4570,7 +4570,7 @@
           <a:p>
             <a:pPr/>
             <a:r>
-              <a:t>Bottleneck: Backrest &amp; Arms Frame (Step 4) = 90 min — 42% of the build (~50 min is connector/bar attachment)</a:t>
+              <a:t>Bottleneck: Backrest &amp; Arms Frame (Step 4) = 90 min — 40% of the build (~50 min is connector/bar attachment)</a:t>
             </a:r>
           </a:p>
           <a:p>

</xml_diff>

<commit_message>
Add Meritage packing-for-shipping (18 min); update swivel notes
- Meritage KT: 254 assembly + 18 packing = 272 min total (~7%); broken out as
  box bottom 9 + middle 3 + top & strapping 6 (same treatment as swivel)
- Swivel KT: updated apples-to-apples note (Meritage now has packing; only
  Sola assembly-only) and added Step 4 "over 2x takt, split 2-3 operators"

Co-Authored-By: Claude Fable 5 <noreply@anthropic.com>
Claude-Session: https://claude.ai/code/session_019MdxDfxB8wg2Ht2aZSuwqK
</commit_message>
<xml_diff>
--- a/standard-work/standalone/Meritage_3Seater_Standard_Work.pptx
+++ b/standard-work/standalone/Meritage_3Seater_Standard_Work.pptx
@@ -4564,7 +4564,7 @@
           <a:p>
             <a:pPr lvl="1"/>
             <a:r>
-              <a:t>Not included in the Meritage or Sola totals (those are assembly-only) — compare to 204 min assembly for apples-to-apples</a:t>
+              <a:t>Packing is now captured for Meritage too; only the Sola total is still assembly-only</a:t>
             </a:r>
           </a:p>
           <a:p>
@@ -4576,7 +4576,7 @@
           <a:p>
             <a:pPr lvl="1"/>
             <a:r>
-              <a:t>As-is this 90-min step caps output at ~4–5 chairs/day; splitting it is the key unlock</a:t>
+              <a:t>At 90 min it is over 2x takt — must be split across at least 2 operators, 3 recommended</a:t>
             </a:r>
           </a:p>
           <a:p>
@@ -4820,28 +4820,32 @@
           <a:bodyPr/>
           <a:lstStyle/>
           <a:p>
-            <a:r>
-              <a:rPr lang="en-US" dirty="0"/>
-              <a:t>Meritage 3-seater Sofa assembly labor time: 254 min </a:t>
-            </a:r>
-          </a:p>
-          <a:p>
-            <a:r>
-              <a:rPr lang="en-US" dirty="0"/>
+            <a:pPr/>
+            <a:r>
+              <a:t>Meritage 3-Seater Sofa assembly labor time: 254 min  (+ 18 min packing for shipping = 272 min total)</a:t>
+            </a:r>
+          </a:p>
+          <a:p>
+            <a:pPr/>
+            <a:r>
+              <a:t>Packing for shipping: 18 min (~7% of labor) — box bottom (9 min) + middle section (3 min) + top section &amp; strapping (6 min)</a:t>
+            </a:r>
+          </a:p>
+          <a:p>
+            <a:pPr/>
+            <a:r>
               <a:t>Theoretical output based on cycle time (41.5 min), assuming parts are available from paint.</a:t>
             </a:r>
           </a:p>
           <a:p>
             <a:pPr lvl="1"/>
             <a:r>
-              <a:rPr lang="en-US" dirty="0"/>
               <a:t>~10 units per day (7 operators)</a:t>
             </a:r>
           </a:p>
           <a:p>
             <a:pPr lvl="1"/>
             <a:r>
-              <a:rPr lang="en-US" dirty="0"/>
               <a:t>Takt time required (demand of 10 units): 42 min</a:t>
             </a:r>
           </a:p>

</xml_diff>